<commit_message>
ppt updation around 50% completed
</commit_message>
<xml_diff>
--- a/ppt/FE Assignment template- 2.pptx
+++ b/ppt/FE Assignment template- 2.pptx
@@ -175,7 +175,7 @@
           <a:p>
             <a:fld id="{1D8BD707-D9CF-40AE-B4C6-C98DA3205C09}" type="datetimeFigureOut">
               <a:rPr lang="en-US"/>
-              <a:t>3/6/2026</a:t>
+              <a:t>3/9/2026</a:t>
             </a:fld>
             <a:endParaRPr lang="en-US"/>
           </a:p>
@@ -340,7 +340,7 @@
           <a:p>
             <a:fld id="{1D8BD707-D9CF-40AE-B4C6-C98DA3205C09}" type="datetimeFigureOut">
               <a:rPr lang="en-US"/>
-              <a:t>3/6/2026</a:t>
+              <a:t>3/9/2026</a:t>
             </a:fld>
             <a:endParaRPr lang="en-US"/>
           </a:p>
@@ -548,7 +548,7 @@
           <a:p>
             <a:fld id="{1D8BD707-D9CF-40AE-B4C6-C98DA3205C09}" type="datetimeFigureOut">
               <a:rPr lang="en-US"/>
-              <a:t>3/6/2026</a:t>
+              <a:t>3/9/2026</a:t>
             </a:fld>
             <a:endParaRPr lang="en-US"/>
           </a:p>
@@ -690,7 +690,7 @@
           <a:p>
             <a:fld id="{1D8BD707-D9CF-40AE-B4C6-C98DA3205C09}" type="datetimeFigureOut">
               <a:rPr lang="en-US"/>
-              <a:t>3/6/2026</a:t>
+              <a:t>3/9/2026</a:t>
             </a:fld>
             <a:endParaRPr lang="en-US"/>
           </a:p>
@@ -809,7 +809,7 @@
           <a:p>
             <a:fld id="{1D8BD707-D9CF-40AE-B4C6-C98DA3205C09}" type="datetimeFigureOut">
               <a:rPr lang="en-US"/>
-              <a:t>3/6/2026</a:t>
+              <a:t>3/9/2026</a:t>
             </a:fld>
             <a:endParaRPr lang="en-US"/>
           </a:p>
@@ -1022,7 +1022,7 @@
           <a:p>
             <a:fld id="{1D8BD707-D9CF-40AE-B4C6-C98DA3205C09}" type="datetimeFigureOut">
               <a:rPr lang="en-US"/>
-              <a:t>3/6/2026</a:t>
+              <a:t>3/9/2026</a:t>
             </a:fld>
             <a:endParaRPr lang="en-US"/>
           </a:p>
@@ -1595,7 +1595,7 @@
         <p:spPr>
           <a:xfrm>
             <a:off x="761796" y="1150365"/>
-            <a:ext cx="6435090" cy="4705775"/>
+            <a:ext cx="6435090" cy="5064848"/>
           </a:xfrm>
           <a:prstGeom prst="rect">
             <a:avLst/>
@@ -1967,21 +1967,21 @@
               </a:spcBef>
             </a:pPr>
             <a:r>
-              <a:rPr sz="1200" b="1" spc="-10">
+              <a:rPr sz="1200" b="1" spc="-10" dirty="0">
                 <a:latin typeface="Times New Roman"/>
                 <a:cs typeface="Times New Roman"/>
               </a:rPr>
               <a:t>NMID:</a:t>
             </a:r>
             <a:r>
-              <a:rPr lang="en-US" sz="1200" b="1" spc="-10">
-                <a:latin typeface="Times New Roman"/>
-                <a:cs typeface="Times New Roman"/>
-              </a:rPr>
-              <a:t> </a:t>
-            </a:r>
-            <a:r>
-              <a:rPr lang="en-IN" sz="1200" b="1" spc="-10">
+              <a:rPr lang="en-US" sz="1200" b="1" spc="-10" dirty="0">
+                <a:latin typeface="Times New Roman"/>
+                <a:cs typeface="Times New Roman"/>
+              </a:rPr>
+              <a:t> </a:t>
+            </a:r>
+            <a:r>
+              <a:rPr lang="en-IN" sz="1200" b="1" spc="-10" dirty="0">
                 <a:latin typeface="Times New Roman"/>
                 <a:cs typeface="Times New Roman"/>
               </a:rPr>
@@ -2076,7 +2076,7 @@
               </a:lnSpc>
             </a:pPr>
             <a:r>
-              <a:rPr sz="1400" b="1" dirty="0">
+              <a:rPr sz="1500" b="1" dirty="0">
                 <a:solidFill>
                   <a:srgbClr val="3B78D7"/>
                 </a:solidFill>
@@ -2086,7 +2086,7 @@
               <a:t>1.</a:t>
             </a:r>
             <a:r>
-              <a:rPr sz="1400" b="1" spc="-25" dirty="0">
+              <a:rPr sz="1500" b="1" spc="-25" dirty="0">
                 <a:solidFill>
                   <a:srgbClr val="3B78D7"/>
                 </a:solidFill>
@@ -2096,7 +2096,7 @@
               <a:t> </a:t>
             </a:r>
             <a:r>
-              <a:rPr sz="1400" b="1" dirty="0">
+              <a:rPr sz="1500" b="1" dirty="0">
                 <a:solidFill>
                   <a:srgbClr val="3B78D7"/>
                 </a:solidFill>
@@ -2106,7 +2106,7 @@
               <a:t>Problem</a:t>
             </a:r>
             <a:r>
-              <a:rPr sz="1400" b="1" spc="-20" dirty="0">
+              <a:rPr sz="1500" b="1" spc="-20" dirty="0">
                 <a:solidFill>
                   <a:srgbClr val="3B78D7"/>
                 </a:solidFill>
@@ -2116,7 +2116,7 @@
               <a:t> </a:t>
             </a:r>
             <a:r>
-              <a:rPr sz="1400" b="1" spc="-10" dirty="0">
+              <a:rPr sz="1500" b="1" spc="-10" dirty="0">
                 <a:solidFill>
                   <a:srgbClr val="3B78D7"/>
                 </a:solidFill>
@@ -2125,7 +2125,10 @@
               </a:rPr>
               <a:t>Statement:</a:t>
             </a:r>
-            <a:endParaRPr sz="1400" dirty="0">
+            <a:endParaRPr lang="en-US" sz="1500" b="1" spc="-10" dirty="0">
+              <a:solidFill>
+                <a:srgbClr val="3B78D7"/>
+              </a:solidFill>
               <a:latin typeface="Times New Roman"/>
               <a:cs typeface="Times New Roman"/>
             </a:endParaRPr>
@@ -2140,352 +2143,12 @@
               </a:spcBef>
             </a:pPr>
             <a:r>
-              <a:rPr sz="1200" i="1" dirty="0">
-                <a:latin typeface="Times New Roman"/>
-                <a:cs typeface="Times New Roman"/>
-              </a:rPr>
-              <a:t>(This</a:t>
-            </a:r>
-            <a:r>
-              <a:rPr sz="1200" i="1" spc="-30" dirty="0">
-                <a:latin typeface="Times New Roman"/>
-                <a:cs typeface="Times New Roman"/>
-              </a:rPr>
-              <a:t> </a:t>
-            </a:r>
-            <a:r>
-              <a:rPr sz="1200" i="1" dirty="0">
-                <a:latin typeface="Times New Roman"/>
-                <a:cs typeface="Times New Roman"/>
-              </a:rPr>
-              <a:t>section</a:t>
-            </a:r>
-            <a:r>
-              <a:rPr sz="1200" i="1" spc="-25" dirty="0">
-                <a:latin typeface="Times New Roman"/>
-                <a:cs typeface="Times New Roman"/>
-              </a:rPr>
-              <a:t> </a:t>
-            </a:r>
-            <a:r>
-              <a:rPr sz="1200" i="1" dirty="0">
-                <a:latin typeface="Times New Roman"/>
-                <a:cs typeface="Times New Roman"/>
-              </a:rPr>
-              <a:t>explains</a:t>
-            </a:r>
-            <a:r>
-              <a:rPr sz="1200" i="1" spc="-30" dirty="0">
-                <a:latin typeface="Times New Roman"/>
-                <a:cs typeface="Times New Roman"/>
-              </a:rPr>
-              <a:t> </a:t>
-            </a:r>
-            <a:r>
-              <a:rPr sz="1200" i="1" dirty="0">
-                <a:latin typeface="Times New Roman"/>
-                <a:cs typeface="Times New Roman"/>
-              </a:rPr>
-              <a:t>the</a:t>
-            </a:r>
-            <a:r>
-              <a:rPr sz="1200" i="1" spc="-30" dirty="0">
-                <a:latin typeface="Times New Roman"/>
-                <a:cs typeface="Times New Roman"/>
-              </a:rPr>
-              <a:t> </a:t>
-            </a:r>
-            <a:r>
-              <a:rPr sz="1200" i="1" dirty="0">
-                <a:latin typeface="Times New Roman"/>
-                <a:cs typeface="Times New Roman"/>
-              </a:rPr>
-              <a:t>need</a:t>
-            </a:r>
-            <a:r>
-              <a:rPr sz="1200" i="1" spc="-25" dirty="0">
-                <a:latin typeface="Times New Roman"/>
-                <a:cs typeface="Times New Roman"/>
-              </a:rPr>
-              <a:t> </a:t>
-            </a:r>
-            <a:r>
-              <a:rPr sz="1200" i="1" dirty="0">
-                <a:latin typeface="Times New Roman"/>
-                <a:cs typeface="Times New Roman"/>
-              </a:rPr>
-              <a:t>to</a:t>
-            </a:r>
-            <a:r>
-              <a:rPr sz="1200" i="1" spc="-20" dirty="0">
-                <a:latin typeface="Times New Roman"/>
-                <a:cs typeface="Times New Roman"/>
-              </a:rPr>
-              <a:t> </a:t>
-            </a:r>
-            <a:r>
-              <a:rPr sz="1200" i="1" dirty="0">
-                <a:latin typeface="Times New Roman"/>
-                <a:cs typeface="Times New Roman"/>
-              </a:rPr>
-              <a:t>improve</a:t>
-            </a:r>
-            <a:r>
-              <a:rPr sz="1200" i="1" spc="-30" dirty="0">
-                <a:latin typeface="Times New Roman"/>
-                <a:cs typeface="Times New Roman"/>
-              </a:rPr>
-              <a:t> </a:t>
-            </a:r>
-            <a:r>
-              <a:rPr sz="1200" i="1" dirty="0">
-                <a:latin typeface="Times New Roman"/>
-                <a:cs typeface="Times New Roman"/>
-              </a:rPr>
-              <a:t>the</a:t>
-            </a:r>
-            <a:r>
-              <a:rPr sz="1200" i="1" spc="-20" dirty="0">
-                <a:latin typeface="Times New Roman"/>
-                <a:cs typeface="Times New Roman"/>
-              </a:rPr>
-              <a:t> </a:t>
-            </a:r>
-            <a:r>
-              <a:rPr sz="1200" i="1" dirty="0">
-                <a:latin typeface="Times New Roman"/>
-                <a:cs typeface="Times New Roman"/>
-              </a:rPr>
-              <a:t>visual</a:t>
-            </a:r>
-            <a:r>
-              <a:rPr sz="1200" i="1" spc="-25" dirty="0">
-                <a:latin typeface="Times New Roman"/>
-                <a:cs typeface="Times New Roman"/>
-              </a:rPr>
-              <a:t> </a:t>
-            </a:r>
-            <a:r>
-              <a:rPr sz="1200" i="1" dirty="0">
-                <a:latin typeface="Times New Roman"/>
-                <a:cs typeface="Times New Roman"/>
-              </a:rPr>
-              <a:t>appearance</a:t>
-            </a:r>
-            <a:r>
-              <a:rPr sz="1200" i="1" spc="-30" dirty="0">
-                <a:latin typeface="Times New Roman"/>
-                <a:cs typeface="Times New Roman"/>
-              </a:rPr>
-              <a:t> </a:t>
-            </a:r>
-            <a:r>
-              <a:rPr sz="1200" i="1" dirty="0">
-                <a:latin typeface="Times New Roman"/>
-                <a:cs typeface="Times New Roman"/>
-              </a:rPr>
-              <a:t>of</a:t>
-            </a:r>
-            <a:r>
-              <a:rPr sz="1200" i="1" spc="-25" dirty="0">
-                <a:latin typeface="Times New Roman"/>
-                <a:cs typeface="Times New Roman"/>
-              </a:rPr>
-              <a:t> </a:t>
-            </a:r>
-            <a:r>
-              <a:rPr sz="1200" i="1" dirty="0">
-                <a:latin typeface="Times New Roman"/>
-                <a:cs typeface="Times New Roman"/>
-              </a:rPr>
-              <a:t>the</a:t>
-            </a:r>
-            <a:r>
-              <a:rPr sz="1200" i="1" spc="-25" dirty="0">
-                <a:latin typeface="Times New Roman"/>
-                <a:cs typeface="Times New Roman"/>
-              </a:rPr>
-              <a:t> </a:t>
-            </a:r>
-            <a:r>
-              <a:rPr sz="1200" i="1" dirty="0">
-                <a:latin typeface="Times New Roman"/>
-                <a:cs typeface="Times New Roman"/>
-              </a:rPr>
-              <a:t>event</a:t>
-            </a:r>
-            <a:r>
-              <a:rPr sz="1200" i="1" spc="-25" dirty="0">
-                <a:latin typeface="Times New Roman"/>
-                <a:cs typeface="Times New Roman"/>
-              </a:rPr>
-              <a:t> </a:t>
-            </a:r>
-            <a:r>
-              <a:rPr sz="1200" i="1" dirty="0">
-                <a:latin typeface="Times New Roman"/>
-                <a:cs typeface="Times New Roman"/>
-              </a:rPr>
-              <a:t>registration</a:t>
-            </a:r>
-            <a:r>
-              <a:rPr sz="1200" i="1" spc="-25" dirty="0">
-                <a:latin typeface="Times New Roman"/>
-                <a:cs typeface="Times New Roman"/>
-              </a:rPr>
-              <a:t> </a:t>
-            </a:r>
-            <a:r>
-              <a:rPr sz="1200" i="1" dirty="0">
-                <a:latin typeface="Times New Roman"/>
-                <a:cs typeface="Times New Roman"/>
-              </a:rPr>
-              <a:t>page</a:t>
-            </a:r>
-            <a:r>
-              <a:rPr sz="1200" i="1" spc="-30" dirty="0">
-                <a:latin typeface="Times New Roman"/>
-                <a:cs typeface="Times New Roman"/>
-              </a:rPr>
-              <a:t> </a:t>
-            </a:r>
-            <a:r>
-              <a:rPr sz="1200" i="1" spc="-10" dirty="0">
-                <a:latin typeface="Times New Roman"/>
-                <a:cs typeface="Times New Roman"/>
-              </a:rPr>
-              <a:t>created </a:t>
-            </a:r>
-            <a:r>
-              <a:rPr sz="1200" i="1" dirty="0">
-                <a:latin typeface="Times New Roman"/>
-                <a:cs typeface="Times New Roman"/>
-              </a:rPr>
-              <a:t>in</a:t>
-            </a:r>
-            <a:r>
-              <a:rPr sz="1200" i="1" spc="-10" dirty="0">
-                <a:latin typeface="Times New Roman"/>
-                <a:cs typeface="Times New Roman"/>
-              </a:rPr>
-              <a:t> Assignment-</a:t>
-            </a:r>
-            <a:r>
-              <a:rPr sz="1200" i="1" dirty="0">
-                <a:latin typeface="Times New Roman"/>
-                <a:cs typeface="Times New Roman"/>
-              </a:rPr>
-              <a:t>1</a:t>
-            </a:r>
-            <a:r>
-              <a:rPr sz="1200" i="1" spc="-5" dirty="0">
-                <a:latin typeface="Times New Roman"/>
-                <a:cs typeface="Times New Roman"/>
-              </a:rPr>
-              <a:t> </a:t>
-            </a:r>
-            <a:r>
-              <a:rPr sz="1200" i="1" dirty="0">
-                <a:latin typeface="Times New Roman"/>
-                <a:cs typeface="Times New Roman"/>
-              </a:rPr>
-              <a:t>using</a:t>
-            </a:r>
-            <a:r>
-              <a:rPr sz="1200" i="1" spc="-5" dirty="0">
-                <a:latin typeface="Times New Roman"/>
-                <a:cs typeface="Times New Roman"/>
-              </a:rPr>
-              <a:t> </a:t>
-            </a:r>
-            <a:r>
-              <a:rPr sz="1200" i="1" dirty="0">
-                <a:latin typeface="Times New Roman"/>
-                <a:cs typeface="Times New Roman"/>
-              </a:rPr>
-              <a:t>CSS</a:t>
-            </a:r>
-            <a:r>
-              <a:rPr sz="1200" i="1" spc="-10" dirty="0">
-                <a:latin typeface="Times New Roman"/>
-                <a:cs typeface="Times New Roman"/>
-              </a:rPr>
-              <a:t> </a:t>
-            </a:r>
-            <a:r>
-              <a:rPr sz="1200" i="1" dirty="0">
-                <a:latin typeface="Times New Roman"/>
-                <a:cs typeface="Times New Roman"/>
-              </a:rPr>
-              <a:t>for</a:t>
-            </a:r>
-            <a:r>
-              <a:rPr sz="1200" i="1" spc="-5" dirty="0">
-                <a:latin typeface="Times New Roman"/>
-                <a:cs typeface="Times New Roman"/>
-              </a:rPr>
-              <a:t> </a:t>
-            </a:r>
-            <a:r>
-              <a:rPr sz="1200" i="1" dirty="0">
-                <a:latin typeface="Times New Roman"/>
-                <a:cs typeface="Times New Roman"/>
-              </a:rPr>
-              <a:t>better</a:t>
-            </a:r>
-            <a:r>
-              <a:rPr sz="1200" i="1" spc="-10" dirty="0">
-                <a:latin typeface="Times New Roman"/>
-                <a:cs typeface="Times New Roman"/>
-              </a:rPr>
-              <a:t> </a:t>
-            </a:r>
-            <a:r>
-              <a:rPr sz="1200" i="1" dirty="0">
-                <a:latin typeface="Times New Roman"/>
-                <a:cs typeface="Times New Roman"/>
-              </a:rPr>
-              <a:t>layout</a:t>
-            </a:r>
-            <a:r>
-              <a:rPr sz="1200" i="1" spc="-5" dirty="0">
-                <a:latin typeface="Times New Roman"/>
-                <a:cs typeface="Times New Roman"/>
-              </a:rPr>
-              <a:t> </a:t>
-            </a:r>
-            <a:r>
-              <a:rPr sz="1200" i="1" dirty="0">
-                <a:latin typeface="Times New Roman"/>
-                <a:cs typeface="Times New Roman"/>
-              </a:rPr>
-              <a:t>and</a:t>
-            </a:r>
-            <a:r>
-              <a:rPr sz="1200" i="1" spc="-10" dirty="0">
-                <a:latin typeface="Times New Roman"/>
-                <a:cs typeface="Times New Roman"/>
-              </a:rPr>
-              <a:t> </a:t>
-            </a:r>
-            <a:r>
-              <a:rPr sz="1200" i="1" dirty="0">
-                <a:latin typeface="Times New Roman"/>
-                <a:cs typeface="Times New Roman"/>
-              </a:rPr>
-              <a:t>user</a:t>
-            </a:r>
-            <a:r>
-              <a:rPr sz="1200" i="1" spc="-10" dirty="0">
-                <a:latin typeface="Times New Roman"/>
-                <a:cs typeface="Times New Roman"/>
-              </a:rPr>
-              <a:t> experience.)</a:t>
-            </a:r>
-            <a:endParaRPr sz="1200" dirty="0">
-              <a:latin typeface="Times New Roman"/>
-              <a:cs typeface="Times New Roman"/>
-            </a:endParaRPr>
+              <a:rPr lang="en-US" sz="1300" dirty="0">
+                <a:latin typeface="Times New Roman"/>
+                <a:cs typeface="Times New Roman"/>
+              </a:rPr>
+              <a:t>The goal is to improve the simple registration page I built in Assignment-1. While the structure was there, it didn't look like a real website. This update uses CSS to fix the layout, add professional spacing, and make it easier for students to read the event details and fill out the form without it feeling cluttered.</a:t>
+            </a:r>
           </a:p>
         </p:txBody>
       </p:sp>
@@ -2497,7 +2160,7 @@
         </p:nvGrpSpPr>
         <p:grpSpPr>
           <a:xfrm>
-            <a:off x="808990" y="6028689"/>
+            <a:off x="808913" y="6246685"/>
             <a:ext cx="6395085" cy="20955"/>
             <a:chOff x="808990" y="6028689"/>
             <a:chExt cx="6395085" cy="20955"/>
@@ -2842,8 +2505,8 @@
         </p:nvSpPr>
         <p:spPr>
           <a:xfrm>
-            <a:off x="796848" y="6265544"/>
-            <a:ext cx="6289040" cy="716280"/>
+            <a:off x="806980" y="6346567"/>
+            <a:ext cx="6289040" cy="911147"/>
           </a:xfrm>
           <a:prstGeom prst="rect">
             <a:avLst/>
@@ -2864,7 +2527,7 @@
               </a:spcBef>
             </a:pPr>
             <a:r>
-              <a:rPr sz="1400" b="1" dirty="0">
+              <a:rPr sz="1500" b="1" dirty="0">
                 <a:solidFill>
                   <a:srgbClr val="3B78D7"/>
                 </a:solidFill>
@@ -2874,7 +2537,7 @@
               <a:t>2.</a:t>
             </a:r>
             <a:r>
-              <a:rPr sz="1400" b="1" spc="-5" dirty="0">
+              <a:rPr sz="1500" b="1" spc="-5" dirty="0">
                 <a:solidFill>
                   <a:srgbClr val="3B78D7"/>
                 </a:solidFill>
@@ -2884,7 +2547,7 @@
               <a:t> </a:t>
             </a:r>
             <a:r>
-              <a:rPr sz="1400" b="1" spc="-10" dirty="0">
+              <a:rPr sz="1500" b="1" spc="-10" dirty="0">
                 <a:solidFill>
                   <a:srgbClr val="3B78D7"/>
                 </a:solidFill>
@@ -2893,7 +2556,7 @@
               </a:rPr>
               <a:t>Objective:</a:t>
             </a:r>
-            <a:endParaRPr sz="1400">
+            <a:endParaRPr sz="1500" dirty="0">
               <a:latin typeface="Times New Roman"/>
               <a:cs typeface="Times New Roman"/>
             </a:endParaRPr>
@@ -2908,366 +2571,19 @@
               </a:spcBef>
             </a:pPr>
             <a:r>
-              <a:rPr sz="1200" i="1" dirty="0">
-                <a:latin typeface="Times New Roman"/>
-                <a:cs typeface="Times New Roman"/>
-              </a:rPr>
-              <a:t>(This</a:t>
-            </a:r>
-            <a:r>
-              <a:rPr sz="1200" i="1" spc="-25" dirty="0">
-                <a:latin typeface="Times New Roman"/>
-                <a:cs typeface="Times New Roman"/>
-              </a:rPr>
-              <a:t> </a:t>
-            </a:r>
-            <a:r>
-              <a:rPr sz="1200" i="1" dirty="0">
-                <a:latin typeface="Times New Roman"/>
-                <a:cs typeface="Times New Roman"/>
-              </a:rPr>
-              <a:t>section</a:t>
-            </a:r>
-            <a:r>
-              <a:rPr sz="1200" i="1" spc="-20" dirty="0">
-                <a:latin typeface="Times New Roman"/>
-                <a:cs typeface="Times New Roman"/>
-              </a:rPr>
-              <a:t> </a:t>
-            </a:r>
-            <a:r>
-              <a:rPr sz="1200" i="1" dirty="0">
-                <a:latin typeface="Times New Roman"/>
-                <a:cs typeface="Times New Roman"/>
-              </a:rPr>
-              <a:t>describes</a:t>
-            </a:r>
-            <a:r>
-              <a:rPr sz="1200" i="1" spc="-25" dirty="0">
-                <a:latin typeface="Times New Roman"/>
-                <a:cs typeface="Times New Roman"/>
-              </a:rPr>
-              <a:t> </a:t>
-            </a:r>
-            <a:r>
-              <a:rPr sz="1200" i="1" dirty="0">
-                <a:latin typeface="Times New Roman"/>
-                <a:cs typeface="Times New Roman"/>
-              </a:rPr>
-              <a:t>the</a:t>
-            </a:r>
-            <a:r>
-              <a:rPr sz="1200" i="1" spc="-25" dirty="0">
-                <a:latin typeface="Times New Roman"/>
-                <a:cs typeface="Times New Roman"/>
-              </a:rPr>
-              <a:t> </a:t>
-            </a:r>
-            <a:r>
-              <a:rPr sz="1200" i="1" dirty="0">
-                <a:latin typeface="Times New Roman"/>
-                <a:cs typeface="Times New Roman"/>
-              </a:rPr>
-              <a:t>goal</a:t>
-            </a:r>
-            <a:r>
-              <a:rPr sz="1200" i="1" spc="-20" dirty="0">
-                <a:latin typeface="Times New Roman"/>
-                <a:cs typeface="Times New Roman"/>
-              </a:rPr>
-              <a:t> </a:t>
-            </a:r>
-            <a:r>
-              <a:rPr sz="1200" i="1" dirty="0">
-                <a:latin typeface="Times New Roman"/>
-                <a:cs typeface="Times New Roman"/>
-              </a:rPr>
-              <a:t>of</a:t>
-            </a:r>
-            <a:r>
-              <a:rPr sz="1200" i="1" spc="-20" dirty="0">
-                <a:latin typeface="Times New Roman"/>
-                <a:cs typeface="Times New Roman"/>
-              </a:rPr>
-              <a:t> </a:t>
-            </a:r>
-            <a:r>
-              <a:rPr sz="1200" i="1" dirty="0">
-                <a:latin typeface="Times New Roman"/>
-                <a:cs typeface="Times New Roman"/>
-              </a:rPr>
-              <a:t>the</a:t>
-            </a:r>
-            <a:r>
-              <a:rPr sz="1200" i="1" spc="-25" dirty="0">
-                <a:latin typeface="Times New Roman"/>
-                <a:cs typeface="Times New Roman"/>
-              </a:rPr>
-              <a:t> </a:t>
-            </a:r>
-            <a:r>
-              <a:rPr sz="1200" i="1" dirty="0">
-                <a:latin typeface="Times New Roman"/>
-                <a:cs typeface="Times New Roman"/>
-              </a:rPr>
-              <a:t>assignment,</a:t>
-            </a:r>
-            <a:r>
-              <a:rPr sz="1200" i="1" spc="-20" dirty="0">
-                <a:latin typeface="Times New Roman"/>
-                <a:cs typeface="Times New Roman"/>
-              </a:rPr>
-              <a:t> </a:t>
-            </a:r>
-            <a:r>
-              <a:rPr sz="1200" i="1" dirty="0">
-                <a:latin typeface="Times New Roman"/>
-                <a:cs typeface="Times New Roman"/>
-              </a:rPr>
-              <a:t>which</a:t>
-            </a:r>
-            <a:r>
-              <a:rPr sz="1200" i="1" spc="-20" dirty="0">
-                <a:latin typeface="Times New Roman"/>
-                <a:cs typeface="Times New Roman"/>
-              </a:rPr>
-              <a:t> </a:t>
-            </a:r>
-            <a:r>
-              <a:rPr sz="1200" i="1" dirty="0">
-                <a:latin typeface="Times New Roman"/>
-                <a:cs typeface="Times New Roman"/>
-              </a:rPr>
-              <a:t>is</a:t>
-            </a:r>
-            <a:r>
-              <a:rPr sz="1200" i="1" spc="-25" dirty="0">
-                <a:latin typeface="Times New Roman"/>
-                <a:cs typeface="Times New Roman"/>
-              </a:rPr>
-              <a:t> </a:t>
-            </a:r>
-            <a:r>
-              <a:rPr sz="1200" i="1" dirty="0">
-                <a:latin typeface="Times New Roman"/>
-                <a:cs typeface="Times New Roman"/>
-              </a:rPr>
-              <a:t>to</a:t>
-            </a:r>
-            <a:r>
-              <a:rPr sz="1200" i="1" spc="-20" dirty="0">
-                <a:latin typeface="Times New Roman"/>
-                <a:cs typeface="Times New Roman"/>
-              </a:rPr>
-              <a:t> </a:t>
-            </a:r>
-            <a:r>
-              <a:rPr sz="1200" i="1" dirty="0">
-                <a:latin typeface="Times New Roman"/>
-                <a:cs typeface="Times New Roman"/>
-              </a:rPr>
-              <a:t>apply</a:t>
-            </a:r>
-            <a:r>
-              <a:rPr sz="1200" i="1" spc="-20" dirty="0">
-                <a:latin typeface="Times New Roman"/>
-                <a:cs typeface="Times New Roman"/>
-              </a:rPr>
-              <a:t> </a:t>
-            </a:r>
-            <a:r>
-              <a:rPr sz="1200" i="1" dirty="0">
-                <a:latin typeface="Times New Roman"/>
-                <a:cs typeface="Times New Roman"/>
-              </a:rPr>
-              <a:t>CSS</a:t>
-            </a:r>
-            <a:r>
-              <a:rPr sz="1200" i="1" spc="-20" dirty="0">
-                <a:latin typeface="Times New Roman"/>
-                <a:cs typeface="Times New Roman"/>
-              </a:rPr>
-              <a:t> </a:t>
-            </a:r>
-            <a:r>
-              <a:rPr sz="1200" i="1" dirty="0">
-                <a:latin typeface="Times New Roman"/>
-                <a:cs typeface="Times New Roman"/>
-              </a:rPr>
-              <a:t>styling</a:t>
-            </a:r>
-            <a:r>
-              <a:rPr sz="1200" i="1" spc="-20" dirty="0">
-                <a:latin typeface="Times New Roman"/>
-                <a:cs typeface="Times New Roman"/>
-              </a:rPr>
-              <a:t> </a:t>
-            </a:r>
-            <a:r>
-              <a:rPr sz="1200" i="1" dirty="0">
-                <a:latin typeface="Times New Roman"/>
-                <a:cs typeface="Times New Roman"/>
-              </a:rPr>
-              <a:t>to</a:t>
-            </a:r>
-            <a:r>
-              <a:rPr sz="1200" i="1" spc="-20" dirty="0">
-                <a:latin typeface="Times New Roman"/>
-                <a:cs typeface="Times New Roman"/>
-              </a:rPr>
-              <a:t> </a:t>
-            </a:r>
-            <a:r>
-              <a:rPr sz="1200" i="1" dirty="0">
-                <a:latin typeface="Times New Roman"/>
-                <a:cs typeface="Times New Roman"/>
-              </a:rPr>
-              <a:t>transform</a:t>
-            </a:r>
-            <a:r>
-              <a:rPr sz="1200" i="1" spc="-25" dirty="0">
-                <a:latin typeface="Times New Roman"/>
-                <a:cs typeface="Times New Roman"/>
-              </a:rPr>
-              <a:t> </a:t>
-            </a:r>
-            <a:r>
-              <a:rPr sz="1200" i="1" dirty="0">
-                <a:latin typeface="Times New Roman"/>
-                <a:cs typeface="Times New Roman"/>
-              </a:rPr>
-              <a:t>the</a:t>
-            </a:r>
-            <a:r>
-              <a:rPr sz="1200" i="1" spc="-25" dirty="0">
-                <a:latin typeface="Times New Roman"/>
-                <a:cs typeface="Times New Roman"/>
-              </a:rPr>
-              <a:t> </a:t>
-            </a:r>
-            <a:r>
-              <a:rPr sz="1200" i="1" spc="-10" dirty="0">
-                <a:latin typeface="Times New Roman"/>
-                <a:cs typeface="Times New Roman"/>
-              </a:rPr>
-              <a:t>basic </a:t>
-            </a:r>
-            <a:r>
-              <a:rPr sz="1200" i="1" dirty="0">
-                <a:latin typeface="Times New Roman"/>
-                <a:cs typeface="Times New Roman"/>
-              </a:rPr>
-              <a:t>HTML</a:t>
-            </a:r>
-            <a:r>
-              <a:rPr sz="1200" i="1" spc="-10" dirty="0">
-                <a:latin typeface="Times New Roman"/>
-                <a:cs typeface="Times New Roman"/>
-              </a:rPr>
-              <a:t> </a:t>
-            </a:r>
-            <a:r>
-              <a:rPr sz="1200" i="1" dirty="0">
-                <a:latin typeface="Times New Roman"/>
-                <a:cs typeface="Times New Roman"/>
-              </a:rPr>
-              <a:t>page</a:t>
-            </a:r>
-            <a:r>
-              <a:rPr sz="1200" i="1" spc="-10" dirty="0">
-                <a:latin typeface="Times New Roman"/>
-                <a:cs typeface="Times New Roman"/>
-              </a:rPr>
-              <a:t> </a:t>
-            </a:r>
-            <a:r>
-              <a:rPr sz="1200" i="1" dirty="0">
-                <a:latin typeface="Times New Roman"/>
-                <a:cs typeface="Times New Roman"/>
-              </a:rPr>
-              <a:t>into</a:t>
-            </a:r>
-            <a:r>
-              <a:rPr sz="1200" i="1" spc="-5" dirty="0">
-                <a:latin typeface="Times New Roman"/>
-                <a:cs typeface="Times New Roman"/>
-              </a:rPr>
-              <a:t> </a:t>
-            </a:r>
-            <a:r>
-              <a:rPr sz="1200" i="1" dirty="0">
-                <a:latin typeface="Times New Roman"/>
-                <a:cs typeface="Times New Roman"/>
-              </a:rPr>
-              <a:t>a</a:t>
-            </a:r>
-            <a:r>
-              <a:rPr sz="1200" i="1" spc="-5" dirty="0">
-                <a:latin typeface="Times New Roman"/>
-                <a:cs typeface="Times New Roman"/>
-              </a:rPr>
-              <a:t> </a:t>
-            </a:r>
-            <a:r>
-              <a:rPr sz="1200" i="1" dirty="0">
-                <a:latin typeface="Times New Roman"/>
-                <a:cs typeface="Times New Roman"/>
-              </a:rPr>
-              <a:t>clean</a:t>
-            </a:r>
-            <a:r>
-              <a:rPr sz="1200" i="1" spc="-5" dirty="0">
-                <a:latin typeface="Times New Roman"/>
-                <a:cs typeface="Times New Roman"/>
-              </a:rPr>
-              <a:t> </a:t>
-            </a:r>
-            <a:r>
-              <a:rPr sz="1200" i="1" dirty="0">
-                <a:latin typeface="Times New Roman"/>
-                <a:cs typeface="Times New Roman"/>
-              </a:rPr>
-              <a:t>and</a:t>
-            </a:r>
-            <a:r>
-              <a:rPr sz="1200" i="1" spc="-5" dirty="0">
-                <a:latin typeface="Times New Roman"/>
-                <a:cs typeface="Times New Roman"/>
-              </a:rPr>
-              <a:t> </a:t>
-            </a:r>
-            <a:r>
-              <a:rPr sz="1200" i="1" spc="-10" dirty="0">
-                <a:latin typeface="Times New Roman"/>
-                <a:cs typeface="Times New Roman"/>
-              </a:rPr>
-              <a:t>professional-</a:t>
-            </a:r>
-            <a:r>
-              <a:rPr sz="1200" i="1" dirty="0">
-                <a:latin typeface="Times New Roman"/>
-                <a:cs typeface="Times New Roman"/>
-              </a:rPr>
-              <a:t>looking</a:t>
-            </a:r>
-            <a:r>
-              <a:rPr sz="1200" i="1" spc="-5" dirty="0">
-                <a:latin typeface="Times New Roman"/>
-                <a:cs typeface="Times New Roman"/>
-              </a:rPr>
-              <a:t> </a:t>
-            </a:r>
-            <a:r>
-              <a:rPr sz="1200" i="1" spc="-10" dirty="0">
-                <a:latin typeface="Times New Roman"/>
-                <a:cs typeface="Times New Roman"/>
-              </a:rPr>
-              <a:t>interface.)</a:t>
-            </a:r>
-            <a:endParaRPr sz="1200">
-              <a:latin typeface="Times New Roman"/>
-              <a:cs typeface="Times New Roman"/>
-            </a:endParaRPr>
+              <a:rPr sz="1300" dirty="0">
+                <a:latin typeface="Times New Roman"/>
+                <a:cs typeface="Times New Roman"/>
+              </a:rPr>
+              <a:t>(</a:t>
+            </a:r>
+            <a:r>
+              <a:rPr lang="en-US" sz="1300" dirty="0">
+                <a:latin typeface="Times New Roman"/>
+                <a:cs typeface="Times New Roman"/>
+              </a:rPr>
+              <a:t>My main objective is to move from "plain HTML" to a "Styled UI." I want to learn how to use the CSS Box Model (padding, margins, borders) to control where things sit on the page and use colors to make the form look like a modern card-style interface.</a:t>
+            </a:r>
           </a:p>
         </p:txBody>
       </p:sp>
@@ -3279,7 +2595,7 @@
         </p:nvGrpSpPr>
         <p:grpSpPr>
           <a:xfrm>
-            <a:off x="801369" y="7414259"/>
+            <a:off x="801370" y="7328646"/>
             <a:ext cx="6402705" cy="20955"/>
             <a:chOff x="801369" y="7414259"/>
             <a:chExt cx="6402705" cy="20955"/>
@@ -3624,8 +2940,8 @@
         </p:nvSpPr>
         <p:spPr>
           <a:xfrm>
-            <a:off x="792276" y="7486810"/>
-            <a:ext cx="6338570" cy="1393825"/>
+            <a:off x="792275" y="7366445"/>
+            <a:ext cx="6494349" cy="2419252"/>
           </a:xfrm>
           <a:prstGeom prst="rect">
             <a:avLst/>
@@ -3651,7 +2967,7 @@
               </a:tabLst>
             </a:pPr>
             <a:r>
-              <a:rPr sz="1400" b="1" spc="-10" dirty="0">
+              <a:rPr sz="1500" b="1" spc="-10" dirty="0">
                 <a:solidFill>
                   <a:srgbClr val="3B78D7"/>
                 </a:solidFill>
@@ -3660,10 +2976,114 @@
               </a:rPr>
               <a:t>Requirements:</a:t>
             </a:r>
-            <a:endParaRPr sz="1400">
+            <a:endParaRPr sz="1500" dirty="0">
               <a:latin typeface="Times New Roman"/>
               <a:cs typeface="Times New Roman"/>
             </a:endParaRPr>
+          </a:p>
+          <a:p>
+            <a:pPr marL="188595" indent="-171450">
+              <a:lnSpc>
+                <a:spcPct val="100000"/>
+              </a:lnSpc>
+              <a:spcBef>
+                <a:spcPts val="550"/>
+              </a:spcBef>
+              <a:buFont typeface="Arial" panose="020B0604020202020204" pitchFamily="34" charset="0"/>
+              <a:buChar char="•"/>
+            </a:pPr>
+            <a:r>
+              <a:rPr lang="en-US" sz="1300" b="1" dirty="0">
+                <a:latin typeface="Times New Roman"/>
+                <a:cs typeface="Times New Roman"/>
+              </a:rPr>
+              <a:t>Visual Design</a:t>
+            </a:r>
+            <a:r>
+              <a:rPr lang="en-US" sz="1300" dirty="0">
+                <a:latin typeface="Times New Roman"/>
+                <a:cs typeface="Times New Roman"/>
+              </a:rPr>
+              <a:t>: Transform the HTML structure into a professional-looking interface</a:t>
+            </a:r>
+          </a:p>
+          <a:p>
+            <a:pPr marL="188595" indent="-171450">
+              <a:lnSpc>
+                <a:spcPct val="100000"/>
+              </a:lnSpc>
+              <a:spcBef>
+                <a:spcPts val="550"/>
+              </a:spcBef>
+              <a:buFont typeface="Arial" panose="020B0604020202020204" pitchFamily="34" charset="0"/>
+              <a:buChar char="•"/>
+            </a:pPr>
+            <a:r>
+              <a:rPr lang="en-US" sz="1300" b="1" dirty="0">
+                <a:latin typeface="Times New Roman"/>
+                <a:cs typeface="Times New Roman"/>
+              </a:rPr>
+              <a:t>Layout Management</a:t>
+            </a:r>
+            <a:r>
+              <a:rPr lang="en-US" sz="1300" dirty="0">
+                <a:latin typeface="Times New Roman"/>
+                <a:cs typeface="Times New Roman"/>
+              </a:rPr>
+              <a:t>: Use the Box Model to center the form and space out elements.</a:t>
+            </a:r>
+          </a:p>
+          <a:p>
+            <a:pPr marL="188595" indent="-171450">
+              <a:lnSpc>
+                <a:spcPct val="100000"/>
+              </a:lnSpc>
+              <a:spcBef>
+                <a:spcPts val="550"/>
+              </a:spcBef>
+              <a:buFont typeface="Arial" panose="020B0604020202020204" pitchFamily="34" charset="0"/>
+              <a:buChar char="•"/>
+            </a:pPr>
+            <a:r>
+              <a:rPr lang="en-US" sz="1300" b="1" dirty="0">
+                <a:latin typeface="Times New Roman"/>
+                <a:cs typeface="Times New Roman"/>
+              </a:rPr>
+              <a:t>Interactive Elements</a:t>
+            </a:r>
+            <a:r>
+              <a:rPr lang="en-US" sz="1300" dirty="0">
+                <a:latin typeface="Times New Roman"/>
+                <a:cs typeface="Times New Roman"/>
+              </a:rPr>
+              <a:t>: Add hover effects and real-time input validation.</a:t>
+            </a:r>
+          </a:p>
+          <a:p>
+            <a:pPr marL="188595" indent="-171450">
+              <a:lnSpc>
+                <a:spcPct val="100000"/>
+              </a:lnSpc>
+              <a:spcBef>
+                <a:spcPts val="550"/>
+              </a:spcBef>
+              <a:buFont typeface="Arial" panose="020B0604020202020204" pitchFamily="34" charset="0"/>
+              <a:buChar char="•"/>
+            </a:pPr>
+            <a:r>
+              <a:rPr lang="en-US" sz="1300" b="1" dirty="0">
+                <a:latin typeface="Times New Roman"/>
+                <a:cs typeface="Times New Roman"/>
+              </a:rPr>
+              <a:t>Data Readability</a:t>
+            </a:r>
+            <a:r>
+              <a:rPr lang="en-US" sz="1300" dirty="0">
+                <a:latin typeface="Times New Roman"/>
+                <a:cs typeface="Times New Roman"/>
+              </a:rPr>
+              <a:t>: Style tables and footers for a clean, organized presentation.</a:t>
+            </a:r>
           </a:p>
           <a:p>
             <a:pPr marL="17145">
@@ -3675,497 +3095,130 @@
               </a:spcBef>
             </a:pPr>
             <a:r>
-              <a:rPr sz="1200" i="1" dirty="0">
-                <a:latin typeface="Times New Roman"/>
-                <a:cs typeface="Times New Roman"/>
-              </a:rPr>
-              <a:t>(This</a:t>
-            </a:r>
-            <a:r>
-              <a:rPr sz="1200" i="1" spc="-20" dirty="0">
-                <a:latin typeface="Times New Roman"/>
-                <a:cs typeface="Times New Roman"/>
-              </a:rPr>
-              <a:t> </a:t>
-            </a:r>
-            <a:r>
-              <a:rPr sz="1200" i="1" dirty="0">
-                <a:latin typeface="Times New Roman"/>
-                <a:cs typeface="Times New Roman"/>
-              </a:rPr>
-              <a:t>section</a:t>
-            </a:r>
-            <a:r>
-              <a:rPr sz="1200" i="1" spc="-10" dirty="0">
-                <a:latin typeface="Times New Roman"/>
-                <a:cs typeface="Times New Roman"/>
-              </a:rPr>
-              <a:t> </a:t>
-            </a:r>
-            <a:r>
-              <a:rPr sz="1200" i="1" dirty="0">
-                <a:latin typeface="Times New Roman"/>
-                <a:cs typeface="Times New Roman"/>
-              </a:rPr>
-              <a:t>lists</a:t>
-            </a:r>
-            <a:r>
-              <a:rPr sz="1200" i="1" spc="-15" dirty="0">
-                <a:latin typeface="Times New Roman"/>
-                <a:cs typeface="Times New Roman"/>
-              </a:rPr>
-              <a:t> </a:t>
-            </a:r>
-            <a:r>
-              <a:rPr sz="1200" i="1" dirty="0">
-                <a:latin typeface="Times New Roman"/>
-                <a:cs typeface="Times New Roman"/>
-              </a:rPr>
-              <a:t>all</a:t>
-            </a:r>
-            <a:r>
-              <a:rPr sz="1200" i="1" spc="-20" dirty="0">
-                <a:latin typeface="Times New Roman"/>
-                <a:cs typeface="Times New Roman"/>
-              </a:rPr>
-              <a:t> </a:t>
-            </a:r>
-            <a:r>
-              <a:rPr sz="1200" i="1" dirty="0">
-                <a:latin typeface="Times New Roman"/>
-                <a:cs typeface="Times New Roman"/>
-              </a:rPr>
-              <a:t>the</a:t>
-            </a:r>
-            <a:r>
-              <a:rPr sz="1200" i="1" spc="-15" dirty="0">
-                <a:latin typeface="Times New Roman"/>
-                <a:cs typeface="Times New Roman"/>
-              </a:rPr>
-              <a:t> </a:t>
-            </a:r>
-            <a:r>
-              <a:rPr sz="1200" i="1" dirty="0">
-                <a:latin typeface="Times New Roman"/>
-                <a:cs typeface="Times New Roman"/>
-              </a:rPr>
-              <a:t>styling</a:t>
-            </a:r>
-            <a:r>
-              <a:rPr sz="1200" i="1" spc="-10" dirty="0">
-                <a:latin typeface="Times New Roman"/>
-                <a:cs typeface="Times New Roman"/>
-              </a:rPr>
-              <a:t> </a:t>
-            </a:r>
-            <a:r>
-              <a:rPr sz="1200" i="1" dirty="0">
-                <a:latin typeface="Times New Roman"/>
-                <a:cs typeface="Times New Roman"/>
-              </a:rPr>
-              <a:t>tasks</a:t>
-            </a:r>
-            <a:r>
-              <a:rPr sz="1200" i="1" spc="-20" dirty="0">
-                <a:latin typeface="Times New Roman"/>
-                <a:cs typeface="Times New Roman"/>
-              </a:rPr>
-              <a:t> </a:t>
-            </a:r>
-            <a:r>
-              <a:rPr sz="1200" i="1" dirty="0">
-                <a:latin typeface="Times New Roman"/>
-                <a:cs typeface="Times New Roman"/>
-              </a:rPr>
-              <a:t>that</a:t>
-            </a:r>
-            <a:r>
-              <a:rPr sz="1200" i="1" spc="-5" dirty="0">
-                <a:latin typeface="Times New Roman"/>
-                <a:cs typeface="Times New Roman"/>
-              </a:rPr>
-              <a:t> </a:t>
-            </a:r>
-            <a:r>
-              <a:rPr sz="1200" i="1" dirty="0">
-                <a:latin typeface="Times New Roman"/>
-                <a:cs typeface="Times New Roman"/>
-              </a:rPr>
-              <a:t>must</a:t>
-            </a:r>
-            <a:r>
-              <a:rPr sz="1200" i="1" spc="-10" dirty="0">
-                <a:latin typeface="Times New Roman"/>
-                <a:cs typeface="Times New Roman"/>
-              </a:rPr>
-              <a:t> </a:t>
-            </a:r>
-            <a:r>
-              <a:rPr sz="1200" i="1" dirty="0">
-                <a:latin typeface="Times New Roman"/>
-                <a:cs typeface="Times New Roman"/>
-              </a:rPr>
-              <a:t>be</a:t>
-            </a:r>
-            <a:r>
-              <a:rPr sz="1200" i="1" spc="-15" dirty="0">
-                <a:latin typeface="Times New Roman"/>
-                <a:cs typeface="Times New Roman"/>
-              </a:rPr>
-              <a:t> </a:t>
-            </a:r>
-            <a:r>
-              <a:rPr sz="1200" i="1" spc="-10" dirty="0">
-                <a:latin typeface="Times New Roman"/>
-                <a:cs typeface="Times New Roman"/>
-              </a:rPr>
-              <a:t>implemented </a:t>
-            </a:r>
-            <a:r>
-              <a:rPr sz="1200" i="1" dirty="0">
-                <a:latin typeface="Times New Roman"/>
-                <a:cs typeface="Times New Roman"/>
-              </a:rPr>
-              <a:t>using</a:t>
-            </a:r>
-            <a:r>
-              <a:rPr sz="1200" i="1" spc="-15" dirty="0">
-                <a:latin typeface="Times New Roman"/>
-                <a:cs typeface="Times New Roman"/>
-              </a:rPr>
-              <a:t> </a:t>
-            </a:r>
-            <a:r>
-              <a:rPr sz="1200" i="1" spc="-10" dirty="0">
-                <a:latin typeface="Times New Roman"/>
-                <a:cs typeface="Times New Roman"/>
-              </a:rPr>
-              <a:t>CSS.)</a:t>
-            </a:r>
-            <a:endParaRPr sz="1200">
+              <a:rPr lang="en-US" sz="1300" b="1" dirty="0">
+                <a:latin typeface="Times New Roman"/>
+                <a:cs typeface="Times New Roman"/>
+              </a:rPr>
+              <a:t>3.1 </a:t>
+            </a:r>
+            <a:r>
+              <a:rPr sz="1500" b="1" dirty="0">
+                <a:latin typeface="Times New Roman"/>
+                <a:cs typeface="Times New Roman"/>
+              </a:rPr>
+              <a:t>Apply</a:t>
+            </a:r>
+            <a:r>
+              <a:rPr sz="1500" b="1" spc="-45" dirty="0">
+                <a:latin typeface="Times New Roman"/>
+                <a:cs typeface="Times New Roman"/>
+              </a:rPr>
+              <a:t> </a:t>
+            </a:r>
+            <a:r>
+              <a:rPr sz="1500" b="1" dirty="0">
+                <a:latin typeface="Times New Roman"/>
+                <a:cs typeface="Times New Roman"/>
+              </a:rPr>
+              <a:t>Global</a:t>
+            </a:r>
+            <a:r>
+              <a:rPr sz="1500" b="1" spc="-45" dirty="0">
+                <a:latin typeface="Times New Roman"/>
+                <a:cs typeface="Times New Roman"/>
+              </a:rPr>
+              <a:t> </a:t>
+            </a:r>
+            <a:r>
+              <a:rPr sz="1500" b="1" spc="-10" dirty="0">
+                <a:latin typeface="Times New Roman"/>
+                <a:cs typeface="Times New Roman"/>
+              </a:rPr>
+              <a:t>Styling:</a:t>
+            </a:r>
+            <a:endParaRPr sz="1500" dirty="0">
               <a:latin typeface="Times New Roman"/>
               <a:cs typeface="Times New Roman"/>
             </a:endParaRPr>
           </a:p>
           <a:p>
-            <a:pPr>
-              <a:lnSpc>
-                <a:spcPct val="100000"/>
-              </a:lnSpc>
-              <a:spcBef>
-                <a:spcPts val="370"/>
-              </a:spcBef>
-            </a:pPr>
-            <a:endParaRPr sz="1200">
-              <a:latin typeface="Times New Roman"/>
-              <a:cs typeface="Times New Roman"/>
-            </a:endParaRPr>
-          </a:p>
-          <a:p>
-            <a:pPr marL="260350" lvl="1" indent="-246379">
-              <a:lnSpc>
-                <a:spcPct val="100000"/>
-              </a:lnSpc>
-              <a:buAutoNum type="arabicPeriod"/>
-              <a:tabLst>
-                <a:tab pos="260350" algn="l"/>
-              </a:tabLst>
-            </a:pPr>
-            <a:r>
-              <a:rPr sz="1300" b="1" dirty="0">
-                <a:latin typeface="Times New Roman"/>
-                <a:cs typeface="Times New Roman"/>
-              </a:rPr>
-              <a:t>Apply</a:t>
-            </a:r>
-            <a:r>
-              <a:rPr sz="1300" b="1" spc="-45" dirty="0">
-                <a:latin typeface="Times New Roman"/>
-                <a:cs typeface="Times New Roman"/>
-              </a:rPr>
-              <a:t> </a:t>
-            </a:r>
-            <a:r>
-              <a:rPr sz="1300" b="1" dirty="0">
-                <a:latin typeface="Times New Roman"/>
-                <a:cs typeface="Times New Roman"/>
-              </a:rPr>
-              <a:t>Global</a:t>
-            </a:r>
-            <a:r>
-              <a:rPr sz="1300" b="1" spc="-45" dirty="0">
-                <a:latin typeface="Times New Roman"/>
-                <a:cs typeface="Times New Roman"/>
-              </a:rPr>
-              <a:t> </a:t>
-            </a:r>
-            <a:r>
-              <a:rPr sz="1300" b="1" spc="-10" dirty="0">
-                <a:latin typeface="Times New Roman"/>
-                <a:cs typeface="Times New Roman"/>
-              </a:rPr>
-              <a:t>Styling:</a:t>
-            </a:r>
-            <a:endParaRPr sz="1300">
-              <a:latin typeface="Times New Roman"/>
-              <a:cs typeface="Times New Roman"/>
-            </a:endParaRPr>
-          </a:p>
-          <a:p>
-            <a:pPr marL="106680" marR="5080">
+            <a:pPr marL="278130" marR="5080" indent="-171450">
               <a:lnSpc>
                 <a:spcPts val="1380"/>
               </a:lnSpc>
               <a:spcBef>
                 <a:spcPts val="425"/>
               </a:spcBef>
+              <a:buFont typeface="Arial" panose="020B0604020202020204" pitchFamily="34" charset="0"/>
+              <a:buChar char="•"/>
             </a:pPr>
             <a:r>
-              <a:rPr sz="1200" i="1" dirty="0">
-                <a:latin typeface="Times New Roman"/>
-                <a:cs typeface="Times New Roman"/>
-              </a:rPr>
-              <a:t>(Apply</a:t>
-            </a:r>
-            <a:r>
-              <a:rPr sz="1200" i="1" spc="-35" dirty="0">
-                <a:latin typeface="Times New Roman"/>
-                <a:cs typeface="Times New Roman"/>
-              </a:rPr>
-              <a:t> </a:t>
-            </a:r>
-            <a:r>
-              <a:rPr sz="1200" i="1" dirty="0">
-                <a:latin typeface="Times New Roman"/>
-                <a:cs typeface="Times New Roman"/>
-              </a:rPr>
-              <a:t>overall</a:t>
-            </a:r>
-            <a:r>
-              <a:rPr sz="1200" i="1" spc="-25" dirty="0">
-                <a:latin typeface="Times New Roman"/>
-                <a:cs typeface="Times New Roman"/>
-              </a:rPr>
-              <a:t> </a:t>
-            </a:r>
-            <a:r>
-              <a:rPr sz="1200" i="1" dirty="0">
-                <a:latin typeface="Times New Roman"/>
-                <a:cs typeface="Times New Roman"/>
-              </a:rPr>
-              <a:t>styles</a:t>
-            </a:r>
-            <a:r>
-              <a:rPr sz="1200" i="1" spc="-35" dirty="0">
-                <a:latin typeface="Times New Roman"/>
-                <a:cs typeface="Times New Roman"/>
-              </a:rPr>
-              <a:t> </a:t>
-            </a:r>
-            <a:r>
-              <a:rPr sz="1200" i="1" dirty="0">
-                <a:latin typeface="Times New Roman"/>
-                <a:cs typeface="Times New Roman"/>
-              </a:rPr>
-              <a:t>to</a:t>
-            </a:r>
-            <a:r>
-              <a:rPr sz="1200" i="1" spc="-30" dirty="0">
-                <a:latin typeface="Times New Roman"/>
-                <a:cs typeface="Times New Roman"/>
-              </a:rPr>
-              <a:t> </a:t>
-            </a:r>
-            <a:r>
-              <a:rPr sz="1200" i="1" dirty="0">
-                <a:latin typeface="Times New Roman"/>
-                <a:cs typeface="Times New Roman"/>
-              </a:rPr>
-              <a:t>the</a:t>
-            </a:r>
-            <a:r>
-              <a:rPr sz="1200" i="1" spc="-30" dirty="0">
-                <a:latin typeface="Times New Roman"/>
-                <a:cs typeface="Times New Roman"/>
-              </a:rPr>
-              <a:t> </a:t>
-            </a:r>
-            <a:r>
-              <a:rPr sz="1200" i="1" dirty="0">
-                <a:latin typeface="Times New Roman"/>
-                <a:cs typeface="Times New Roman"/>
-              </a:rPr>
-              <a:t>entire</a:t>
-            </a:r>
-            <a:r>
-              <a:rPr sz="1200" i="1" spc="-35" dirty="0">
-                <a:latin typeface="Times New Roman"/>
-                <a:cs typeface="Times New Roman"/>
-              </a:rPr>
-              <a:t> </a:t>
-            </a:r>
-            <a:r>
-              <a:rPr sz="1200" i="1" dirty="0">
-                <a:latin typeface="Times New Roman"/>
-                <a:cs typeface="Times New Roman"/>
-              </a:rPr>
-              <a:t>webpage</a:t>
-            </a:r>
-            <a:r>
-              <a:rPr sz="1200" i="1" spc="-35" dirty="0">
-                <a:latin typeface="Times New Roman"/>
-                <a:cs typeface="Times New Roman"/>
-              </a:rPr>
-              <a:t> </a:t>
-            </a:r>
-            <a:r>
-              <a:rPr sz="1200" i="1" dirty="0">
-                <a:latin typeface="Times New Roman"/>
-                <a:cs typeface="Times New Roman"/>
-              </a:rPr>
-              <a:t>including</a:t>
-            </a:r>
-            <a:r>
-              <a:rPr sz="1200" i="1" spc="-30" dirty="0">
-                <a:latin typeface="Times New Roman"/>
-                <a:cs typeface="Times New Roman"/>
-              </a:rPr>
-              <a:t> </a:t>
-            </a:r>
-            <a:r>
-              <a:rPr sz="1200" i="1" dirty="0">
-                <a:latin typeface="Times New Roman"/>
-                <a:cs typeface="Times New Roman"/>
-              </a:rPr>
-              <a:t>background,</a:t>
-            </a:r>
-            <a:r>
-              <a:rPr sz="1200" i="1" spc="-30" dirty="0">
-                <a:latin typeface="Times New Roman"/>
-                <a:cs typeface="Times New Roman"/>
-              </a:rPr>
-              <a:t> </a:t>
-            </a:r>
-            <a:r>
-              <a:rPr sz="1200" i="1" dirty="0">
-                <a:latin typeface="Times New Roman"/>
-                <a:cs typeface="Times New Roman"/>
-              </a:rPr>
-              <a:t>font,</a:t>
-            </a:r>
-            <a:r>
-              <a:rPr sz="1200" i="1" spc="-30" dirty="0">
-                <a:latin typeface="Times New Roman"/>
-                <a:cs typeface="Times New Roman"/>
-              </a:rPr>
-              <a:t> </a:t>
-            </a:r>
-            <a:r>
-              <a:rPr sz="1200" i="1" dirty="0">
-                <a:latin typeface="Times New Roman"/>
-                <a:cs typeface="Times New Roman"/>
-              </a:rPr>
-              <a:t>spacing,</a:t>
-            </a:r>
-            <a:r>
-              <a:rPr sz="1200" i="1" spc="-30" dirty="0">
-                <a:latin typeface="Times New Roman"/>
-                <a:cs typeface="Times New Roman"/>
-              </a:rPr>
-              <a:t> </a:t>
-            </a:r>
-            <a:r>
-              <a:rPr sz="1200" i="1" dirty="0">
-                <a:latin typeface="Times New Roman"/>
-                <a:cs typeface="Times New Roman"/>
-              </a:rPr>
-              <a:t>and</a:t>
-            </a:r>
-            <a:r>
-              <a:rPr sz="1200" i="1" spc="-30" dirty="0">
-                <a:latin typeface="Times New Roman"/>
-                <a:cs typeface="Times New Roman"/>
-              </a:rPr>
-              <a:t> </a:t>
-            </a:r>
-            <a:r>
-              <a:rPr sz="1200" i="1" dirty="0">
-                <a:latin typeface="Times New Roman"/>
-                <a:cs typeface="Times New Roman"/>
-              </a:rPr>
-              <a:t>text</a:t>
-            </a:r>
-            <a:r>
-              <a:rPr sz="1200" i="1" spc="-30" dirty="0">
-                <a:latin typeface="Times New Roman"/>
-                <a:cs typeface="Times New Roman"/>
-              </a:rPr>
-              <a:t> </a:t>
-            </a:r>
-            <a:r>
-              <a:rPr sz="1200" i="1" dirty="0">
-                <a:latin typeface="Times New Roman"/>
-                <a:cs typeface="Times New Roman"/>
-              </a:rPr>
-              <a:t>alignment</a:t>
-            </a:r>
-            <a:r>
-              <a:rPr sz="1200" i="1" spc="-25" dirty="0">
-                <a:latin typeface="Times New Roman"/>
-                <a:cs typeface="Times New Roman"/>
-              </a:rPr>
-              <a:t> to </a:t>
-            </a:r>
-            <a:r>
-              <a:rPr sz="1200" i="1" dirty="0">
-                <a:latin typeface="Times New Roman"/>
-                <a:cs typeface="Times New Roman"/>
-              </a:rPr>
-              <a:t>ensure</a:t>
-            </a:r>
-            <a:r>
-              <a:rPr sz="1200" i="1" spc="-20" dirty="0">
-                <a:latin typeface="Times New Roman"/>
-                <a:cs typeface="Times New Roman"/>
-              </a:rPr>
-              <a:t> </a:t>
-            </a:r>
-            <a:r>
-              <a:rPr sz="1200" i="1" dirty="0">
-                <a:latin typeface="Times New Roman"/>
-                <a:cs typeface="Times New Roman"/>
-              </a:rPr>
-              <a:t>a</a:t>
-            </a:r>
-            <a:r>
-              <a:rPr sz="1200" i="1" spc="-15" dirty="0">
-                <a:latin typeface="Times New Roman"/>
-                <a:cs typeface="Times New Roman"/>
-              </a:rPr>
-              <a:t> </a:t>
-            </a:r>
-            <a:r>
-              <a:rPr sz="1200" i="1" dirty="0">
-                <a:latin typeface="Times New Roman"/>
-                <a:cs typeface="Times New Roman"/>
-              </a:rPr>
-              <a:t>consistent</a:t>
-            </a:r>
-            <a:r>
-              <a:rPr sz="1200" i="1" spc="-15" dirty="0">
-                <a:latin typeface="Times New Roman"/>
-                <a:cs typeface="Times New Roman"/>
-              </a:rPr>
-              <a:t> </a:t>
-            </a:r>
-            <a:r>
-              <a:rPr sz="1200" i="1" spc="-10" dirty="0">
-                <a:latin typeface="Times New Roman"/>
-                <a:cs typeface="Times New Roman"/>
-              </a:rPr>
-              <a:t>design.)</a:t>
-            </a:r>
-            <a:endParaRPr sz="1200">
+              <a:rPr lang="en-US" sz="1300" b="1" dirty="0">
+                <a:latin typeface="Times New Roman"/>
+                <a:cs typeface="Times New Roman"/>
+              </a:rPr>
+              <a:t>Background</a:t>
+            </a:r>
+            <a:r>
+              <a:rPr lang="en-US" sz="1300" dirty="0">
+                <a:latin typeface="Times New Roman"/>
+                <a:cs typeface="Times New Roman"/>
+              </a:rPr>
+              <a:t>: Applied a light blue background color (#f0f8ff) to the entire page.</a:t>
+            </a:r>
+          </a:p>
+          <a:p>
+            <a:pPr marL="278130" marR="5080" indent="-171450">
+              <a:lnSpc>
+                <a:spcPts val="1380"/>
+              </a:lnSpc>
+              <a:spcBef>
+                <a:spcPts val="425"/>
+              </a:spcBef>
+              <a:buFont typeface="Arial" panose="020B0604020202020204" pitchFamily="34" charset="0"/>
+              <a:buChar char="•"/>
+            </a:pPr>
+            <a:r>
+              <a:rPr lang="en-US" sz="1300" b="1" dirty="0">
+                <a:latin typeface="Times New Roman"/>
+                <a:cs typeface="Times New Roman"/>
+              </a:rPr>
+              <a:t>Typography: </a:t>
+            </a:r>
+            <a:r>
+              <a:rPr lang="en-US" sz="1300" dirty="0">
+                <a:latin typeface="Times New Roman"/>
+                <a:cs typeface="Times New Roman"/>
+              </a:rPr>
+              <a:t>Set the primary font family to Arial, sans-serif for clean readability.</a:t>
+            </a:r>
+          </a:p>
+          <a:p>
+            <a:pPr marL="278130" marR="5080" indent="-171450">
+              <a:lnSpc>
+                <a:spcPts val="1380"/>
+              </a:lnSpc>
+              <a:spcBef>
+                <a:spcPts val="425"/>
+              </a:spcBef>
+              <a:buFont typeface="Arial" panose="020B0604020202020204" pitchFamily="34" charset="0"/>
+              <a:buChar char="•"/>
+            </a:pPr>
+            <a:r>
+              <a:rPr lang="en-US" sz="1300" b="1" dirty="0">
+                <a:latin typeface="Times New Roman"/>
+                <a:cs typeface="Times New Roman"/>
+              </a:rPr>
+              <a:t>Spacing</a:t>
+            </a:r>
+            <a:r>
+              <a:rPr lang="en-US" sz="1300" dirty="0">
+                <a:latin typeface="Times New Roman"/>
+                <a:cs typeface="Times New Roman"/>
+              </a:rPr>
+              <a:t>: Used padding: 20px and margin: 0 on the body to ensure content is well-spaced.</a:t>
+            </a:r>
+            <a:endParaRPr sz="1300" dirty="0">
               <a:latin typeface="Times New Roman"/>
               <a:cs typeface="Times New Roman"/>
             </a:endParaRPr>
@@ -4180,7 +3233,7 @@
         </p:nvGrpSpPr>
         <p:grpSpPr>
           <a:xfrm>
-            <a:off x="806450" y="9338944"/>
+            <a:off x="792276" y="10128972"/>
             <a:ext cx="6399530" cy="21590"/>
             <a:chOff x="806450" y="9338944"/>
             <a:chExt cx="6399530" cy="21590"/>
@@ -4674,28 +3727,6 @@
           </a:prstGeom>
         </p:spPr>
       </p:pic>
-      <p:pic>
-        <p:nvPicPr>
-          <p:cNvPr id="4" name="object 4"/>
-          <p:cNvPicPr/>
-          <p:nvPr/>
-        </p:nvPicPr>
-        <p:blipFill>
-          <a:blip r:embed="rId2" cstate="print"/>
-          <a:stretch>
-            <a:fillRect/>
-          </a:stretch>
-        </p:blipFill>
-        <p:spPr>
-          <a:xfrm>
-            <a:off x="4416425" y="9873589"/>
-            <a:ext cx="996314" cy="434174"/>
-          </a:xfrm>
-          <a:prstGeom prst="rect">
-            <a:avLst/>
-          </a:prstGeom>
-        </p:spPr>
-      </p:pic>
       <p:sp>
         <p:nvSpPr>
           <p:cNvPr id="5" name="object 5"/>
@@ -4705,7 +3736,7 @@
         <p:spPr>
           <a:xfrm>
             <a:off x="773988" y="1123555"/>
-            <a:ext cx="6075045" cy="668020"/>
+            <a:ext cx="6075045" cy="860492"/>
           </a:xfrm>
           <a:prstGeom prst="rect">
             <a:avLst/>
@@ -4726,394 +3757,162 @@
               </a:spcBef>
             </a:pPr>
             <a:r>
-              <a:rPr sz="1300" b="1" dirty="0">
+              <a:rPr lang="en-US" sz="1500" b="1" dirty="0">
                 <a:latin typeface="Times New Roman"/>
                 <a:cs typeface="Times New Roman"/>
               </a:rPr>
               <a:t>3.2</a:t>
             </a:r>
             <a:r>
-              <a:rPr sz="1300" b="1" spc="-30" dirty="0">
-                <a:latin typeface="Times New Roman"/>
-                <a:cs typeface="Times New Roman"/>
-              </a:rPr>
-              <a:t> </a:t>
-            </a:r>
-            <a:r>
-              <a:rPr sz="1300" b="1" dirty="0">
+              <a:rPr lang="en-US" sz="1500" b="1" spc="-30" dirty="0">
+                <a:latin typeface="Times New Roman"/>
+                <a:cs typeface="Times New Roman"/>
+              </a:rPr>
+              <a:t> </a:t>
+            </a:r>
+            <a:r>
+              <a:rPr lang="en-US" sz="1500" b="1" dirty="0">
                 <a:latin typeface="Times New Roman"/>
                 <a:cs typeface="Times New Roman"/>
               </a:rPr>
               <a:t>Style</a:t>
             </a:r>
             <a:r>
-              <a:rPr sz="1300" b="1" spc="-30" dirty="0">
-                <a:latin typeface="Times New Roman"/>
-                <a:cs typeface="Times New Roman"/>
-              </a:rPr>
-              <a:t> </a:t>
-            </a:r>
-            <a:r>
-              <a:rPr sz="1300" b="1" dirty="0">
+              <a:rPr lang="en-US" sz="1500" b="1" spc="-30" dirty="0">
+                <a:latin typeface="Times New Roman"/>
+                <a:cs typeface="Times New Roman"/>
+              </a:rPr>
+              <a:t> </a:t>
+            </a:r>
+            <a:r>
+              <a:rPr lang="en-US" sz="1500" b="1" dirty="0">
                 <a:latin typeface="Times New Roman"/>
                 <a:cs typeface="Times New Roman"/>
               </a:rPr>
               <a:t>the</a:t>
             </a:r>
             <a:r>
-              <a:rPr sz="1300" b="1" spc="-15" dirty="0">
-                <a:latin typeface="Times New Roman"/>
-                <a:cs typeface="Times New Roman"/>
-              </a:rPr>
-              <a:t> </a:t>
-            </a:r>
-            <a:r>
-              <a:rPr sz="1300" b="1" dirty="0">
+              <a:rPr lang="en-US" sz="1500" b="1" spc="-15" dirty="0">
+                <a:latin typeface="Times New Roman"/>
+                <a:cs typeface="Times New Roman"/>
+              </a:rPr>
+              <a:t> </a:t>
+            </a:r>
+            <a:r>
+              <a:rPr lang="en-US" sz="1500" b="1" dirty="0">
                 <a:latin typeface="Times New Roman"/>
                 <a:cs typeface="Times New Roman"/>
               </a:rPr>
               <a:t>Event</a:t>
             </a:r>
             <a:r>
-              <a:rPr sz="1300" b="1" spc="-15" dirty="0">
-                <a:latin typeface="Times New Roman"/>
-                <a:cs typeface="Times New Roman"/>
-              </a:rPr>
-              <a:t> </a:t>
-            </a:r>
-            <a:r>
-              <a:rPr sz="1300" b="1" dirty="0">
+              <a:rPr lang="en-US" sz="1500" b="1" spc="-15" dirty="0">
+                <a:latin typeface="Times New Roman"/>
+                <a:cs typeface="Times New Roman"/>
+              </a:rPr>
+              <a:t> </a:t>
+            </a:r>
+            <a:r>
+              <a:rPr lang="en-US" sz="1500" b="1" dirty="0">
                 <a:latin typeface="Times New Roman"/>
                 <a:cs typeface="Times New Roman"/>
               </a:rPr>
               <a:t>Title</a:t>
             </a:r>
             <a:r>
-              <a:rPr sz="1300" b="1" spc="-30" dirty="0">
-                <a:latin typeface="Times New Roman"/>
-                <a:cs typeface="Times New Roman"/>
-              </a:rPr>
-              <a:t> </a:t>
-            </a:r>
-            <a:r>
-              <a:rPr sz="1300" b="1" dirty="0">
+              <a:rPr lang="en-US" sz="1500" b="1" spc="-30" dirty="0">
+                <a:latin typeface="Times New Roman"/>
+                <a:cs typeface="Times New Roman"/>
+              </a:rPr>
+              <a:t> </a:t>
+            </a:r>
+            <a:r>
+              <a:rPr lang="en-US" sz="1500" b="1" dirty="0">
                 <a:latin typeface="Times New Roman"/>
                 <a:cs typeface="Times New Roman"/>
               </a:rPr>
               <a:t>and</a:t>
             </a:r>
             <a:r>
-              <a:rPr sz="1300" b="1" spc="-20" dirty="0">
-                <a:latin typeface="Times New Roman"/>
-                <a:cs typeface="Times New Roman"/>
-              </a:rPr>
-              <a:t> </a:t>
-            </a:r>
-            <a:r>
-              <a:rPr sz="1300" b="1" spc="-10" dirty="0">
+              <a:rPr lang="en-US" sz="1500" b="1" spc="-20" dirty="0">
+                <a:latin typeface="Times New Roman"/>
+                <a:cs typeface="Times New Roman"/>
+              </a:rPr>
+              <a:t> </a:t>
+            </a:r>
+            <a:r>
+              <a:rPr lang="en-US" sz="1500" b="1" spc="-10" dirty="0">
                 <a:latin typeface="Times New Roman"/>
                 <a:cs typeface="Times New Roman"/>
               </a:rPr>
               <a:t>Description:</a:t>
             </a:r>
-            <a:endParaRPr sz="1300">
+          </a:p>
+          <a:p>
+            <a:pPr marL="12700">
+              <a:lnSpc>
+                <a:spcPct val="100000"/>
+              </a:lnSpc>
+              <a:spcBef>
+                <a:spcPts val="450"/>
+              </a:spcBef>
+            </a:pPr>
+            <a:endParaRPr lang="en-US" sz="300" dirty="0">
               <a:latin typeface="Times New Roman"/>
               <a:cs typeface="Times New Roman"/>
             </a:endParaRPr>
           </a:p>
           <a:p>
-            <a:pPr marL="73025" marR="5080">
+            <a:pPr marL="358775" marR="5080" indent="-285750">
               <a:lnSpc>
                 <a:spcPts val="1380"/>
               </a:lnSpc>
               <a:spcBef>
                 <a:spcPts val="425"/>
               </a:spcBef>
+              <a:buFont typeface="Arial" panose="020B0604020202020204" pitchFamily="34" charset="0"/>
+              <a:buChar char="•"/>
             </a:pPr>
             <a:r>
-              <a:rPr sz="1200" i="1" dirty="0">
-                <a:latin typeface="Times New Roman"/>
-                <a:cs typeface="Times New Roman"/>
-              </a:rPr>
-              <a:t>(Enhance</a:t>
-            </a:r>
-            <a:r>
-              <a:rPr sz="1200" i="1" spc="-35" dirty="0">
-                <a:latin typeface="Times New Roman"/>
-                <a:cs typeface="Times New Roman"/>
-              </a:rPr>
-              <a:t> </a:t>
-            </a:r>
-            <a:r>
-              <a:rPr sz="1200" i="1" dirty="0">
-                <a:latin typeface="Times New Roman"/>
-                <a:cs typeface="Times New Roman"/>
-              </a:rPr>
-              <a:t>the</a:t>
-            </a:r>
-            <a:r>
-              <a:rPr sz="1200" i="1" spc="-25" dirty="0">
-                <a:latin typeface="Times New Roman"/>
-                <a:cs typeface="Times New Roman"/>
-              </a:rPr>
-              <a:t> </a:t>
-            </a:r>
-            <a:r>
-              <a:rPr sz="1200" i="1" dirty="0">
-                <a:latin typeface="Times New Roman"/>
-                <a:cs typeface="Times New Roman"/>
-              </a:rPr>
-              <a:t>appearance</a:t>
-            </a:r>
-            <a:r>
-              <a:rPr sz="1200" i="1" spc="-35" dirty="0">
-                <a:latin typeface="Times New Roman"/>
-                <a:cs typeface="Times New Roman"/>
-              </a:rPr>
-              <a:t> </a:t>
-            </a:r>
-            <a:r>
-              <a:rPr sz="1200" i="1" dirty="0">
-                <a:latin typeface="Times New Roman"/>
-                <a:cs typeface="Times New Roman"/>
-              </a:rPr>
-              <a:t>of</a:t>
-            </a:r>
-            <a:r>
-              <a:rPr sz="1200" i="1" spc="-25" dirty="0">
-                <a:latin typeface="Times New Roman"/>
-                <a:cs typeface="Times New Roman"/>
-              </a:rPr>
-              <a:t> </a:t>
-            </a:r>
-            <a:r>
-              <a:rPr sz="1200" i="1" dirty="0">
-                <a:latin typeface="Times New Roman"/>
-                <a:cs typeface="Times New Roman"/>
-              </a:rPr>
-              <a:t>the</a:t>
-            </a:r>
-            <a:r>
-              <a:rPr sz="1200" i="1" spc="-30" dirty="0">
-                <a:latin typeface="Times New Roman"/>
-                <a:cs typeface="Times New Roman"/>
-              </a:rPr>
-              <a:t> </a:t>
-            </a:r>
-            <a:r>
-              <a:rPr sz="1200" i="1" dirty="0">
-                <a:latin typeface="Times New Roman"/>
-                <a:cs typeface="Times New Roman"/>
-              </a:rPr>
-              <a:t>event</a:t>
-            </a:r>
-            <a:r>
-              <a:rPr sz="1200" i="1" spc="-30" dirty="0">
-                <a:latin typeface="Times New Roman"/>
-                <a:cs typeface="Times New Roman"/>
-              </a:rPr>
-              <a:t> </a:t>
-            </a:r>
-            <a:r>
-              <a:rPr sz="1200" i="1" dirty="0">
-                <a:latin typeface="Times New Roman"/>
-                <a:cs typeface="Times New Roman"/>
-              </a:rPr>
-              <a:t>heading</a:t>
-            </a:r>
-            <a:r>
-              <a:rPr sz="1200" i="1" spc="-25" dirty="0">
-                <a:latin typeface="Times New Roman"/>
-                <a:cs typeface="Times New Roman"/>
-              </a:rPr>
-              <a:t> </a:t>
-            </a:r>
-            <a:r>
-              <a:rPr sz="1200" i="1" dirty="0">
-                <a:latin typeface="Times New Roman"/>
-                <a:cs typeface="Times New Roman"/>
-              </a:rPr>
-              <a:t>and</a:t>
-            </a:r>
-            <a:r>
-              <a:rPr sz="1200" i="1" spc="-30" dirty="0">
-                <a:latin typeface="Times New Roman"/>
-                <a:cs typeface="Times New Roman"/>
-              </a:rPr>
-              <a:t> </a:t>
-            </a:r>
-            <a:r>
-              <a:rPr sz="1200" i="1" dirty="0">
-                <a:latin typeface="Times New Roman"/>
-                <a:cs typeface="Times New Roman"/>
-              </a:rPr>
-              <a:t>description</a:t>
-            </a:r>
-            <a:r>
-              <a:rPr sz="1200" i="1" spc="-25" dirty="0">
-                <a:latin typeface="Times New Roman"/>
-                <a:cs typeface="Times New Roman"/>
-              </a:rPr>
-              <a:t> </a:t>
-            </a:r>
-            <a:r>
-              <a:rPr sz="1200" i="1" dirty="0">
-                <a:latin typeface="Times New Roman"/>
-                <a:cs typeface="Times New Roman"/>
-              </a:rPr>
-              <a:t>using</a:t>
-            </a:r>
-            <a:r>
-              <a:rPr sz="1200" i="1" spc="-30" dirty="0">
-                <a:latin typeface="Times New Roman"/>
-                <a:cs typeface="Times New Roman"/>
-              </a:rPr>
-              <a:t> </a:t>
-            </a:r>
-            <a:r>
-              <a:rPr sz="1200" i="1" dirty="0">
-                <a:latin typeface="Times New Roman"/>
-                <a:cs typeface="Times New Roman"/>
-              </a:rPr>
-              <a:t>font</a:t>
-            </a:r>
-            <a:r>
-              <a:rPr sz="1200" i="1" spc="-25" dirty="0">
-                <a:latin typeface="Times New Roman"/>
-                <a:cs typeface="Times New Roman"/>
-              </a:rPr>
-              <a:t> </a:t>
-            </a:r>
-            <a:r>
-              <a:rPr sz="1200" i="1" dirty="0">
-                <a:latin typeface="Times New Roman"/>
-                <a:cs typeface="Times New Roman"/>
-              </a:rPr>
-              <a:t>size,</a:t>
-            </a:r>
-            <a:r>
-              <a:rPr sz="1200" i="1" spc="-30" dirty="0">
-                <a:latin typeface="Times New Roman"/>
-                <a:cs typeface="Times New Roman"/>
-              </a:rPr>
-              <a:t> </a:t>
-            </a:r>
-            <a:r>
-              <a:rPr sz="1200" i="1" dirty="0">
-                <a:latin typeface="Times New Roman"/>
-                <a:cs typeface="Times New Roman"/>
-              </a:rPr>
-              <a:t>color,</a:t>
-            </a:r>
-            <a:r>
-              <a:rPr sz="1200" i="1" spc="-25" dirty="0">
-                <a:latin typeface="Times New Roman"/>
-                <a:cs typeface="Times New Roman"/>
-              </a:rPr>
-              <a:t> </a:t>
-            </a:r>
-            <a:r>
-              <a:rPr sz="1200" i="1" dirty="0">
-                <a:latin typeface="Times New Roman"/>
-                <a:cs typeface="Times New Roman"/>
-              </a:rPr>
-              <a:t>spacing,</a:t>
-            </a:r>
-            <a:r>
-              <a:rPr sz="1200" i="1" spc="-30" dirty="0">
-                <a:latin typeface="Times New Roman"/>
-                <a:cs typeface="Times New Roman"/>
-              </a:rPr>
-              <a:t> </a:t>
-            </a:r>
-            <a:r>
-              <a:rPr sz="1200" i="1" spc="-25" dirty="0">
-                <a:latin typeface="Times New Roman"/>
-                <a:cs typeface="Times New Roman"/>
-              </a:rPr>
-              <a:t>and </a:t>
-            </a:r>
-            <a:r>
-              <a:rPr sz="1200" i="1" dirty="0">
-                <a:latin typeface="Times New Roman"/>
-                <a:cs typeface="Times New Roman"/>
-              </a:rPr>
-              <a:t>alignment</a:t>
-            </a:r>
-            <a:r>
-              <a:rPr sz="1200" i="1" spc="-40" dirty="0">
-                <a:latin typeface="Times New Roman"/>
-                <a:cs typeface="Times New Roman"/>
-              </a:rPr>
-              <a:t> </a:t>
-            </a:r>
-            <a:r>
-              <a:rPr sz="1200" i="1" dirty="0">
-                <a:latin typeface="Times New Roman"/>
-                <a:cs typeface="Times New Roman"/>
-              </a:rPr>
-              <a:t>to</a:t>
-            </a:r>
-            <a:r>
-              <a:rPr sz="1200" i="1" spc="-35" dirty="0">
-                <a:latin typeface="Times New Roman"/>
-                <a:cs typeface="Times New Roman"/>
-              </a:rPr>
-              <a:t> </a:t>
-            </a:r>
-            <a:r>
-              <a:rPr sz="1200" i="1" dirty="0">
-                <a:latin typeface="Times New Roman"/>
-                <a:cs typeface="Times New Roman"/>
-              </a:rPr>
-              <a:t>make</a:t>
-            </a:r>
-            <a:r>
-              <a:rPr sz="1200" i="1" spc="-45" dirty="0">
-                <a:latin typeface="Times New Roman"/>
-                <a:cs typeface="Times New Roman"/>
-              </a:rPr>
-              <a:t> </a:t>
-            </a:r>
-            <a:r>
-              <a:rPr sz="1200" i="1" dirty="0">
-                <a:latin typeface="Times New Roman"/>
-                <a:cs typeface="Times New Roman"/>
-              </a:rPr>
-              <a:t>them</a:t>
-            </a:r>
-            <a:r>
-              <a:rPr sz="1200" i="1" spc="-30" dirty="0">
-                <a:latin typeface="Times New Roman"/>
-                <a:cs typeface="Times New Roman"/>
-              </a:rPr>
-              <a:t> </a:t>
-            </a:r>
-            <a:r>
-              <a:rPr sz="1200" i="1" dirty="0">
-                <a:latin typeface="Times New Roman"/>
-                <a:cs typeface="Times New Roman"/>
-              </a:rPr>
-              <a:t>visually</a:t>
-            </a:r>
-            <a:r>
-              <a:rPr sz="1200" i="1" spc="-35" dirty="0">
-                <a:latin typeface="Times New Roman"/>
-                <a:cs typeface="Times New Roman"/>
-              </a:rPr>
-              <a:t> </a:t>
-            </a:r>
-            <a:r>
-              <a:rPr sz="1200" i="1" spc="-10" dirty="0">
-                <a:latin typeface="Times New Roman"/>
-                <a:cs typeface="Times New Roman"/>
-              </a:rPr>
-              <a:t>prominent.)</a:t>
-            </a:r>
-            <a:endParaRPr sz="1200">
-              <a:latin typeface="Times New Roman"/>
-              <a:cs typeface="Times New Roman"/>
-            </a:endParaRPr>
+              <a:rPr lang="en-US" sz="1300" b="1" dirty="0">
+                <a:latin typeface="Times New Roman"/>
+                <a:cs typeface="Times New Roman"/>
+              </a:rPr>
+              <a:t>Prominence:</a:t>
+            </a:r>
+            <a:r>
+              <a:rPr lang="en-US" sz="1300" dirty="0">
+                <a:latin typeface="Times New Roman"/>
+                <a:cs typeface="Times New Roman"/>
+              </a:rPr>
+              <a:t> Centered the h2 heading and increased its visibility. </a:t>
+            </a:r>
+          </a:p>
+          <a:p>
+            <a:pPr marL="358775" marR="5080" indent="-285750">
+              <a:lnSpc>
+                <a:spcPts val="1380"/>
+              </a:lnSpc>
+              <a:spcBef>
+                <a:spcPts val="425"/>
+              </a:spcBef>
+              <a:buFont typeface="Arial" panose="020B0604020202020204" pitchFamily="34" charset="0"/>
+              <a:buChar char="•"/>
+            </a:pPr>
+            <a:r>
+              <a:rPr lang="en-US" sz="1300" b="1" dirty="0">
+                <a:latin typeface="Times New Roman"/>
+                <a:cs typeface="Times New Roman"/>
+              </a:rPr>
+              <a:t>Readability</a:t>
+            </a:r>
+            <a:r>
+              <a:rPr lang="en-US" sz="1300" dirty="0">
+                <a:latin typeface="Times New Roman"/>
+                <a:cs typeface="Times New Roman"/>
+              </a:rPr>
+              <a:t>: Maintained a clear registration instruction paragraph below the title</a:t>
+            </a:r>
           </a:p>
         </p:txBody>
       </p:sp>
@@ -5125,7 +3924,7 @@
         </p:nvGrpSpPr>
         <p:grpSpPr>
           <a:xfrm>
-            <a:off x="801369" y="2273934"/>
+            <a:off x="757872" y="2237473"/>
             <a:ext cx="6402705" cy="20320"/>
             <a:chOff x="801369" y="2273934"/>
             <a:chExt cx="6402705" cy="20320"/>
@@ -5470,8 +4269,8 @@
         </p:nvSpPr>
         <p:spPr>
           <a:xfrm>
-            <a:off x="789228" y="2532633"/>
-            <a:ext cx="6373495" cy="723900"/>
+            <a:off x="801370" y="2426945"/>
+            <a:ext cx="6373495" cy="1089401"/>
           </a:xfrm>
           <a:prstGeom prst="rect">
             <a:avLst/>
@@ -5506,345 +4305,117 @@
               <a:t> </a:t>
             </a:r>
             <a:r>
-              <a:rPr sz="1300" b="1" dirty="0">
+              <a:rPr sz="1500" b="1" dirty="0">
                 <a:latin typeface="Times New Roman"/>
                 <a:cs typeface="Times New Roman"/>
               </a:rPr>
               <a:t>Design</a:t>
             </a:r>
             <a:r>
-              <a:rPr sz="1300" b="1" spc="-15" dirty="0">
-                <a:latin typeface="Times New Roman"/>
-                <a:cs typeface="Times New Roman"/>
-              </a:rPr>
-              <a:t> </a:t>
-            </a:r>
-            <a:r>
-              <a:rPr sz="1300" b="1" dirty="0">
+              <a:rPr sz="1500" b="1" spc="-15" dirty="0">
+                <a:latin typeface="Times New Roman"/>
+                <a:cs typeface="Times New Roman"/>
+              </a:rPr>
+              <a:t> </a:t>
+            </a:r>
+            <a:r>
+              <a:rPr sz="1500" b="1" dirty="0">
                 <a:latin typeface="Times New Roman"/>
                 <a:cs typeface="Times New Roman"/>
               </a:rPr>
               <a:t>the</a:t>
             </a:r>
             <a:r>
-              <a:rPr sz="1300" b="1" spc="-15" dirty="0">
-                <a:latin typeface="Times New Roman"/>
-                <a:cs typeface="Times New Roman"/>
-              </a:rPr>
-              <a:t> </a:t>
-            </a:r>
-            <a:r>
-              <a:rPr sz="1300" b="1" dirty="0">
+              <a:rPr sz="1500" b="1" spc="-15" dirty="0">
+                <a:latin typeface="Times New Roman"/>
+                <a:cs typeface="Times New Roman"/>
+              </a:rPr>
+              <a:t> </a:t>
+            </a:r>
+            <a:r>
+              <a:rPr sz="1500" b="1" dirty="0">
                 <a:latin typeface="Times New Roman"/>
                 <a:cs typeface="Times New Roman"/>
               </a:rPr>
               <a:t>Event </a:t>
             </a:r>
             <a:r>
-              <a:rPr sz="1300" b="1" spc="-10" dirty="0">
+              <a:rPr sz="1500" b="1" spc="-10" dirty="0">
                 <a:latin typeface="Times New Roman"/>
                 <a:cs typeface="Times New Roman"/>
               </a:rPr>
               <a:t>Information</a:t>
             </a:r>
             <a:r>
-              <a:rPr sz="1300" b="1" spc="-15" dirty="0">
-                <a:latin typeface="Times New Roman"/>
-                <a:cs typeface="Times New Roman"/>
-              </a:rPr>
-              <a:t> </a:t>
-            </a:r>
-            <a:r>
-              <a:rPr sz="1300" b="1" spc="-10" dirty="0">
+              <a:rPr sz="1500" b="1" spc="-15" dirty="0">
+                <a:latin typeface="Times New Roman"/>
+                <a:cs typeface="Times New Roman"/>
+              </a:rPr>
+              <a:t> </a:t>
+            </a:r>
+            <a:r>
+              <a:rPr sz="1500" b="1" spc="-10" dirty="0">
                 <a:latin typeface="Times New Roman"/>
                 <a:cs typeface="Times New Roman"/>
               </a:rPr>
               <a:t>Section</a:t>
             </a:r>
-            <a:endParaRPr sz="1300">
+            <a:endParaRPr sz="1500" dirty="0">
               <a:latin typeface="Times New Roman"/>
               <a:cs typeface="Times New Roman"/>
             </a:endParaRPr>
           </a:p>
           <a:p>
-            <a:pPr marL="20320" marR="5080">
+            <a:pPr marL="306070" marR="5080" indent="-285750">
               <a:lnSpc>
                 <a:spcPts val="1380"/>
               </a:lnSpc>
               <a:spcBef>
                 <a:spcPts val="1215"/>
               </a:spcBef>
+              <a:buFont typeface="Arial" panose="020B0604020202020204" pitchFamily="34" charset="0"/>
+              <a:buChar char="•"/>
             </a:pPr>
             <a:r>
-              <a:rPr sz="1200" dirty="0">
-                <a:latin typeface="Times New Roman"/>
-                <a:cs typeface="Times New Roman"/>
-              </a:rPr>
-              <a:t>(</a:t>
-            </a:r>
-            <a:r>
-              <a:rPr sz="1200" i="1" dirty="0">
-                <a:latin typeface="Times New Roman"/>
-                <a:cs typeface="Times New Roman"/>
-              </a:rPr>
-              <a:t>Improve</a:t>
-            </a:r>
-            <a:r>
-              <a:rPr sz="1200" i="1" spc="-35" dirty="0">
-                <a:latin typeface="Times New Roman"/>
-                <a:cs typeface="Times New Roman"/>
-              </a:rPr>
-              <a:t> </a:t>
-            </a:r>
-            <a:r>
-              <a:rPr sz="1200" i="1" dirty="0">
-                <a:latin typeface="Times New Roman"/>
-                <a:cs typeface="Times New Roman"/>
-              </a:rPr>
-              <a:t>the</a:t>
-            </a:r>
-            <a:r>
-              <a:rPr sz="1200" i="1" spc="-25" dirty="0">
-                <a:latin typeface="Times New Roman"/>
-                <a:cs typeface="Times New Roman"/>
-              </a:rPr>
-              <a:t> </a:t>
-            </a:r>
-            <a:r>
-              <a:rPr sz="1200" i="1" dirty="0">
-                <a:latin typeface="Times New Roman"/>
-                <a:cs typeface="Times New Roman"/>
-              </a:rPr>
-              <a:t>layout</a:t>
-            </a:r>
-            <a:r>
-              <a:rPr sz="1200" i="1" spc="-25" dirty="0">
-                <a:latin typeface="Times New Roman"/>
-                <a:cs typeface="Times New Roman"/>
-              </a:rPr>
-              <a:t> </a:t>
-            </a:r>
-            <a:r>
-              <a:rPr sz="1200" i="1" dirty="0">
-                <a:latin typeface="Times New Roman"/>
-                <a:cs typeface="Times New Roman"/>
-              </a:rPr>
-              <a:t>and</a:t>
-            </a:r>
-            <a:r>
-              <a:rPr sz="1200" i="1" spc="-20" dirty="0">
-                <a:latin typeface="Times New Roman"/>
-                <a:cs typeface="Times New Roman"/>
-              </a:rPr>
-              <a:t> </a:t>
-            </a:r>
-            <a:r>
-              <a:rPr sz="1200" i="1" dirty="0">
-                <a:latin typeface="Times New Roman"/>
-                <a:cs typeface="Times New Roman"/>
-              </a:rPr>
-              <a:t>readability</a:t>
-            </a:r>
-            <a:r>
-              <a:rPr sz="1200" i="1" spc="-30" dirty="0">
-                <a:latin typeface="Times New Roman"/>
-                <a:cs typeface="Times New Roman"/>
-              </a:rPr>
-              <a:t> </a:t>
-            </a:r>
-            <a:r>
-              <a:rPr sz="1200" i="1" dirty="0">
-                <a:latin typeface="Times New Roman"/>
-                <a:cs typeface="Times New Roman"/>
-              </a:rPr>
-              <a:t>of</a:t>
-            </a:r>
-            <a:r>
-              <a:rPr sz="1200" i="1" spc="-25" dirty="0">
-                <a:latin typeface="Times New Roman"/>
-                <a:cs typeface="Times New Roman"/>
-              </a:rPr>
-              <a:t> </a:t>
-            </a:r>
-            <a:r>
-              <a:rPr sz="1200" i="1" dirty="0">
-                <a:latin typeface="Times New Roman"/>
-                <a:cs typeface="Times New Roman"/>
-              </a:rPr>
-              <a:t>the</a:t>
-            </a:r>
-            <a:r>
-              <a:rPr sz="1200" i="1" spc="-30" dirty="0">
-                <a:latin typeface="Times New Roman"/>
-                <a:cs typeface="Times New Roman"/>
-              </a:rPr>
-              <a:t> </a:t>
-            </a:r>
-            <a:r>
-              <a:rPr sz="1200" i="1" dirty="0">
-                <a:latin typeface="Times New Roman"/>
-                <a:cs typeface="Times New Roman"/>
-              </a:rPr>
-              <a:t>event</a:t>
-            </a:r>
-            <a:r>
-              <a:rPr sz="1200" i="1" spc="-25" dirty="0">
-                <a:latin typeface="Times New Roman"/>
-                <a:cs typeface="Times New Roman"/>
-              </a:rPr>
-              <a:t> </a:t>
-            </a:r>
-            <a:r>
-              <a:rPr sz="1200" i="1" dirty="0">
-                <a:latin typeface="Times New Roman"/>
-                <a:cs typeface="Times New Roman"/>
-              </a:rPr>
-              <a:t>details</a:t>
-            </a:r>
-            <a:r>
-              <a:rPr sz="1200" i="1" spc="-35" dirty="0">
-                <a:latin typeface="Times New Roman"/>
-                <a:cs typeface="Times New Roman"/>
-              </a:rPr>
-              <a:t> </a:t>
-            </a:r>
-            <a:r>
-              <a:rPr sz="1200" i="1" dirty="0">
-                <a:latin typeface="Times New Roman"/>
-                <a:cs typeface="Times New Roman"/>
-              </a:rPr>
-              <a:t>section</a:t>
-            </a:r>
-            <a:r>
-              <a:rPr sz="1200" i="1" spc="-25" dirty="0">
-                <a:latin typeface="Times New Roman"/>
-                <a:cs typeface="Times New Roman"/>
-              </a:rPr>
-              <a:t> </a:t>
-            </a:r>
-            <a:r>
-              <a:rPr sz="1200" i="1" dirty="0">
-                <a:latin typeface="Times New Roman"/>
-                <a:cs typeface="Times New Roman"/>
-              </a:rPr>
-              <a:t>by</a:t>
-            </a:r>
-            <a:r>
-              <a:rPr sz="1200" i="1" spc="-30" dirty="0">
-                <a:latin typeface="Times New Roman"/>
-                <a:cs typeface="Times New Roman"/>
-              </a:rPr>
-              <a:t> </a:t>
-            </a:r>
-            <a:r>
-              <a:rPr sz="1200" i="1" dirty="0">
-                <a:latin typeface="Times New Roman"/>
-                <a:cs typeface="Times New Roman"/>
-              </a:rPr>
-              <a:t>adding</a:t>
-            </a:r>
-            <a:r>
-              <a:rPr sz="1200" i="1" spc="-25" dirty="0">
-                <a:latin typeface="Times New Roman"/>
-                <a:cs typeface="Times New Roman"/>
-              </a:rPr>
-              <a:t> </a:t>
-            </a:r>
-            <a:r>
-              <a:rPr sz="1200" i="1" dirty="0">
-                <a:latin typeface="Times New Roman"/>
-                <a:cs typeface="Times New Roman"/>
-              </a:rPr>
-              <a:t>borders,</a:t>
-            </a:r>
-            <a:r>
-              <a:rPr sz="1200" i="1" spc="-30" dirty="0">
-                <a:latin typeface="Times New Roman"/>
-                <a:cs typeface="Times New Roman"/>
-              </a:rPr>
-              <a:t> </a:t>
-            </a:r>
-            <a:r>
-              <a:rPr sz="1200" i="1" dirty="0">
-                <a:latin typeface="Times New Roman"/>
-                <a:cs typeface="Times New Roman"/>
-              </a:rPr>
-              <a:t>spacing,</a:t>
-            </a:r>
-            <a:r>
-              <a:rPr sz="1200" i="1" spc="-25" dirty="0">
-                <a:latin typeface="Times New Roman"/>
-                <a:cs typeface="Times New Roman"/>
-              </a:rPr>
-              <a:t> </a:t>
-            </a:r>
-            <a:r>
-              <a:rPr sz="1200" i="1" spc="-10" dirty="0">
-                <a:latin typeface="Times New Roman"/>
-                <a:cs typeface="Times New Roman"/>
-              </a:rPr>
-              <a:t>background </a:t>
-            </a:r>
-            <a:r>
-              <a:rPr sz="1200" i="1" dirty="0">
-                <a:latin typeface="Times New Roman"/>
-                <a:cs typeface="Times New Roman"/>
-              </a:rPr>
-              <a:t>colors,</a:t>
-            </a:r>
-            <a:r>
-              <a:rPr sz="1200" i="1" spc="-25" dirty="0">
-                <a:latin typeface="Times New Roman"/>
-                <a:cs typeface="Times New Roman"/>
-              </a:rPr>
-              <a:t> </a:t>
-            </a:r>
-            <a:r>
-              <a:rPr sz="1200" i="1" dirty="0">
-                <a:latin typeface="Times New Roman"/>
-                <a:cs typeface="Times New Roman"/>
-              </a:rPr>
-              <a:t>and</a:t>
-            </a:r>
-            <a:r>
-              <a:rPr sz="1200" i="1" spc="-20" dirty="0">
-                <a:latin typeface="Times New Roman"/>
-                <a:cs typeface="Times New Roman"/>
-              </a:rPr>
-              <a:t> </a:t>
-            </a:r>
-            <a:r>
-              <a:rPr sz="1200" i="1" dirty="0">
-                <a:latin typeface="Times New Roman"/>
-                <a:cs typeface="Times New Roman"/>
-              </a:rPr>
-              <a:t>proper</a:t>
-            </a:r>
-            <a:r>
-              <a:rPr sz="1200" i="1" spc="-25" dirty="0">
-                <a:latin typeface="Times New Roman"/>
-                <a:cs typeface="Times New Roman"/>
-              </a:rPr>
-              <a:t> </a:t>
-            </a:r>
-            <a:r>
-              <a:rPr sz="1200" i="1" spc="-10" dirty="0">
-                <a:latin typeface="Times New Roman"/>
-                <a:cs typeface="Times New Roman"/>
-              </a:rPr>
-              <a:t>alignment.</a:t>
-            </a:r>
-            <a:r>
-              <a:rPr sz="1200" spc="-10" dirty="0">
-                <a:latin typeface="Times New Roman"/>
-                <a:cs typeface="Times New Roman"/>
-              </a:rPr>
-              <a:t>)</a:t>
-            </a:r>
-            <a:endParaRPr sz="1200">
-              <a:latin typeface="Times New Roman"/>
-              <a:cs typeface="Times New Roman"/>
-            </a:endParaRPr>
+              <a:rPr lang="en-US" sz="1300" b="1" dirty="0">
+                <a:latin typeface="Times New Roman"/>
+                <a:cs typeface="Times New Roman"/>
+              </a:rPr>
+              <a:t>Alignment:</a:t>
+            </a:r>
+            <a:r>
+              <a:rPr lang="en-US" sz="1300" dirty="0">
+                <a:latin typeface="Times New Roman"/>
+                <a:cs typeface="Times New Roman"/>
+              </a:rPr>
+              <a:t> Centered the information table using margin: 20px auto.</a:t>
+            </a:r>
+          </a:p>
+          <a:p>
+            <a:pPr marL="306070" marR="5080" indent="-285750">
+              <a:lnSpc>
+                <a:spcPts val="1380"/>
+              </a:lnSpc>
+              <a:spcBef>
+                <a:spcPts val="1215"/>
+              </a:spcBef>
+              <a:buFont typeface="Arial" panose="020B0604020202020204" pitchFamily="34" charset="0"/>
+              <a:buChar char="•"/>
+            </a:pPr>
+            <a:r>
+              <a:rPr lang="en-US" sz="1300" b="1" dirty="0">
+                <a:latin typeface="Times New Roman"/>
+                <a:cs typeface="Times New Roman"/>
+              </a:rPr>
+              <a:t>Table Structure:</a:t>
+            </a:r>
+            <a:r>
+              <a:rPr lang="en-US" sz="1300" dirty="0">
+                <a:latin typeface="Times New Roman"/>
+                <a:cs typeface="Times New Roman"/>
+              </a:rPr>
+              <a:t> Applied border-collapse: collapse and added padding to the event data cells.</a:t>
+            </a:r>
           </a:p>
         </p:txBody>
       </p:sp>
@@ -6201,8 +4772,8 @@
         </p:nvSpPr>
         <p:spPr>
           <a:xfrm>
-            <a:off x="789228" y="3915904"/>
-            <a:ext cx="6282690" cy="668020"/>
+            <a:off x="825537" y="3759195"/>
+            <a:ext cx="6282690" cy="1109278"/>
           </a:xfrm>
           <a:prstGeom prst="rect">
             <a:avLst/>
@@ -6223,335 +4794,125 @@
               </a:spcBef>
             </a:pPr>
             <a:r>
-              <a:rPr sz="1300" b="1" dirty="0">
+              <a:rPr sz="1500" b="1" dirty="0">
                 <a:latin typeface="Times New Roman"/>
                 <a:cs typeface="Times New Roman"/>
               </a:rPr>
               <a:t>3.4</a:t>
             </a:r>
             <a:r>
-              <a:rPr sz="1300" b="1" spc="-25" dirty="0">
-                <a:latin typeface="Times New Roman"/>
-                <a:cs typeface="Times New Roman"/>
-              </a:rPr>
-              <a:t> </a:t>
-            </a:r>
-            <a:r>
-              <a:rPr sz="1300" b="1" dirty="0">
+              <a:rPr sz="1500" b="1" spc="-25" dirty="0">
+                <a:latin typeface="Times New Roman"/>
+                <a:cs typeface="Times New Roman"/>
+              </a:rPr>
+              <a:t> </a:t>
+            </a:r>
+            <a:r>
+              <a:rPr sz="1500" b="1" dirty="0">
                 <a:latin typeface="Times New Roman"/>
                 <a:cs typeface="Times New Roman"/>
               </a:rPr>
               <a:t>Enhance</a:t>
             </a:r>
             <a:r>
-              <a:rPr sz="1300" b="1" spc="-25" dirty="0">
-                <a:latin typeface="Times New Roman"/>
-                <a:cs typeface="Times New Roman"/>
-              </a:rPr>
-              <a:t> </a:t>
-            </a:r>
-            <a:r>
-              <a:rPr sz="1300" b="1" dirty="0">
+              <a:rPr sz="1500" b="1" spc="-25" dirty="0">
+                <a:latin typeface="Times New Roman"/>
+                <a:cs typeface="Times New Roman"/>
+              </a:rPr>
+              <a:t> </a:t>
+            </a:r>
+            <a:r>
+              <a:rPr sz="1500" b="1" dirty="0">
                 <a:latin typeface="Times New Roman"/>
                 <a:cs typeface="Times New Roman"/>
               </a:rPr>
               <a:t>the</a:t>
             </a:r>
             <a:r>
-              <a:rPr sz="1300" b="1" spc="-10" dirty="0">
+              <a:rPr sz="1500" b="1" spc="-10" dirty="0">
                 <a:latin typeface="Times New Roman"/>
                 <a:cs typeface="Times New Roman"/>
               </a:rPr>
               <a:t> Registration</a:t>
             </a:r>
             <a:r>
-              <a:rPr sz="1300" b="1" spc="-25" dirty="0">
-                <a:latin typeface="Times New Roman"/>
-                <a:cs typeface="Times New Roman"/>
-              </a:rPr>
-              <a:t> </a:t>
-            </a:r>
-            <a:r>
-              <a:rPr sz="1300" b="1" dirty="0">
+              <a:rPr sz="1500" b="1" spc="-25" dirty="0">
+                <a:latin typeface="Times New Roman"/>
+                <a:cs typeface="Times New Roman"/>
+              </a:rPr>
+              <a:t> </a:t>
+            </a:r>
+            <a:r>
+              <a:rPr sz="1500" b="1" dirty="0">
                 <a:latin typeface="Times New Roman"/>
                 <a:cs typeface="Times New Roman"/>
               </a:rPr>
               <a:t>Form</a:t>
             </a:r>
             <a:r>
-              <a:rPr sz="1300" b="1" spc="-10" dirty="0">
+              <a:rPr sz="1500" b="1" spc="-10" dirty="0">
                 <a:latin typeface="Times New Roman"/>
                 <a:cs typeface="Times New Roman"/>
               </a:rPr>
               <a:t> Layout:</a:t>
             </a:r>
-            <a:endParaRPr sz="1300">
+            <a:endParaRPr sz="1500" dirty="0">
               <a:latin typeface="Times New Roman"/>
               <a:cs typeface="Times New Roman"/>
             </a:endParaRPr>
           </a:p>
           <a:p>
-            <a:pPr marL="109855" marR="5080">
+            <a:pPr marL="281305" marR="5080" indent="-171450">
               <a:lnSpc>
                 <a:spcPts val="1380"/>
               </a:lnSpc>
               <a:spcBef>
                 <a:spcPts val="425"/>
               </a:spcBef>
+              <a:buFont typeface="Arial" panose="020B0604020202020204" pitchFamily="34" charset="0"/>
+              <a:buChar char="•"/>
             </a:pPr>
             <a:r>
-              <a:rPr sz="1200" i="1" dirty="0">
-                <a:latin typeface="Times New Roman"/>
-                <a:cs typeface="Times New Roman"/>
-              </a:rPr>
-              <a:t>(Style</a:t>
-            </a:r>
-            <a:r>
-              <a:rPr sz="1200" i="1" spc="-25" dirty="0">
-                <a:latin typeface="Times New Roman"/>
-                <a:cs typeface="Times New Roman"/>
-              </a:rPr>
-              <a:t> </a:t>
-            </a:r>
-            <a:r>
-              <a:rPr sz="1200" i="1" dirty="0">
-                <a:latin typeface="Times New Roman"/>
-                <a:cs typeface="Times New Roman"/>
-              </a:rPr>
-              <a:t>the</a:t>
-            </a:r>
-            <a:r>
-              <a:rPr sz="1200" i="1" spc="-30" dirty="0">
-                <a:latin typeface="Times New Roman"/>
-                <a:cs typeface="Times New Roman"/>
-              </a:rPr>
-              <a:t> </a:t>
-            </a:r>
-            <a:r>
-              <a:rPr sz="1200" i="1" dirty="0">
-                <a:latin typeface="Times New Roman"/>
-                <a:cs typeface="Times New Roman"/>
-              </a:rPr>
-              <a:t>registration</a:t>
-            </a:r>
-            <a:r>
-              <a:rPr sz="1200" i="1" spc="-20" dirty="0">
-                <a:latin typeface="Times New Roman"/>
-                <a:cs typeface="Times New Roman"/>
-              </a:rPr>
-              <a:t> </a:t>
-            </a:r>
-            <a:r>
-              <a:rPr sz="1200" i="1" dirty="0">
-                <a:latin typeface="Times New Roman"/>
-                <a:cs typeface="Times New Roman"/>
-              </a:rPr>
-              <a:t>form</a:t>
-            </a:r>
-            <a:r>
-              <a:rPr sz="1200" i="1" spc="-30" dirty="0">
-                <a:latin typeface="Times New Roman"/>
-                <a:cs typeface="Times New Roman"/>
-              </a:rPr>
-              <a:t> </a:t>
-            </a:r>
-            <a:r>
-              <a:rPr sz="1200" i="1" dirty="0">
-                <a:latin typeface="Times New Roman"/>
-                <a:cs typeface="Times New Roman"/>
-              </a:rPr>
-              <a:t>using</a:t>
-            </a:r>
-            <a:r>
-              <a:rPr sz="1200" i="1" spc="-20" dirty="0">
-                <a:latin typeface="Times New Roman"/>
-                <a:cs typeface="Times New Roman"/>
-              </a:rPr>
-              <a:t> </a:t>
-            </a:r>
-            <a:r>
-              <a:rPr sz="1200" i="1" dirty="0">
-                <a:latin typeface="Times New Roman"/>
-                <a:cs typeface="Times New Roman"/>
-              </a:rPr>
-              <a:t>a</a:t>
-            </a:r>
-            <a:r>
-              <a:rPr sz="1200" i="1" spc="-25" dirty="0">
-                <a:latin typeface="Times New Roman"/>
-                <a:cs typeface="Times New Roman"/>
-              </a:rPr>
-              <a:t> </a:t>
-            </a:r>
-            <a:r>
-              <a:rPr sz="1200" i="1" dirty="0">
-                <a:latin typeface="Times New Roman"/>
-                <a:cs typeface="Times New Roman"/>
-              </a:rPr>
-              <a:t>card</a:t>
-            </a:r>
-            <a:r>
-              <a:rPr sz="1200" i="1" spc="-20" dirty="0">
-                <a:latin typeface="Times New Roman"/>
-                <a:cs typeface="Times New Roman"/>
-              </a:rPr>
-              <a:t> </a:t>
-            </a:r>
-            <a:r>
-              <a:rPr sz="1200" i="1" dirty="0">
-                <a:latin typeface="Times New Roman"/>
-                <a:cs typeface="Times New Roman"/>
-              </a:rPr>
-              <a:t>layout</a:t>
-            </a:r>
-            <a:r>
-              <a:rPr sz="1200" i="1" spc="-25" dirty="0">
-                <a:latin typeface="Times New Roman"/>
-                <a:cs typeface="Times New Roman"/>
-              </a:rPr>
-              <a:t> </a:t>
-            </a:r>
-            <a:r>
-              <a:rPr sz="1200" i="1" dirty="0">
-                <a:latin typeface="Times New Roman"/>
-                <a:cs typeface="Times New Roman"/>
-              </a:rPr>
-              <a:t>with</a:t>
-            </a:r>
-            <a:r>
-              <a:rPr sz="1200" i="1" spc="-20" dirty="0">
-                <a:latin typeface="Times New Roman"/>
-                <a:cs typeface="Times New Roman"/>
-              </a:rPr>
-              <a:t> </a:t>
-            </a:r>
-            <a:r>
-              <a:rPr sz="1200" i="1" dirty="0">
-                <a:latin typeface="Times New Roman"/>
-                <a:cs typeface="Times New Roman"/>
-              </a:rPr>
-              <a:t>borders,</a:t>
-            </a:r>
-            <a:r>
-              <a:rPr sz="1200" i="1" spc="-25" dirty="0">
-                <a:latin typeface="Times New Roman"/>
-                <a:cs typeface="Times New Roman"/>
-              </a:rPr>
-              <a:t> </a:t>
-            </a:r>
-            <a:r>
-              <a:rPr sz="1200" i="1" dirty="0">
-                <a:latin typeface="Times New Roman"/>
-                <a:cs typeface="Times New Roman"/>
-              </a:rPr>
-              <a:t>padding,</a:t>
-            </a:r>
-            <a:r>
-              <a:rPr sz="1200" i="1" spc="-20" dirty="0">
-                <a:latin typeface="Times New Roman"/>
-                <a:cs typeface="Times New Roman"/>
-              </a:rPr>
-              <a:t> </a:t>
-            </a:r>
-            <a:r>
-              <a:rPr sz="1200" i="1" dirty="0">
-                <a:latin typeface="Times New Roman"/>
-                <a:cs typeface="Times New Roman"/>
-              </a:rPr>
-              <a:t>rounded</a:t>
-            </a:r>
-            <a:r>
-              <a:rPr sz="1200" i="1" spc="-25" dirty="0">
-                <a:latin typeface="Times New Roman"/>
-                <a:cs typeface="Times New Roman"/>
-              </a:rPr>
-              <a:t> </a:t>
-            </a:r>
-            <a:r>
-              <a:rPr sz="1200" i="1" dirty="0">
-                <a:latin typeface="Times New Roman"/>
-                <a:cs typeface="Times New Roman"/>
-              </a:rPr>
-              <a:t>corners,</a:t>
-            </a:r>
-            <a:r>
-              <a:rPr sz="1200" i="1" spc="-25" dirty="0">
-                <a:latin typeface="Times New Roman"/>
-                <a:cs typeface="Times New Roman"/>
-              </a:rPr>
-              <a:t> </a:t>
-            </a:r>
-            <a:r>
-              <a:rPr sz="1200" i="1" dirty="0">
-                <a:latin typeface="Times New Roman"/>
-                <a:cs typeface="Times New Roman"/>
-              </a:rPr>
-              <a:t>and</a:t>
-            </a:r>
-            <a:r>
-              <a:rPr sz="1200" i="1" spc="-20" dirty="0">
-                <a:latin typeface="Times New Roman"/>
-                <a:cs typeface="Times New Roman"/>
-              </a:rPr>
-              <a:t> </a:t>
-            </a:r>
-            <a:r>
-              <a:rPr sz="1200" i="1" spc="-10" dirty="0">
-                <a:latin typeface="Times New Roman"/>
-                <a:cs typeface="Times New Roman"/>
-              </a:rPr>
-              <a:t>shadow </a:t>
-            </a:r>
-            <a:r>
-              <a:rPr sz="1200" i="1" dirty="0">
-                <a:latin typeface="Times New Roman"/>
-                <a:cs typeface="Times New Roman"/>
-              </a:rPr>
-              <a:t>effects</a:t>
-            </a:r>
-            <a:r>
-              <a:rPr sz="1200" i="1" spc="-40" dirty="0">
-                <a:latin typeface="Times New Roman"/>
-                <a:cs typeface="Times New Roman"/>
-              </a:rPr>
-              <a:t> </a:t>
-            </a:r>
-            <a:r>
-              <a:rPr sz="1200" i="1" dirty="0">
-                <a:latin typeface="Times New Roman"/>
-                <a:cs typeface="Times New Roman"/>
-              </a:rPr>
-              <a:t>to</a:t>
-            </a:r>
-            <a:r>
-              <a:rPr sz="1200" i="1" spc="-30" dirty="0">
-                <a:latin typeface="Times New Roman"/>
-                <a:cs typeface="Times New Roman"/>
-              </a:rPr>
-              <a:t> </a:t>
-            </a:r>
-            <a:r>
-              <a:rPr sz="1200" i="1" dirty="0">
-                <a:latin typeface="Times New Roman"/>
-                <a:cs typeface="Times New Roman"/>
-              </a:rPr>
-              <a:t>improve</a:t>
-            </a:r>
-            <a:r>
-              <a:rPr sz="1200" i="1" spc="-40" dirty="0">
-                <a:latin typeface="Times New Roman"/>
-                <a:cs typeface="Times New Roman"/>
-              </a:rPr>
-              <a:t> </a:t>
-            </a:r>
-            <a:r>
-              <a:rPr sz="1200" i="1" spc="-10" dirty="0">
-                <a:latin typeface="Times New Roman"/>
-                <a:cs typeface="Times New Roman"/>
-              </a:rPr>
-              <a:t>presentation.)</a:t>
-            </a:r>
-            <a:endParaRPr sz="1200">
+              <a:rPr lang="en-US" sz="1300" b="1" dirty="0">
+                <a:latin typeface="Times New Roman"/>
+                <a:cs typeface="Times New Roman"/>
+              </a:rPr>
+              <a:t>Card Layout:</a:t>
+            </a:r>
+            <a:r>
+              <a:rPr lang="en-US" sz="1300" dirty="0">
+                <a:latin typeface="Times New Roman"/>
+                <a:cs typeface="Times New Roman"/>
+              </a:rPr>
+              <a:t> Placed the form in a centered container with a white background and 10px rounded corners.</a:t>
+            </a:r>
+          </a:p>
+          <a:p>
+            <a:pPr marL="281305" marR="5080" indent="-171450">
+              <a:lnSpc>
+                <a:spcPts val="1380"/>
+              </a:lnSpc>
+              <a:spcBef>
+                <a:spcPts val="425"/>
+              </a:spcBef>
+              <a:buFont typeface="Arial" panose="020B0604020202020204" pitchFamily="34" charset="0"/>
+              <a:buChar char="•"/>
+            </a:pPr>
+            <a:r>
+              <a:rPr lang="en-US" sz="1300" b="1" dirty="0">
+                <a:latin typeface="Times New Roman"/>
+                <a:cs typeface="Times New Roman"/>
+              </a:rPr>
+              <a:t>Visual Depth:</a:t>
+            </a:r>
+            <a:r>
+              <a:rPr lang="en-US" sz="1300" dirty="0">
+                <a:latin typeface="Times New Roman"/>
+                <a:cs typeface="Times New Roman"/>
+              </a:rPr>
+              <a:t> Added a light box-shadow to make the form stand out from the background.</a:t>
+            </a:r>
+            <a:endParaRPr sz="1300" dirty="0">
               <a:latin typeface="Times New Roman"/>
               <a:cs typeface="Times New Roman"/>
             </a:endParaRPr>
@@ -6566,7 +4927,7 @@
         </p:nvGrpSpPr>
         <p:grpSpPr>
           <a:xfrm>
-            <a:off x="801369" y="5018404"/>
+            <a:off x="801370" y="4981168"/>
             <a:ext cx="6402705" cy="20955"/>
             <a:chOff x="801369" y="5018404"/>
             <a:chExt cx="6402705" cy="20955"/>
@@ -6911,8 +5272,8 @@
         </p:nvSpPr>
         <p:spPr>
           <a:xfrm>
-            <a:off x="796848" y="5174106"/>
-            <a:ext cx="6315710" cy="699770"/>
+            <a:off x="801370" y="5139865"/>
+            <a:ext cx="6315710" cy="858568"/>
           </a:xfrm>
           <a:prstGeom prst="rect">
             <a:avLst/>
@@ -6933,307 +5294,139 @@
               </a:spcBef>
             </a:pPr>
             <a:r>
-              <a:rPr sz="1300" b="1" dirty="0">
+              <a:rPr sz="1500" b="1" dirty="0">
                 <a:latin typeface="Times New Roman"/>
                 <a:cs typeface="Times New Roman"/>
               </a:rPr>
               <a:t>3.5</a:t>
             </a:r>
             <a:r>
-              <a:rPr sz="1300" b="1" spc="-35" dirty="0">
-                <a:latin typeface="Times New Roman"/>
-                <a:cs typeface="Times New Roman"/>
-              </a:rPr>
-              <a:t> </a:t>
-            </a:r>
-            <a:r>
-              <a:rPr sz="1300" b="1" dirty="0">
+              <a:rPr sz="1500" b="1" spc="-35" dirty="0">
+                <a:latin typeface="Times New Roman"/>
+                <a:cs typeface="Times New Roman"/>
+              </a:rPr>
+              <a:t> </a:t>
+            </a:r>
+            <a:r>
+              <a:rPr sz="1500" b="1" dirty="0">
                 <a:latin typeface="Times New Roman"/>
                 <a:cs typeface="Times New Roman"/>
               </a:rPr>
               <a:t>Style</a:t>
             </a:r>
             <a:r>
-              <a:rPr sz="1300" b="1" spc="-30" dirty="0">
-                <a:latin typeface="Times New Roman"/>
-                <a:cs typeface="Times New Roman"/>
-              </a:rPr>
-              <a:t> </a:t>
-            </a:r>
-            <a:r>
-              <a:rPr sz="1300" b="1" dirty="0">
+              <a:rPr sz="1500" b="1" spc="-30" dirty="0">
+                <a:latin typeface="Times New Roman"/>
+                <a:cs typeface="Times New Roman"/>
+              </a:rPr>
+              <a:t> </a:t>
+            </a:r>
+            <a:r>
+              <a:rPr sz="1500" b="1" dirty="0">
                 <a:latin typeface="Times New Roman"/>
                 <a:cs typeface="Times New Roman"/>
               </a:rPr>
               <a:t>Fieldsets</a:t>
             </a:r>
             <a:r>
-              <a:rPr sz="1300" b="1" spc="-30" dirty="0">
-                <a:latin typeface="Times New Roman"/>
-                <a:cs typeface="Times New Roman"/>
-              </a:rPr>
-              <a:t> </a:t>
-            </a:r>
-            <a:r>
-              <a:rPr sz="1300" b="1" dirty="0">
+              <a:rPr sz="1500" b="1" spc="-30" dirty="0">
+                <a:latin typeface="Times New Roman"/>
+                <a:cs typeface="Times New Roman"/>
+              </a:rPr>
+              <a:t> </a:t>
+            </a:r>
+            <a:r>
+              <a:rPr sz="1500" b="1" dirty="0">
                 <a:latin typeface="Times New Roman"/>
                 <a:cs typeface="Times New Roman"/>
               </a:rPr>
               <a:t>and</a:t>
             </a:r>
             <a:r>
-              <a:rPr sz="1300" b="1" spc="-25" dirty="0">
-                <a:latin typeface="Times New Roman"/>
-                <a:cs typeface="Times New Roman"/>
-              </a:rPr>
-              <a:t> </a:t>
-            </a:r>
-            <a:r>
-              <a:rPr sz="1300" b="1" spc="-10" dirty="0">
+              <a:rPr sz="1500" b="1" spc="-25" dirty="0">
+                <a:latin typeface="Times New Roman"/>
+                <a:cs typeface="Times New Roman"/>
+              </a:rPr>
+              <a:t> </a:t>
+            </a:r>
+            <a:r>
+              <a:rPr sz="1500" b="1" spc="-10" dirty="0">
                 <a:latin typeface="Times New Roman"/>
                 <a:cs typeface="Times New Roman"/>
               </a:rPr>
               <a:t>Legends:</a:t>
             </a:r>
-            <a:endParaRPr sz="1300">
+            <a:endParaRPr sz="1500" dirty="0">
               <a:latin typeface="Times New Roman"/>
               <a:cs typeface="Times New Roman"/>
             </a:endParaRPr>
           </a:p>
           <a:p>
-            <a:pPr marL="102235" marR="5080">
+            <a:pPr marL="273685" marR="5080" indent="-171450">
               <a:lnSpc>
                 <a:spcPts val="1380"/>
               </a:lnSpc>
               <a:spcBef>
                 <a:spcPts val="1025"/>
               </a:spcBef>
+              <a:buFont typeface="Arial" panose="020B0604020202020204" pitchFamily="34" charset="0"/>
+              <a:buChar char="•"/>
             </a:pPr>
             <a:r>
-              <a:rPr sz="1200" i="1" dirty="0">
-                <a:latin typeface="Times New Roman"/>
-                <a:cs typeface="Times New Roman"/>
-              </a:rPr>
-              <a:t>(Improve</a:t>
-            </a:r>
-            <a:r>
-              <a:rPr sz="1200" i="1" spc="-35" dirty="0">
-                <a:latin typeface="Times New Roman"/>
-                <a:cs typeface="Times New Roman"/>
-              </a:rPr>
-              <a:t> </a:t>
-            </a:r>
-            <a:r>
-              <a:rPr sz="1200" i="1" dirty="0">
-                <a:latin typeface="Times New Roman"/>
-                <a:cs typeface="Times New Roman"/>
-              </a:rPr>
-              <a:t>the</a:t>
-            </a:r>
-            <a:r>
-              <a:rPr sz="1200" i="1" spc="-25" dirty="0">
-                <a:latin typeface="Times New Roman"/>
-                <a:cs typeface="Times New Roman"/>
-              </a:rPr>
-              <a:t> </a:t>
-            </a:r>
-            <a:r>
-              <a:rPr sz="1200" i="1" dirty="0">
-                <a:latin typeface="Times New Roman"/>
-                <a:cs typeface="Times New Roman"/>
-              </a:rPr>
-              <a:t>appearance</a:t>
-            </a:r>
-            <a:r>
-              <a:rPr sz="1200" i="1" spc="-20" dirty="0">
-                <a:latin typeface="Times New Roman"/>
-                <a:cs typeface="Times New Roman"/>
-              </a:rPr>
-              <a:t> </a:t>
-            </a:r>
-            <a:r>
-              <a:rPr sz="1200" i="1" dirty="0">
-                <a:latin typeface="Times New Roman"/>
-                <a:cs typeface="Times New Roman"/>
-              </a:rPr>
-              <a:t>of</a:t>
-            </a:r>
-            <a:r>
-              <a:rPr sz="1200" i="1" spc="-25" dirty="0">
-                <a:latin typeface="Times New Roman"/>
-                <a:cs typeface="Times New Roman"/>
-              </a:rPr>
-              <a:t> </a:t>
-            </a:r>
-            <a:r>
-              <a:rPr sz="1200" i="1" dirty="0">
+              <a:rPr lang="en-US" sz="1300" b="1" dirty="0">
+                <a:latin typeface="Times New Roman"/>
+                <a:cs typeface="Times New Roman"/>
+              </a:rPr>
+              <a:t>Structure:</a:t>
+            </a:r>
+            <a:r>
+              <a:rPr lang="en-US" sz="1300" dirty="0">
+                <a:latin typeface="Times New Roman"/>
+                <a:cs typeface="Times New Roman"/>
+              </a:rPr>
+              <a:t> Applied light gray borders (#ddd) and internal padding to all </a:t>
+            </a:r>
+            <a:r>
+              <a:rPr lang="en-US" sz="1300" dirty="0" err="1">
                 <a:latin typeface="Times New Roman"/>
                 <a:cs typeface="Times New Roman"/>
               </a:rPr>
               <a:t>fieldsets</a:t>
             </a:r>
             <a:r>
-              <a:rPr sz="1200" i="1" spc="-30" dirty="0">
-                <a:latin typeface="Times New Roman"/>
-                <a:cs typeface="Times New Roman"/>
-              </a:rPr>
-              <a:t> </a:t>
-            </a:r>
-            <a:r>
-              <a:rPr sz="1200" i="1" dirty="0">
-                <a:latin typeface="Times New Roman"/>
-                <a:cs typeface="Times New Roman"/>
-              </a:rPr>
-              <a:t>and</a:t>
-            </a:r>
-            <a:r>
-              <a:rPr sz="1200" i="1" spc="-25" dirty="0">
-                <a:latin typeface="Times New Roman"/>
-                <a:cs typeface="Times New Roman"/>
-              </a:rPr>
-              <a:t> </a:t>
-            </a:r>
-            <a:r>
-              <a:rPr sz="1200" i="1" dirty="0">
-                <a:latin typeface="Times New Roman"/>
-                <a:cs typeface="Times New Roman"/>
-              </a:rPr>
-              <a:t>legends</a:t>
-            </a:r>
-            <a:r>
-              <a:rPr sz="1200" i="1" spc="-30" dirty="0">
-                <a:latin typeface="Times New Roman"/>
-                <a:cs typeface="Times New Roman"/>
-              </a:rPr>
-              <a:t> </a:t>
-            </a:r>
-            <a:r>
-              <a:rPr sz="1200" i="1" dirty="0">
-                <a:latin typeface="Times New Roman"/>
-                <a:cs typeface="Times New Roman"/>
-              </a:rPr>
-              <a:t>by</a:t>
-            </a:r>
-            <a:r>
-              <a:rPr sz="1200" i="1" spc="-30" dirty="0">
-                <a:latin typeface="Times New Roman"/>
-                <a:cs typeface="Times New Roman"/>
-              </a:rPr>
-              <a:t> </a:t>
-            </a:r>
-            <a:r>
-              <a:rPr sz="1200" i="1" dirty="0">
-                <a:latin typeface="Times New Roman"/>
-                <a:cs typeface="Times New Roman"/>
-              </a:rPr>
-              <a:t>adding</a:t>
-            </a:r>
-            <a:r>
-              <a:rPr sz="1200" i="1" spc="-25" dirty="0">
-                <a:latin typeface="Times New Roman"/>
-                <a:cs typeface="Times New Roman"/>
-              </a:rPr>
-              <a:t> </a:t>
-            </a:r>
-            <a:r>
-              <a:rPr sz="1200" i="1" dirty="0">
-                <a:latin typeface="Times New Roman"/>
-                <a:cs typeface="Times New Roman"/>
-              </a:rPr>
-              <a:t>borders,</a:t>
-            </a:r>
-            <a:r>
-              <a:rPr sz="1200" i="1" spc="-30" dirty="0">
-                <a:latin typeface="Times New Roman"/>
-                <a:cs typeface="Times New Roman"/>
-              </a:rPr>
-              <a:t> </a:t>
-            </a:r>
-            <a:r>
-              <a:rPr sz="1200" i="1" dirty="0">
-                <a:latin typeface="Times New Roman"/>
-                <a:cs typeface="Times New Roman"/>
-              </a:rPr>
-              <a:t>spacing,</a:t>
-            </a:r>
-            <a:r>
-              <a:rPr sz="1200" i="1" spc="-25" dirty="0">
-                <a:latin typeface="Times New Roman"/>
-                <a:cs typeface="Times New Roman"/>
-              </a:rPr>
-              <a:t> </a:t>
-            </a:r>
-            <a:r>
-              <a:rPr sz="1200" i="1" dirty="0">
-                <a:latin typeface="Times New Roman"/>
-                <a:cs typeface="Times New Roman"/>
-              </a:rPr>
-              <a:t>background</a:t>
-            </a:r>
-            <a:r>
-              <a:rPr sz="1200" i="1" spc="-25" dirty="0">
-                <a:latin typeface="Times New Roman"/>
-                <a:cs typeface="Times New Roman"/>
-              </a:rPr>
-              <a:t> </a:t>
-            </a:r>
-            <a:r>
-              <a:rPr sz="1200" i="1" spc="-10" dirty="0">
-                <a:latin typeface="Times New Roman"/>
-                <a:cs typeface="Times New Roman"/>
-              </a:rPr>
-              <a:t>highlights, </a:t>
-            </a:r>
-            <a:r>
-              <a:rPr sz="1200" i="1" dirty="0">
-                <a:latin typeface="Times New Roman"/>
-                <a:cs typeface="Times New Roman"/>
-              </a:rPr>
-              <a:t>and</a:t>
-            </a:r>
-            <a:r>
-              <a:rPr sz="1200" i="1" spc="-20" dirty="0">
-                <a:latin typeface="Times New Roman"/>
-                <a:cs typeface="Times New Roman"/>
-              </a:rPr>
-              <a:t> </a:t>
-            </a:r>
-            <a:r>
-              <a:rPr sz="1200" i="1" dirty="0">
-                <a:latin typeface="Times New Roman"/>
-                <a:cs typeface="Times New Roman"/>
-              </a:rPr>
-              <a:t>bold</a:t>
-            </a:r>
-            <a:r>
-              <a:rPr sz="1200" i="1" spc="-20" dirty="0">
-                <a:latin typeface="Times New Roman"/>
-                <a:cs typeface="Times New Roman"/>
-              </a:rPr>
-              <a:t> </a:t>
-            </a:r>
-            <a:r>
-              <a:rPr sz="1200" i="1" dirty="0">
-                <a:latin typeface="Times New Roman"/>
-                <a:cs typeface="Times New Roman"/>
-              </a:rPr>
-              <a:t>text</a:t>
-            </a:r>
-            <a:r>
-              <a:rPr sz="1200" i="1" spc="-20" dirty="0">
-                <a:latin typeface="Times New Roman"/>
-                <a:cs typeface="Times New Roman"/>
-              </a:rPr>
-              <a:t> </a:t>
-            </a:r>
-            <a:r>
-              <a:rPr sz="1200" i="1" spc="-10" dirty="0">
-                <a:latin typeface="Times New Roman"/>
-                <a:cs typeface="Times New Roman"/>
-              </a:rPr>
-              <a:t>styling.)</a:t>
-            </a:r>
-            <a:endParaRPr sz="1200">
+              <a:rPr lang="en-US" sz="1300" dirty="0">
+                <a:latin typeface="Times New Roman"/>
+                <a:cs typeface="Times New Roman"/>
+              </a:rPr>
+              <a:t>.</a:t>
+            </a:r>
+          </a:p>
+          <a:p>
+            <a:pPr marL="273685" marR="5080" indent="-171450">
+              <a:lnSpc>
+                <a:spcPts val="1380"/>
+              </a:lnSpc>
+              <a:spcBef>
+                <a:spcPts val="1025"/>
+              </a:spcBef>
+              <a:buFont typeface="Arial" panose="020B0604020202020204" pitchFamily="34" charset="0"/>
+              <a:buChar char="•"/>
+            </a:pPr>
+            <a:r>
+              <a:rPr lang="en-US" sz="1300" b="1" dirty="0">
+                <a:latin typeface="Times New Roman"/>
+                <a:cs typeface="Times New Roman"/>
+              </a:rPr>
+              <a:t>Text Styling</a:t>
+            </a:r>
+            <a:r>
+              <a:rPr lang="en-US" sz="1300" dirty="0">
+                <a:latin typeface="Times New Roman"/>
+                <a:cs typeface="Times New Roman"/>
+              </a:rPr>
+              <a:t>: Set the legends to bold to clearly identify each form section.</a:t>
+            </a:r>
+            <a:endParaRPr sz="1300" dirty="0">
               <a:latin typeface="Times New Roman"/>
               <a:cs typeface="Times New Roman"/>
             </a:endParaRPr>
@@ -7593,8 +5786,8 @@
         </p:nvSpPr>
         <p:spPr>
           <a:xfrm>
-            <a:off x="773988" y="6497192"/>
-            <a:ext cx="6221095" cy="701040"/>
+            <a:off x="736587" y="6558285"/>
+            <a:ext cx="6221095" cy="1038105"/>
           </a:xfrm>
           <a:prstGeom prst="rect">
             <a:avLst/>
@@ -7615,356 +5808,111 @@
               </a:spcBef>
             </a:pPr>
             <a:r>
-              <a:rPr sz="1300" b="1" dirty="0">
+              <a:rPr sz="1500" b="1" dirty="0">
                 <a:latin typeface="Times New Roman"/>
                 <a:cs typeface="Times New Roman"/>
               </a:rPr>
               <a:t>3.6</a:t>
             </a:r>
             <a:r>
-              <a:rPr sz="1300" b="1" spc="-30" dirty="0">
-                <a:latin typeface="Times New Roman"/>
-                <a:cs typeface="Times New Roman"/>
-              </a:rPr>
-              <a:t> </a:t>
-            </a:r>
-            <a:r>
-              <a:rPr sz="1300" b="1" dirty="0">
+              <a:rPr sz="1500" b="1" spc="-30" dirty="0">
+                <a:latin typeface="Times New Roman"/>
+                <a:cs typeface="Times New Roman"/>
+              </a:rPr>
+              <a:t> </a:t>
+            </a:r>
+            <a:r>
+              <a:rPr sz="1500" b="1" dirty="0">
                 <a:latin typeface="Times New Roman"/>
                 <a:cs typeface="Times New Roman"/>
               </a:rPr>
               <a:t>Improve</a:t>
             </a:r>
             <a:r>
-              <a:rPr sz="1300" b="1" spc="-30" dirty="0">
-                <a:latin typeface="Times New Roman"/>
-                <a:cs typeface="Times New Roman"/>
-              </a:rPr>
-              <a:t> </a:t>
-            </a:r>
-            <a:r>
-              <a:rPr sz="1300" b="1" dirty="0">
+              <a:rPr sz="1500" b="1" spc="-30" dirty="0">
+                <a:latin typeface="Times New Roman"/>
+                <a:cs typeface="Times New Roman"/>
+              </a:rPr>
+              <a:t> </a:t>
+            </a:r>
+            <a:r>
+              <a:rPr sz="1500" b="1" dirty="0">
                 <a:latin typeface="Times New Roman"/>
                 <a:cs typeface="Times New Roman"/>
               </a:rPr>
               <a:t>Input</a:t>
             </a:r>
             <a:r>
-              <a:rPr sz="1300" b="1" spc="-15" dirty="0">
-                <a:latin typeface="Times New Roman"/>
-                <a:cs typeface="Times New Roman"/>
-              </a:rPr>
-              <a:t> </a:t>
-            </a:r>
-            <a:r>
-              <a:rPr sz="1300" b="1" spc="-10" dirty="0">
+              <a:rPr sz="1500" b="1" spc="-15" dirty="0">
+                <a:latin typeface="Times New Roman"/>
+                <a:cs typeface="Times New Roman"/>
+              </a:rPr>
+              <a:t> </a:t>
+            </a:r>
+            <a:r>
+              <a:rPr sz="1500" b="1" spc="-10" dirty="0">
                 <a:latin typeface="Times New Roman"/>
                 <a:cs typeface="Times New Roman"/>
               </a:rPr>
               <a:t>Elements:</a:t>
             </a:r>
-            <a:endParaRPr sz="1300">
+            <a:endParaRPr sz="1500" dirty="0">
               <a:latin typeface="Times New Roman"/>
               <a:cs typeface="Times New Roman"/>
             </a:endParaRPr>
           </a:p>
           <a:p>
-            <a:pPr marL="125095" marR="5080">
+            <a:pPr marL="296545" marR="5080" indent="-171450">
               <a:lnSpc>
                 <a:spcPts val="1380"/>
               </a:lnSpc>
               <a:spcBef>
                 <a:spcPts val="1035"/>
               </a:spcBef>
+              <a:buFont typeface="Arial" panose="020B0604020202020204" pitchFamily="34" charset="0"/>
+              <a:buChar char="•"/>
             </a:pPr>
             <a:r>
-              <a:rPr sz="1200" i="1" dirty="0">
-                <a:latin typeface="Times New Roman"/>
-                <a:cs typeface="Times New Roman"/>
-              </a:rPr>
-              <a:t>(Apply</a:t>
-            </a:r>
-            <a:r>
-              <a:rPr sz="1200" i="1" spc="-30" dirty="0">
-                <a:latin typeface="Times New Roman"/>
-                <a:cs typeface="Times New Roman"/>
-              </a:rPr>
-              <a:t> </a:t>
-            </a:r>
-            <a:r>
-              <a:rPr sz="1200" i="1" dirty="0">
-                <a:latin typeface="Times New Roman"/>
-                <a:cs typeface="Times New Roman"/>
-              </a:rPr>
-              <a:t>consistent</a:t>
-            </a:r>
-            <a:r>
-              <a:rPr sz="1200" i="1" spc="-30" dirty="0">
-                <a:latin typeface="Times New Roman"/>
-                <a:cs typeface="Times New Roman"/>
-              </a:rPr>
-              <a:t> </a:t>
-            </a:r>
-            <a:r>
-              <a:rPr sz="1200" i="1" dirty="0">
-                <a:latin typeface="Times New Roman"/>
-                <a:cs typeface="Times New Roman"/>
-              </a:rPr>
-              <a:t>styling</a:t>
-            </a:r>
-            <a:r>
-              <a:rPr sz="1200" i="1" spc="-25" dirty="0">
-                <a:latin typeface="Times New Roman"/>
-                <a:cs typeface="Times New Roman"/>
-              </a:rPr>
-              <a:t> </a:t>
-            </a:r>
-            <a:r>
-              <a:rPr sz="1200" i="1" dirty="0">
-                <a:latin typeface="Times New Roman"/>
-                <a:cs typeface="Times New Roman"/>
-              </a:rPr>
-              <a:t>to</a:t>
-            </a:r>
-            <a:r>
-              <a:rPr sz="1200" i="1" spc="-30" dirty="0">
-                <a:latin typeface="Times New Roman"/>
-                <a:cs typeface="Times New Roman"/>
-              </a:rPr>
-              <a:t> </a:t>
-            </a:r>
-            <a:r>
-              <a:rPr sz="1200" i="1" dirty="0">
-                <a:latin typeface="Times New Roman"/>
-                <a:cs typeface="Times New Roman"/>
-              </a:rPr>
-              <a:t>textboxes,</a:t>
-            </a:r>
-            <a:r>
-              <a:rPr sz="1200" i="1" spc="-25" dirty="0">
-                <a:latin typeface="Times New Roman"/>
-                <a:cs typeface="Times New Roman"/>
-              </a:rPr>
-              <a:t> </a:t>
-            </a:r>
-            <a:r>
-              <a:rPr sz="1200" i="1" dirty="0">
-                <a:latin typeface="Times New Roman"/>
-                <a:cs typeface="Times New Roman"/>
-              </a:rPr>
-              <a:t>dropdowns,</a:t>
-            </a:r>
-            <a:r>
-              <a:rPr sz="1200" i="1" spc="-30" dirty="0">
-                <a:latin typeface="Times New Roman"/>
-                <a:cs typeface="Times New Roman"/>
-              </a:rPr>
-              <a:t> </a:t>
-            </a:r>
-            <a:r>
-              <a:rPr sz="1200" i="1" dirty="0">
-                <a:latin typeface="Times New Roman"/>
-                <a:cs typeface="Times New Roman"/>
-              </a:rPr>
-              <a:t>radio</a:t>
-            </a:r>
-            <a:r>
-              <a:rPr sz="1200" i="1" spc="-30" dirty="0">
-                <a:latin typeface="Times New Roman"/>
-                <a:cs typeface="Times New Roman"/>
-              </a:rPr>
-              <a:t> </a:t>
-            </a:r>
-            <a:r>
-              <a:rPr sz="1200" i="1" dirty="0">
-                <a:latin typeface="Times New Roman"/>
-                <a:cs typeface="Times New Roman"/>
-              </a:rPr>
-              <a:t>buttons,</a:t>
-            </a:r>
-            <a:r>
-              <a:rPr sz="1200" i="1" spc="-25" dirty="0">
-                <a:latin typeface="Times New Roman"/>
-                <a:cs typeface="Times New Roman"/>
-              </a:rPr>
-              <a:t> </a:t>
-            </a:r>
-            <a:r>
-              <a:rPr sz="1200" i="1" dirty="0">
-                <a:latin typeface="Times New Roman"/>
-                <a:cs typeface="Times New Roman"/>
-              </a:rPr>
-              <a:t>checkboxes,</a:t>
-            </a:r>
-            <a:r>
-              <a:rPr sz="1200" i="1" spc="-30" dirty="0">
-                <a:latin typeface="Times New Roman"/>
-                <a:cs typeface="Times New Roman"/>
-              </a:rPr>
-              <a:t> </a:t>
-            </a:r>
-            <a:r>
-              <a:rPr sz="1200" i="1" dirty="0">
-                <a:latin typeface="Times New Roman"/>
-                <a:cs typeface="Times New Roman"/>
-              </a:rPr>
-              <a:t>file</a:t>
-            </a:r>
-            <a:r>
-              <a:rPr sz="1200" i="1" spc="-25" dirty="0">
-                <a:latin typeface="Times New Roman"/>
-                <a:cs typeface="Times New Roman"/>
-              </a:rPr>
-              <a:t> </a:t>
-            </a:r>
-            <a:r>
-              <a:rPr sz="1200" i="1" dirty="0">
-                <a:latin typeface="Times New Roman"/>
-                <a:cs typeface="Times New Roman"/>
-              </a:rPr>
-              <a:t>upload</a:t>
-            </a:r>
-            <a:r>
-              <a:rPr sz="1200" i="1" spc="-30" dirty="0">
-                <a:latin typeface="Times New Roman"/>
-                <a:cs typeface="Times New Roman"/>
-              </a:rPr>
-              <a:t> </a:t>
-            </a:r>
-            <a:r>
-              <a:rPr sz="1200" i="1" dirty="0">
-                <a:latin typeface="Times New Roman"/>
-                <a:cs typeface="Times New Roman"/>
-              </a:rPr>
-              <a:t>fields,</a:t>
-            </a:r>
-            <a:r>
-              <a:rPr sz="1200" i="1" spc="-25" dirty="0">
-                <a:latin typeface="Times New Roman"/>
-                <a:cs typeface="Times New Roman"/>
-              </a:rPr>
-              <a:t> and </a:t>
-            </a:r>
-            <a:r>
-              <a:rPr sz="1200" i="1" dirty="0">
-                <a:latin typeface="Times New Roman"/>
-                <a:cs typeface="Times New Roman"/>
-              </a:rPr>
-              <a:t>textarea</a:t>
-            </a:r>
-            <a:r>
-              <a:rPr sz="1200" i="1" spc="-35" dirty="0">
-                <a:latin typeface="Times New Roman"/>
-                <a:cs typeface="Times New Roman"/>
-              </a:rPr>
-              <a:t> </a:t>
-            </a:r>
-            <a:r>
-              <a:rPr sz="1200" i="1" dirty="0">
-                <a:latin typeface="Times New Roman"/>
-                <a:cs typeface="Times New Roman"/>
-              </a:rPr>
-              <a:t>elements.</a:t>
-            </a:r>
-            <a:r>
-              <a:rPr sz="1200" i="1" spc="-30" dirty="0">
-                <a:latin typeface="Times New Roman"/>
-                <a:cs typeface="Times New Roman"/>
-              </a:rPr>
-              <a:t> </a:t>
-            </a:r>
-            <a:r>
-              <a:rPr sz="1200" i="1" dirty="0">
-                <a:latin typeface="Times New Roman"/>
-                <a:cs typeface="Times New Roman"/>
-              </a:rPr>
-              <a:t>Add</a:t>
-            </a:r>
-            <a:r>
-              <a:rPr sz="1200" i="1" spc="-35" dirty="0">
-                <a:latin typeface="Times New Roman"/>
-                <a:cs typeface="Times New Roman"/>
-              </a:rPr>
-              <a:t> </a:t>
-            </a:r>
-            <a:r>
-              <a:rPr sz="1200" i="1" dirty="0">
-                <a:latin typeface="Times New Roman"/>
-                <a:cs typeface="Times New Roman"/>
-              </a:rPr>
-              <a:t>focus</a:t>
-            </a:r>
-            <a:r>
-              <a:rPr sz="1200" i="1" spc="-35" dirty="0">
-                <a:latin typeface="Times New Roman"/>
-                <a:cs typeface="Times New Roman"/>
-              </a:rPr>
-              <a:t> </a:t>
-            </a:r>
-            <a:r>
-              <a:rPr sz="1200" i="1" dirty="0">
-                <a:latin typeface="Times New Roman"/>
-                <a:cs typeface="Times New Roman"/>
-              </a:rPr>
-              <a:t>effects</a:t>
-            </a:r>
-            <a:r>
-              <a:rPr sz="1200" i="1" spc="-40" dirty="0">
-                <a:latin typeface="Times New Roman"/>
-                <a:cs typeface="Times New Roman"/>
-              </a:rPr>
-              <a:t> </a:t>
-            </a:r>
-            <a:r>
-              <a:rPr sz="1200" i="1" dirty="0">
-                <a:latin typeface="Times New Roman"/>
-                <a:cs typeface="Times New Roman"/>
-              </a:rPr>
-              <a:t>for</a:t>
-            </a:r>
-            <a:r>
-              <a:rPr sz="1200" i="1" spc="-35" dirty="0">
-                <a:latin typeface="Times New Roman"/>
-                <a:cs typeface="Times New Roman"/>
-              </a:rPr>
-              <a:t> </a:t>
-            </a:r>
-            <a:r>
-              <a:rPr sz="1200" i="1" dirty="0">
-                <a:latin typeface="Times New Roman"/>
-                <a:cs typeface="Times New Roman"/>
-              </a:rPr>
-              <a:t>better</a:t>
-            </a:r>
-            <a:r>
-              <a:rPr sz="1200" i="1" spc="-35" dirty="0">
-                <a:latin typeface="Times New Roman"/>
-                <a:cs typeface="Times New Roman"/>
-              </a:rPr>
-              <a:t> </a:t>
-            </a:r>
-            <a:r>
-              <a:rPr sz="1200" i="1" dirty="0">
-                <a:latin typeface="Times New Roman"/>
-                <a:cs typeface="Times New Roman"/>
-              </a:rPr>
-              <a:t>user</a:t>
-            </a:r>
-            <a:r>
-              <a:rPr sz="1200" i="1" spc="-30" dirty="0">
-                <a:latin typeface="Times New Roman"/>
-                <a:cs typeface="Times New Roman"/>
-              </a:rPr>
-              <a:t> </a:t>
-            </a:r>
-            <a:r>
-              <a:rPr sz="1200" i="1" spc="-10" dirty="0">
-                <a:latin typeface="Times New Roman"/>
-                <a:cs typeface="Times New Roman"/>
-              </a:rPr>
-              <a:t>interaction.)</a:t>
-            </a:r>
-            <a:endParaRPr sz="1200">
+              <a:rPr lang="en-US" sz="1300" b="1" dirty="0">
+                <a:latin typeface="Times New Roman"/>
+                <a:cs typeface="Times New Roman"/>
+              </a:rPr>
+              <a:t>Consistency</a:t>
+            </a:r>
+            <a:r>
+              <a:rPr lang="en-US" sz="1300" dirty="0">
+                <a:latin typeface="Times New Roman"/>
+                <a:cs typeface="Times New Roman"/>
+              </a:rPr>
+              <a:t>: Removed default input lines and ensured inputs have uniform width within the form.</a:t>
+            </a:r>
+          </a:p>
+          <a:p>
+            <a:pPr marL="296545" marR="5080" indent="-171450">
+              <a:lnSpc>
+                <a:spcPts val="1380"/>
+              </a:lnSpc>
+              <a:spcBef>
+                <a:spcPts val="1035"/>
+              </a:spcBef>
+              <a:buFont typeface="Arial" panose="020B0604020202020204" pitchFamily="34" charset="0"/>
+              <a:buChar char="•"/>
+            </a:pPr>
+            <a:r>
+              <a:rPr lang="en-US" sz="1300" b="1" dirty="0">
+                <a:latin typeface="Times New Roman"/>
+                <a:cs typeface="Times New Roman"/>
+              </a:rPr>
+              <a:t>Validation:</a:t>
+            </a:r>
+            <a:r>
+              <a:rPr lang="en-US" sz="1300" dirty="0">
+                <a:latin typeface="Times New Roman"/>
+                <a:cs typeface="Times New Roman"/>
+              </a:rPr>
+              <a:t> Coded the borders to change to green for correct input and red for errors.</a:t>
+            </a:r>
+            <a:endParaRPr sz="1300" dirty="0">
               <a:latin typeface="Times New Roman"/>
               <a:cs typeface="Times New Roman"/>
             </a:endParaRPr>
@@ -8324,8 +6272,8 @@
         </p:nvSpPr>
         <p:spPr>
           <a:xfrm>
-            <a:off x="773988" y="7837169"/>
-            <a:ext cx="6390005" cy="725170"/>
+            <a:off x="750503" y="7900685"/>
+            <a:ext cx="6390005" cy="1089401"/>
           </a:xfrm>
           <a:prstGeom prst="rect">
             <a:avLst/>
@@ -8346,268 +6294,99 @@
               </a:spcBef>
             </a:pPr>
             <a:r>
-              <a:rPr sz="1300" b="1" dirty="0">
+              <a:rPr sz="1500" b="1" dirty="0">
                 <a:latin typeface="Times New Roman"/>
                 <a:cs typeface="Times New Roman"/>
               </a:rPr>
               <a:t>3.7</a:t>
             </a:r>
             <a:r>
-              <a:rPr sz="1300" b="1" spc="-35" dirty="0">
-                <a:latin typeface="Times New Roman"/>
-                <a:cs typeface="Times New Roman"/>
-              </a:rPr>
-              <a:t> </a:t>
-            </a:r>
-            <a:r>
-              <a:rPr sz="1300" b="1" dirty="0">
+              <a:rPr sz="1500" b="1" spc="-35" dirty="0">
+                <a:latin typeface="Times New Roman"/>
+                <a:cs typeface="Times New Roman"/>
+              </a:rPr>
+              <a:t> </a:t>
+            </a:r>
+            <a:r>
+              <a:rPr sz="1500" b="1" dirty="0">
                 <a:latin typeface="Times New Roman"/>
                 <a:cs typeface="Times New Roman"/>
               </a:rPr>
               <a:t>Button</a:t>
             </a:r>
             <a:r>
-              <a:rPr sz="1300" b="1" spc="-35" dirty="0">
-                <a:latin typeface="Times New Roman"/>
-                <a:cs typeface="Times New Roman"/>
-              </a:rPr>
-              <a:t> </a:t>
-            </a:r>
-            <a:r>
-              <a:rPr sz="1300" b="1" spc="-10" dirty="0">
-                <a:latin typeface="Times New Roman"/>
-                <a:cs typeface="Times New Roman"/>
-              </a:rPr>
-              <a:t>Styling:</a:t>
-            </a:r>
-            <a:endParaRPr sz="1300">
-              <a:latin typeface="Times New Roman"/>
-              <a:cs typeface="Times New Roman"/>
-            </a:endParaRPr>
+              <a:rPr sz="1500" b="1" spc="-35" dirty="0">
+                <a:latin typeface="Times New Roman"/>
+                <a:cs typeface="Times New Roman"/>
+              </a:rPr>
+              <a:t> </a:t>
+            </a:r>
+            <a:r>
+              <a:rPr sz="1500" b="1" spc="-10" dirty="0">
+                <a:latin typeface="Times New Roman"/>
+                <a:cs typeface="Times New Roman"/>
+              </a:rPr>
+              <a:t>Styling</a:t>
+            </a:r>
+            <a:r>
+              <a:rPr lang="en-US" sz="1500" b="1" spc="-10" dirty="0">
+                <a:latin typeface="Times New Roman"/>
+                <a:cs typeface="Times New Roman"/>
+              </a:rPr>
+              <a:t>:</a:t>
+            </a:r>
           </a:p>
           <a:p>
-            <a:pPr marL="125095" marR="5080">
+            <a:pPr marL="410845" marR="5080" indent="-285750">
               <a:lnSpc>
                 <a:spcPts val="1380"/>
               </a:lnSpc>
               <a:spcBef>
                 <a:spcPts val="1225"/>
               </a:spcBef>
+              <a:buFont typeface="Arial" panose="020B0604020202020204" pitchFamily="34" charset="0"/>
+              <a:buChar char="•"/>
             </a:pPr>
             <a:r>
-              <a:rPr sz="1200" i="1" dirty="0">
-                <a:latin typeface="Times New Roman"/>
-                <a:cs typeface="Times New Roman"/>
-              </a:rPr>
-              <a:t>(Design</a:t>
-            </a:r>
-            <a:r>
-              <a:rPr sz="1200" i="1" spc="-30" dirty="0">
-                <a:latin typeface="Times New Roman"/>
-                <a:cs typeface="Times New Roman"/>
-              </a:rPr>
-              <a:t> </a:t>
-            </a:r>
-            <a:r>
-              <a:rPr sz="1200" i="1" dirty="0">
-                <a:latin typeface="Times New Roman"/>
-                <a:cs typeface="Times New Roman"/>
-              </a:rPr>
-              <a:t>attractive</a:t>
-            </a:r>
-            <a:r>
-              <a:rPr sz="1200" i="1" spc="-30" dirty="0">
-                <a:latin typeface="Times New Roman"/>
-                <a:cs typeface="Times New Roman"/>
-              </a:rPr>
-              <a:t> </a:t>
-            </a:r>
-            <a:r>
-              <a:rPr sz="1200" i="1" dirty="0">
-                <a:latin typeface="Times New Roman"/>
-                <a:cs typeface="Times New Roman"/>
-              </a:rPr>
-              <a:t>Submit</a:t>
-            </a:r>
-            <a:r>
-              <a:rPr sz="1200" i="1" spc="-25" dirty="0">
-                <a:latin typeface="Times New Roman"/>
-                <a:cs typeface="Times New Roman"/>
-              </a:rPr>
-              <a:t> </a:t>
-            </a:r>
-            <a:r>
-              <a:rPr sz="1200" i="1" dirty="0">
-                <a:latin typeface="Times New Roman"/>
-                <a:cs typeface="Times New Roman"/>
-              </a:rPr>
-              <a:t>and</a:t>
-            </a:r>
-            <a:r>
-              <a:rPr sz="1200" i="1" spc="-25" dirty="0">
-                <a:latin typeface="Times New Roman"/>
-                <a:cs typeface="Times New Roman"/>
-              </a:rPr>
-              <a:t> </a:t>
-            </a:r>
-            <a:r>
-              <a:rPr sz="1200" i="1" dirty="0">
-                <a:latin typeface="Times New Roman"/>
-                <a:cs typeface="Times New Roman"/>
-              </a:rPr>
-              <a:t>Reset</a:t>
-            </a:r>
-            <a:r>
-              <a:rPr sz="1200" i="1" spc="-25" dirty="0">
-                <a:latin typeface="Times New Roman"/>
-                <a:cs typeface="Times New Roman"/>
-              </a:rPr>
-              <a:t> </a:t>
-            </a:r>
-            <a:r>
-              <a:rPr sz="1200" i="1" dirty="0">
-                <a:latin typeface="Times New Roman"/>
-                <a:cs typeface="Times New Roman"/>
-              </a:rPr>
-              <a:t>buttons</a:t>
-            </a:r>
-            <a:r>
-              <a:rPr sz="1200" i="1" spc="-30" dirty="0">
-                <a:latin typeface="Times New Roman"/>
-                <a:cs typeface="Times New Roman"/>
-              </a:rPr>
-              <a:t> </a:t>
-            </a:r>
-            <a:r>
-              <a:rPr sz="1200" i="1" dirty="0">
-                <a:latin typeface="Times New Roman"/>
-                <a:cs typeface="Times New Roman"/>
-              </a:rPr>
-              <a:t>using</a:t>
-            </a:r>
-            <a:r>
-              <a:rPr sz="1200" i="1" spc="-25" dirty="0">
-                <a:latin typeface="Times New Roman"/>
-                <a:cs typeface="Times New Roman"/>
-              </a:rPr>
-              <a:t> </a:t>
-            </a:r>
-            <a:r>
-              <a:rPr sz="1200" i="1" dirty="0">
-                <a:latin typeface="Times New Roman"/>
-                <a:cs typeface="Times New Roman"/>
-              </a:rPr>
-              <a:t>background</a:t>
-            </a:r>
-            <a:r>
-              <a:rPr sz="1200" i="1" spc="-25" dirty="0">
-                <a:latin typeface="Times New Roman"/>
-                <a:cs typeface="Times New Roman"/>
-              </a:rPr>
-              <a:t> </a:t>
-            </a:r>
-            <a:r>
-              <a:rPr sz="1200" i="1" dirty="0">
-                <a:latin typeface="Times New Roman"/>
-                <a:cs typeface="Times New Roman"/>
-              </a:rPr>
-              <a:t>colors,</a:t>
-            </a:r>
-            <a:r>
-              <a:rPr sz="1200" i="1" spc="-25" dirty="0">
-                <a:latin typeface="Times New Roman"/>
-                <a:cs typeface="Times New Roman"/>
-              </a:rPr>
-              <a:t> </a:t>
-            </a:r>
-            <a:r>
-              <a:rPr sz="1200" i="1" dirty="0">
-                <a:latin typeface="Times New Roman"/>
-                <a:cs typeface="Times New Roman"/>
-              </a:rPr>
-              <a:t>padding,</a:t>
-            </a:r>
-            <a:r>
-              <a:rPr sz="1200" i="1" spc="-25" dirty="0">
-                <a:latin typeface="Times New Roman"/>
-                <a:cs typeface="Times New Roman"/>
-              </a:rPr>
-              <a:t> </a:t>
-            </a:r>
-            <a:r>
-              <a:rPr sz="1200" i="1" dirty="0">
-                <a:latin typeface="Times New Roman"/>
-                <a:cs typeface="Times New Roman"/>
-              </a:rPr>
-              <a:t>hover</a:t>
-            </a:r>
-            <a:r>
-              <a:rPr sz="1200" i="1" spc="-30" dirty="0">
-                <a:latin typeface="Times New Roman"/>
-                <a:cs typeface="Times New Roman"/>
-              </a:rPr>
-              <a:t> </a:t>
-            </a:r>
-            <a:r>
-              <a:rPr sz="1200" i="1" dirty="0">
-                <a:latin typeface="Times New Roman"/>
-                <a:cs typeface="Times New Roman"/>
-              </a:rPr>
-              <a:t>effects,</a:t>
-            </a:r>
-            <a:r>
-              <a:rPr sz="1200" i="1" spc="-25" dirty="0">
-                <a:latin typeface="Times New Roman"/>
-                <a:cs typeface="Times New Roman"/>
-              </a:rPr>
-              <a:t> </a:t>
-            </a:r>
-            <a:r>
-              <a:rPr sz="1200" i="1" spc="-10" dirty="0">
-                <a:latin typeface="Times New Roman"/>
-                <a:cs typeface="Times New Roman"/>
-              </a:rPr>
-              <a:t>rounded </a:t>
-            </a:r>
-            <a:r>
-              <a:rPr sz="1200" i="1" dirty="0">
-                <a:latin typeface="Times New Roman"/>
-                <a:cs typeface="Times New Roman"/>
-              </a:rPr>
-              <a:t>corners,</a:t>
-            </a:r>
-            <a:r>
-              <a:rPr sz="1200" i="1" spc="-20" dirty="0">
-                <a:latin typeface="Times New Roman"/>
-                <a:cs typeface="Times New Roman"/>
-              </a:rPr>
-              <a:t> </a:t>
-            </a:r>
-            <a:r>
-              <a:rPr sz="1200" i="1" dirty="0">
-                <a:latin typeface="Times New Roman"/>
-                <a:cs typeface="Times New Roman"/>
-              </a:rPr>
-              <a:t>and</a:t>
-            </a:r>
-            <a:r>
-              <a:rPr sz="1200" i="1" spc="-20" dirty="0">
-                <a:latin typeface="Times New Roman"/>
-                <a:cs typeface="Times New Roman"/>
-              </a:rPr>
-              <a:t> </a:t>
-            </a:r>
-            <a:r>
-              <a:rPr sz="1200" i="1" spc="-10" dirty="0">
-                <a:latin typeface="Times New Roman"/>
-                <a:cs typeface="Times New Roman"/>
-              </a:rPr>
-              <a:t>transitions.)</a:t>
-            </a:r>
-            <a:endParaRPr sz="1200">
-              <a:latin typeface="Times New Roman"/>
-              <a:cs typeface="Times New Roman"/>
-            </a:endParaRPr>
+              <a:rPr lang="en-US" sz="1300" b="1" dirty="0">
+                <a:latin typeface="Times New Roman"/>
+                <a:cs typeface="Times New Roman"/>
+              </a:rPr>
+              <a:t>Visual Design:</a:t>
+            </a:r>
+            <a:r>
+              <a:rPr lang="en-US" sz="1300" dirty="0">
+                <a:latin typeface="Times New Roman"/>
+                <a:cs typeface="Times New Roman"/>
+              </a:rPr>
+              <a:t> Styled the "Submit" button with a dark blue background and "Reset" with a red background.</a:t>
+            </a:r>
+          </a:p>
+          <a:p>
+            <a:pPr marL="410845" marR="5080" indent="-285750">
+              <a:lnSpc>
+                <a:spcPts val="1380"/>
+              </a:lnSpc>
+              <a:spcBef>
+                <a:spcPts val="1225"/>
+              </a:spcBef>
+              <a:buFont typeface="Arial" panose="020B0604020202020204" pitchFamily="34" charset="0"/>
+              <a:buChar char="•"/>
+            </a:pPr>
+            <a:r>
+              <a:rPr lang="en-US" sz="1300" b="1" dirty="0">
+                <a:latin typeface="Times New Roman"/>
+                <a:cs typeface="Times New Roman"/>
+              </a:rPr>
+              <a:t>Interactivity:</a:t>
+            </a:r>
+            <a:r>
+              <a:rPr lang="en-US" sz="1300" dirty="0">
+                <a:latin typeface="Times New Roman"/>
+                <a:cs typeface="Times New Roman"/>
+              </a:rPr>
+              <a:t> Added cursor: pointer and rounded edges for a modern feel.</a:t>
+            </a:r>
           </a:p>
         </p:txBody>
       </p:sp>
@@ -8619,7 +6398,7 @@
         </p:nvGrpSpPr>
         <p:grpSpPr>
           <a:xfrm>
-            <a:off x="801369" y="9038589"/>
+            <a:off x="754697" y="9364401"/>
             <a:ext cx="6402705" cy="21590"/>
             <a:chOff x="801369" y="9038589"/>
             <a:chExt cx="6402705" cy="21590"/>
@@ -8994,50 +6773,6 @@
           <a:xfrm>
             <a:off x="2749550" y="342899"/>
             <a:ext cx="1004798" cy="566420"/>
-          </a:xfrm>
-          <a:prstGeom prst="rect">
-            <a:avLst/>
-          </a:prstGeom>
-        </p:spPr>
-      </p:pic>
-      <p:pic>
-        <p:nvPicPr>
-          <p:cNvPr id="55" name="object 55"/>
-          <p:cNvPicPr/>
-          <p:nvPr/>
-        </p:nvPicPr>
-        <p:blipFill>
-          <a:blip r:embed="rId4" cstate="print"/>
-          <a:stretch>
-            <a:fillRect/>
-          </a:stretch>
-        </p:blipFill>
-        <p:spPr>
-          <a:xfrm>
-            <a:off x="739775" y="9845014"/>
-            <a:ext cx="1495933" cy="370205"/>
-          </a:xfrm>
-          <a:prstGeom prst="rect">
-            <a:avLst/>
-          </a:prstGeom>
-        </p:spPr>
-      </p:pic>
-      <p:pic>
-        <p:nvPicPr>
-          <p:cNvPr id="56" name="object 56"/>
-          <p:cNvPicPr/>
-          <p:nvPr/>
-        </p:nvPicPr>
-        <p:blipFill>
-          <a:blip r:embed="rId5" cstate="print"/>
-          <a:stretch>
-            <a:fillRect/>
-          </a:stretch>
-        </p:blipFill>
-        <p:spPr>
-          <a:xfrm>
-            <a:off x="2749550" y="9806914"/>
-            <a:ext cx="1004798" cy="566419"/>
           </a:xfrm>
           <a:prstGeom prst="rect">
             <a:avLst/>
@@ -9879,7 +7614,7 @@
               </a:rPr>
               <a:t>Section:</a:t>
             </a:r>
-            <a:endParaRPr sz="1300">
+            <a:endParaRPr sz="1300" dirty="0">
               <a:latin typeface="Times New Roman"/>
               <a:cs typeface="Times New Roman"/>
             </a:endParaRPr>
@@ -10131,7 +7866,7 @@
               </a:rPr>
               <a:t>form.)</a:t>
             </a:r>
-            <a:endParaRPr sz="1200">
+            <a:endParaRPr sz="1200" dirty="0">
               <a:latin typeface="Times New Roman"/>
               <a:cs typeface="Times New Roman"/>
             </a:endParaRPr>
@@ -10547,7 +8282,7 @@
               </a:rPr>
               <a:t>Design:</a:t>
             </a:r>
-            <a:endParaRPr sz="1300">
+            <a:endParaRPr sz="1300" dirty="0">
               <a:latin typeface="Times New Roman"/>
               <a:cs typeface="Times New Roman"/>
             </a:endParaRPr>
@@ -10785,7 +8520,7 @@
               </a:rPr>
               <a:t>information.)</a:t>
             </a:r>
-            <a:endParaRPr sz="1200">
+            <a:endParaRPr sz="1200" dirty="0">
               <a:latin typeface="Times New Roman"/>
               <a:cs typeface="Times New Roman"/>
             </a:endParaRPr>
@@ -13153,6 +10888,72 @@
           </p:txBody>
         </p:sp>
       </p:grpSp>
+      <p:pic>
+        <p:nvPicPr>
+          <p:cNvPr id="55" name="object 55"/>
+          <p:cNvPicPr/>
+          <p:nvPr/>
+        </p:nvPicPr>
+        <p:blipFill>
+          <a:blip r:embed="rId3" cstate="print"/>
+          <a:stretch>
+            <a:fillRect/>
+          </a:stretch>
+        </p:blipFill>
+        <p:spPr>
+          <a:xfrm>
+            <a:off x="801370" y="340996"/>
+            <a:ext cx="1495933" cy="370205"/>
+          </a:xfrm>
+          <a:prstGeom prst="rect">
+            <a:avLst/>
+          </a:prstGeom>
+        </p:spPr>
+      </p:pic>
+      <p:pic>
+        <p:nvPicPr>
+          <p:cNvPr id="51" name="object 4"/>
+          <p:cNvPicPr/>
+          <p:nvPr/>
+        </p:nvPicPr>
+        <p:blipFill>
+          <a:blip r:embed="rId4" cstate="print"/>
+          <a:stretch>
+            <a:fillRect/>
+          </a:stretch>
+        </p:blipFill>
+        <p:spPr>
+          <a:xfrm>
+            <a:off x="4514469" y="329185"/>
+            <a:ext cx="996314" cy="434174"/>
+          </a:xfrm>
+          <a:prstGeom prst="rect">
+            <a:avLst/>
+          </a:prstGeom>
+        </p:spPr>
+      </p:pic>
+      <p:pic>
+        <p:nvPicPr>
+          <p:cNvPr id="56" name="object 56"/>
+          <p:cNvPicPr/>
+          <p:nvPr/>
+        </p:nvPicPr>
+        <p:blipFill>
+          <a:blip r:embed="rId5" cstate="print"/>
+          <a:stretch>
+            <a:fillRect/>
+          </a:stretch>
+        </p:blipFill>
+        <p:spPr>
+          <a:xfrm>
+            <a:off x="2847594" y="262510"/>
+            <a:ext cx="1004798" cy="566419"/>
+          </a:xfrm>
+          <a:prstGeom prst="rect">
+            <a:avLst/>
+          </a:prstGeom>
+        </p:spPr>
+      </p:pic>
     </p:spTree>
   </p:cSld>
   <p:clrMapOvr>

</xml_diff>

<commit_message>
almost completed template 2 filename and screenshot remaining
</commit_message>
<xml_diff>
--- a/ppt/FE Assignment template- 2.pptx
+++ b/ppt/FE Assignment template- 2.pptx
@@ -175,7 +175,7 @@
           <a:p>
             <a:fld id="{1D8BD707-D9CF-40AE-B4C6-C98DA3205C09}" type="datetimeFigureOut">
               <a:rPr lang="en-US"/>
-              <a:t>3/9/2026</a:t>
+              <a:t>3/10/2026</a:t>
             </a:fld>
             <a:endParaRPr lang="en-US"/>
           </a:p>
@@ -340,7 +340,7 @@
           <a:p>
             <a:fld id="{1D8BD707-D9CF-40AE-B4C6-C98DA3205C09}" type="datetimeFigureOut">
               <a:rPr lang="en-US"/>
-              <a:t>3/9/2026</a:t>
+              <a:t>3/10/2026</a:t>
             </a:fld>
             <a:endParaRPr lang="en-US"/>
           </a:p>
@@ -548,7 +548,7 @@
           <a:p>
             <a:fld id="{1D8BD707-D9CF-40AE-B4C6-C98DA3205C09}" type="datetimeFigureOut">
               <a:rPr lang="en-US"/>
-              <a:t>3/9/2026</a:t>
+              <a:t>3/10/2026</a:t>
             </a:fld>
             <a:endParaRPr lang="en-US"/>
           </a:p>
@@ -690,7 +690,7 @@
           <a:p>
             <a:fld id="{1D8BD707-D9CF-40AE-B4C6-C98DA3205C09}" type="datetimeFigureOut">
               <a:rPr lang="en-US"/>
-              <a:t>3/9/2026</a:t>
+              <a:t>3/10/2026</a:t>
             </a:fld>
             <a:endParaRPr lang="en-US"/>
           </a:p>
@@ -809,7 +809,7 @@
           <a:p>
             <a:fld id="{1D8BD707-D9CF-40AE-B4C6-C98DA3205C09}" type="datetimeFigureOut">
               <a:rPr lang="en-US"/>
-              <a:t>3/9/2026</a:t>
+              <a:t>3/10/2026</a:t>
             </a:fld>
             <a:endParaRPr lang="en-US"/>
           </a:p>
@@ -1022,7 +1022,7 @@
           <a:p>
             <a:fld id="{1D8BD707-D9CF-40AE-B4C6-C98DA3205C09}" type="datetimeFigureOut">
               <a:rPr lang="en-US"/>
-              <a:t>3/9/2026</a:t>
+              <a:t>3/10/2026</a:t>
             </a:fld>
             <a:endParaRPr lang="en-US"/>
           </a:p>
@@ -1852,14 +1852,7 @@
                 <a:latin typeface="Times New Roman"/>
                 <a:cs typeface="Times New Roman"/>
               </a:rPr>
-              <a:t> Tagore College of Arts and Science ,</a:t>
-            </a:r>
-            <a:r>
-              <a:rPr lang="en-US" sz="1200" b="1" spc="-20" dirty="0" err="1">
-                <a:latin typeface="Times New Roman"/>
-                <a:cs typeface="Times New Roman"/>
-              </a:rPr>
-              <a:t>Chrompet</a:t>
+              <a:t> Tagore College of Arts and Science .</a:t>
             </a:r>
             <a:endParaRPr sz="1200" dirty="0">
               <a:latin typeface="Times New Roman"/>
@@ -6834,8 +6827,8 @@
         </p:nvSpPr>
         <p:spPr>
           <a:xfrm>
-            <a:off x="796848" y="1293622"/>
-            <a:ext cx="6082665" cy="699135"/>
+            <a:off x="829501" y="1029413"/>
+            <a:ext cx="6082665" cy="1186863"/>
           </a:xfrm>
           <a:prstGeom prst="rect">
             <a:avLst/>
@@ -6918,259 +6911,77 @@
               </a:rPr>
               <a:t>Table:</a:t>
             </a:r>
-            <a:endParaRPr sz="1300">
+            <a:endParaRPr sz="1300" dirty="0">
               <a:latin typeface="Times New Roman"/>
               <a:cs typeface="Times New Roman"/>
             </a:endParaRPr>
           </a:p>
           <a:p>
-            <a:pPr marL="102235" marR="5080">
+            <a:pPr marL="273685" marR="5080" indent="-171450">
               <a:lnSpc>
                 <a:spcPts val="1380"/>
               </a:lnSpc>
               <a:spcBef>
                 <a:spcPts val="1025"/>
               </a:spcBef>
+              <a:buFont typeface="Arial" panose="020B0604020202020204" pitchFamily="34" charset="0"/>
+              <a:buChar char="•"/>
             </a:pPr>
             <a:r>
-              <a:rPr sz="1200" i="1" dirty="0">
-                <a:latin typeface="Times New Roman"/>
-                <a:cs typeface="Times New Roman"/>
-              </a:rPr>
-              <a:t>(Enhance</a:t>
-            </a:r>
-            <a:r>
-              <a:rPr sz="1200" i="1" spc="-30" dirty="0">
-                <a:latin typeface="Times New Roman"/>
-                <a:cs typeface="Times New Roman"/>
-              </a:rPr>
-              <a:t> </a:t>
-            </a:r>
-            <a:r>
-              <a:rPr sz="1200" i="1" dirty="0">
-                <a:latin typeface="Times New Roman"/>
-                <a:cs typeface="Times New Roman"/>
-              </a:rPr>
-              <a:t>the</a:t>
-            </a:r>
-            <a:r>
-              <a:rPr sz="1200" i="1" spc="-20" dirty="0">
-                <a:latin typeface="Times New Roman"/>
-                <a:cs typeface="Times New Roman"/>
-              </a:rPr>
-              <a:t> </a:t>
-            </a:r>
-            <a:r>
-              <a:rPr sz="1200" i="1" dirty="0">
-                <a:latin typeface="Times New Roman"/>
-                <a:cs typeface="Times New Roman"/>
-              </a:rPr>
-              <a:t>table</a:t>
-            </a:r>
-            <a:r>
-              <a:rPr sz="1200" i="1" spc="-20" dirty="0">
-                <a:latin typeface="Times New Roman"/>
-                <a:cs typeface="Times New Roman"/>
-              </a:rPr>
-              <a:t> </a:t>
-            </a:r>
-            <a:r>
-              <a:rPr sz="1200" i="1" dirty="0">
-                <a:latin typeface="Times New Roman"/>
-                <a:cs typeface="Times New Roman"/>
-              </a:rPr>
-              <a:t>by</a:t>
-            </a:r>
-            <a:r>
-              <a:rPr sz="1200" i="1" spc="-25" dirty="0">
-                <a:latin typeface="Times New Roman"/>
-                <a:cs typeface="Times New Roman"/>
-              </a:rPr>
-              <a:t> </a:t>
-            </a:r>
-            <a:r>
-              <a:rPr sz="1200" i="1" dirty="0">
-                <a:latin typeface="Times New Roman"/>
-                <a:cs typeface="Times New Roman"/>
-              </a:rPr>
-              <a:t>adding</a:t>
-            </a:r>
-            <a:r>
-              <a:rPr sz="1200" i="1" spc="-20" dirty="0">
-                <a:latin typeface="Times New Roman"/>
-                <a:cs typeface="Times New Roman"/>
-              </a:rPr>
-              <a:t> </a:t>
-            </a:r>
-            <a:r>
-              <a:rPr sz="1200" i="1" dirty="0">
-                <a:latin typeface="Times New Roman"/>
-                <a:cs typeface="Times New Roman"/>
-              </a:rPr>
-              <a:t>borders,</a:t>
-            </a:r>
-            <a:r>
-              <a:rPr sz="1200" i="1" spc="-20" dirty="0">
-                <a:latin typeface="Times New Roman"/>
-                <a:cs typeface="Times New Roman"/>
-              </a:rPr>
-              <a:t> </a:t>
-            </a:r>
-            <a:r>
-              <a:rPr sz="1200" i="1" dirty="0">
-                <a:latin typeface="Times New Roman"/>
-                <a:cs typeface="Times New Roman"/>
-              </a:rPr>
-              <a:t>header</a:t>
-            </a:r>
-            <a:r>
-              <a:rPr sz="1200" i="1" spc="-25" dirty="0">
-                <a:latin typeface="Times New Roman"/>
-                <a:cs typeface="Times New Roman"/>
-              </a:rPr>
-              <a:t> </a:t>
-            </a:r>
-            <a:r>
-              <a:rPr sz="1200" i="1" dirty="0">
-                <a:latin typeface="Times New Roman"/>
-                <a:cs typeface="Times New Roman"/>
-              </a:rPr>
-              <a:t>background</a:t>
-            </a:r>
-            <a:r>
-              <a:rPr sz="1200" i="1" spc="-25" dirty="0">
-                <a:latin typeface="Times New Roman"/>
-                <a:cs typeface="Times New Roman"/>
-              </a:rPr>
-              <a:t> </a:t>
-            </a:r>
-            <a:r>
-              <a:rPr sz="1200" i="1" dirty="0">
-                <a:latin typeface="Times New Roman"/>
-                <a:cs typeface="Times New Roman"/>
-              </a:rPr>
-              <a:t>color,</a:t>
-            </a:r>
-            <a:r>
-              <a:rPr sz="1200" i="1" spc="-20" dirty="0">
-                <a:latin typeface="Times New Roman"/>
-                <a:cs typeface="Times New Roman"/>
-              </a:rPr>
-              <a:t> </a:t>
-            </a:r>
-            <a:r>
-              <a:rPr sz="1200" i="1" dirty="0">
-                <a:latin typeface="Times New Roman"/>
-                <a:cs typeface="Times New Roman"/>
-              </a:rPr>
-              <a:t>alternate</a:t>
-            </a:r>
-            <a:r>
-              <a:rPr sz="1200" i="1" spc="-25" dirty="0">
-                <a:latin typeface="Times New Roman"/>
-                <a:cs typeface="Times New Roman"/>
-              </a:rPr>
-              <a:t> </a:t>
-            </a:r>
-            <a:r>
-              <a:rPr sz="1200" i="1" dirty="0">
-                <a:latin typeface="Times New Roman"/>
-                <a:cs typeface="Times New Roman"/>
-              </a:rPr>
-              <a:t>row</a:t>
-            </a:r>
-            <a:r>
-              <a:rPr sz="1200" i="1" spc="-20" dirty="0">
-                <a:latin typeface="Times New Roman"/>
-                <a:cs typeface="Times New Roman"/>
-              </a:rPr>
-              <a:t> </a:t>
-            </a:r>
-            <a:r>
-              <a:rPr sz="1200" i="1" dirty="0">
-                <a:latin typeface="Times New Roman"/>
-                <a:cs typeface="Times New Roman"/>
-              </a:rPr>
-              <a:t>styling,</a:t>
-            </a:r>
-            <a:r>
-              <a:rPr sz="1200" i="1" spc="-20" dirty="0">
-                <a:latin typeface="Times New Roman"/>
-                <a:cs typeface="Times New Roman"/>
-              </a:rPr>
-              <a:t> </a:t>
-            </a:r>
-            <a:r>
-              <a:rPr sz="1200" i="1" dirty="0">
-                <a:latin typeface="Times New Roman"/>
-                <a:cs typeface="Times New Roman"/>
-              </a:rPr>
-              <a:t>and</a:t>
-            </a:r>
-            <a:r>
-              <a:rPr sz="1200" i="1" spc="-20" dirty="0">
-                <a:latin typeface="Times New Roman"/>
-                <a:cs typeface="Times New Roman"/>
-              </a:rPr>
-              <a:t> </a:t>
-            </a:r>
-            <a:r>
-              <a:rPr sz="1200" i="1" spc="-10" dirty="0">
-                <a:latin typeface="Times New Roman"/>
-                <a:cs typeface="Times New Roman"/>
-              </a:rPr>
-              <a:t>hover </a:t>
-            </a:r>
-            <a:r>
-              <a:rPr sz="1200" i="1" dirty="0">
-                <a:latin typeface="Times New Roman"/>
-                <a:cs typeface="Times New Roman"/>
-              </a:rPr>
-              <a:t>effects</a:t>
-            </a:r>
-            <a:r>
-              <a:rPr sz="1200" i="1" spc="-40" dirty="0">
-                <a:latin typeface="Times New Roman"/>
-                <a:cs typeface="Times New Roman"/>
-              </a:rPr>
-              <a:t> </a:t>
-            </a:r>
-            <a:r>
-              <a:rPr sz="1200" i="1" dirty="0">
-                <a:latin typeface="Times New Roman"/>
-                <a:cs typeface="Times New Roman"/>
-              </a:rPr>
-              <a:t>for</a:t>
-            </a:r>
-            <a:r>
-              <a:rPr sz="1200" i="1" spc="-35" dirty="0">
-                <a:latin typeface="Times New Roman"/>
-                <a:cs typeface="Times New Roman"/>
-              </a:rPr>
-              <a:t> </a:t>
-            </a:r>
-            <a:r>
-              <a:rPr sz="1200" i="1" dirty="0">
-                <a:latin typeface="Times New Roman"/>
-                <a:cs typeface="Times New Roman"/>
-              </a:rPr>
-              <a:t>better</a:t>
-            </a:r>
-            <a:r>
-              <a:rPr sz="1200" i="1" spc="-40" dirty="0">
-                <a:latin typeface="Times New Roman"/>
-                <a:cs typeface="Times New Roman"/>
-              </a:rPr>
-              <a:t> </a:t>
-            </a:r>
-            <a:r>
-              <a:rPr sz="1200" i="1" spc="-10" dirty="0">
-                <a:latin typeface="Times New Roman"/>
-                <a:cs typeface="Times New Roman"/>
-              </a:rPr>
-              <a:t>readability.)</a:t>
-            </a:r>
-            <a:endParaRPr sz="1200">
+              <a:rPr lang="en-US" sz="1400" b="1" dirty="0">
+                <a:latin typeface="Times New Roman"/>
+                <a:cs typeface="Times New Roman"/>
+              </a:rPr>
+              <a:t>Header Style</a:t>
+            </a:r>
+            <a:r>
+              <a:rPr lang="en-US" sz="1400" dirty="0">
+                <a:latin typeface="Times New Roman"/>
+                <a:cs typeface="Times New Roman"/>
+              </a:rPr>
+              <a:t>: Highlighted the table headers &lt;</a:t>
+            </a:r>
+            <a:r>
+              <a:rPr lang="en-US" sz="1400" dirty="0" err="1">
+                <a:latin typeface="Times New Roman"/>
+                <a:cs typeface="Times New Roman"/>
+              </a:rPr>
+              <a:t>th</a:t>
+            </a:r>
+            <a:r>
+              <a:rPr lang="en-US" sz="1400" dirty="0">
+                <a:latin typeface="Times New Roman"/>
+                <a:cs typeface="Times New Roman"/>
+              </a:rPr>
+              <a:t>&gt; with a bright yellow background (#ffeb3b).</a:t>
+            </a:r>
+          </a:p>
+          <a:p>
+            <a:pPr marL="273685" marR="5080" indent="-171450">
+              <a:lnSpc>
+                <a:spcPts val="1380"/>
+              </a:lnSpc>
+              <a:spcBef>
+                <a:spcPts val="1025"/>
+              </a:spcBef>
+              <a:buFont typeface="Arial" panose="020B0604020202020204" pitchFamily="34" charset="0"/>
+              <a:buChar char="•"/>
+            </a:pPr>
+            <a:r>
+              <a:rPr lang="en-US" sz="1400" b="1" dirty="0">
+                <a:latin typeface="Times New Roman"/>
+                <a:cs typeface="Times New Roman"/>
+              </a:rPr>
+              <a:t>Readability</a:t>
+            </a:r>
+            <a:r>
+              <a:rPr lang="en-US" sz="1400" dirty="0">
+                <a:latin typeface="Times New Roman"/>
+                <a:cs typeface="Times New Roman"/>
+              </a:rPr>
+              <a:t>: Applied consistent borders and padding to ensure student data is easy to scan</a:t>
+            </a:r>
+            <a:endParaRPr lang="en-US" sz="1300" i="1" dirty="0">
               <a:latin typeface="Times New Roman"/>
               <a:cs typeface="Times New Roman"/>
             </a:endParaRPr>
@@ -7185,7 +6996,7 @@
         </p:nvGrpSpPr>
         <p:grpSpPr>
           <a:xfrm>
-            <a:off x="801369" y="2552699"/>
+            <a:off x="801370" y="2298481"/>
             <a:ext cx="6402705" cy="20320"/>
             <a:chOff x="801369" y="2552699"/>
             <a:chExt cx="6402705" cy="20320"/>
@@ -7530,8 +7341,8 @@
         </p:nvSpPr>
         <p:spPr>
           <a:xfrm>
-            <a:off x="796848" y="2710941"/>
-            <a:ext cx="6006465" cy="699770"/>
+            <a:off x="805321" y="2410753"/>
+            <a:ext cx="6006465" cy="827791"/>
           </a:xfrm>
           <a:prstGeom prst="rect">
             <a:avLst/>
@@ -7620,256 +7431,56 @@
             </a:endParaRPr>
           </a:p>
           <a:p>
-            <a:pPr marL="102235" marR="5080">
+            <a:pPr marL="273685" marR="5080" indent="-171450">
               <a:lnSpc>
                 <a:spcPts val="1380"/>
               </a:lnSpc>
               <a:spcBef>
                 <a:spcPts val="1025"/>
               </a:spcBef>
+              <a:buFont typeface="Arial" panose="020B0604020202020204" pitchFamily="34" charset="0"/>
+              <a:buChar char="•"/>
             </a:pPr>
             <a:r>
-              <a:rPr sz="1200" i="1" dirty="0">
-                <a:latin typeface="Times New Roman"/>
-                <a:cs typeface="Times New Roman"/>
-              </a:rPr>
-              <a:t>(Align</a:t>
-            </a:r>
-            <a:r>
-              <a:rPr sz="1200" i="1" spc="-30" dirty="0">
-                <a:latin typeface="Times New Roman"/>
-                <a:cs typeface="Times New Roman"/>
-              </a:rPr>
-              <a:t> </a:t>
-            </a:r>
-            <a:r>
-              <a:rPr sz="1200" i="1" dirty="0">
-                <a:latin typeface="Times New Roman"/>
-                <a:cs typeface="Times New Roman"/>
-              </a:rPr>
-              <a:t>the</a:t>
-            </a:r>
-            <a:r>
-              <a:rPr sz="1200" i="1" spc="-30" dirty="0">
-                <a:latin typeface="Times New Roman"/>
-                <a:cs typeface="Times New Roman"/>
-              </a:rPr>
-              <a:t> </a:t>
-            </a:r>
-            <a:r>
-              <a:rPr sz="1200" i="1" dirty="0">
-                <a:latin typeface="Times New Roman"/>
-                <a:cs typeface="Times New Roman"/>
-              </a:rPr>
-              <a:t>declaration</a:t>
-            </a:r>
-            <a:r>
-              <a:rPr sz="1200" i="1" spc="-25" dirty="0">
-                <a:latin typeface="Times New Roman"/>
-                <a:cs typeface="Times New Roman"/>
-              </a:rPr>
-              <a:t> </a:t>
-            </a:r>
-            <a:r>
-              <a:rPr sz="1200" i="1" dirty="0">
-                <a:latin typeface="Times New Roman"/>
-                <a:cs typeface="Times New Roman"/>
-              </a:rPr>
-              <a:t>checkbox</a:t>
-            </a:r>
-            <a:r>
-              <a:rPr sz="1200" i="1" spc="-35" dirty="0">
-                <a:latin typeface="Times New Roman"/>
-                <a:cs typeface="Times New Roman"/>
-              </a:rPr>
-              <a:t> </a:t>
-            </a:r>
-            <a:r>
-              <a:rPr sz="1200" i="1" dirty="0">
-                <a:latin typeface="Times New Roman"/>
-                <a:cs typeface="Times New Roman"/>
-              </a:rPr>
-              <a:t>properly</a:t>
-            </a:r>
-            <a:r>
-              <a:rPr sz="1200" i="1" spc="-30" dirty="0">
-                <a:latin typeface="Times New Roman"/>
-                <a:cs typeface="Times New Roman"/>
-              </a:rPr>
-              <a:t> </a:t>
-            </a:r>
-            <a:r>
-              <a:rPr sz="1200" i="1" dirty="0">
-                <a:latin typeface="Times New Roman"/>
-                <a:cs typeface="Times New Roman"/>
-              </a:rPr>
-              <a:t>and</a:t>
-            </a:r>
-            <a:r>
-              <a:rPr sz="1200" i="1" spc="-25" dirty="0">
-                <a:latin typeface="Times New Roman"/>
-                <a:cs typeface="Times New Roman"/>
-              </a:rPr>
-              <a:t> </a:t>
-            </a:r>
-            <a:r>
-              <a:rPr sz="1200" i="1" dirty="0">
-                <a:latin typeface="Times New Roman"/>
-                <a:cs typeface="Times New Roman"/>
-              </a:rPr>
-              <a:t>add</a:t>
-            </a:r>
-            <a:r>
-              <a:rPr sz="1200" i="1" spc="-25" dirty="0">
-                <a:latin typeface="Times New Roman"/>
-                <a:cs typeface="Times New Roman"/>
-              </a:rPr>
-              <a:t> </a:t>
-            </a:r>
-            <a:r>
-              <a:rPr sz="1200" i="1" dirty="0">
-                <a:latin typeface="Times New Roman"/>
-                <a:cs typeface="Times New Roman"/>
-              </a:rPr>
-              <a:t>spacing</a:t>
-            </a:r>
-            <a:r>
-              <a:rPr sz="1200" i="1" spc="-25" dirty="0">
-                <a:latin typeface="Times New Roman"/>
-                <a:cs typeface="Times New Roman"/>
-              </a:rPr>
-              <a:t> </a:t>
-            </a:r>
-            <a:r>
-              <a:rPr sz="1200" i="1" dirty="0">
-                <a:latin typeface="Times New Roman"/>
-                <a:cs typeface="Times New Roman"/>
-              </a:rPr>
-              <a:t>to</a:t>
-            </a:r>
-            <a:r>
-              <a:rPr sz="1200" i="1" spc="-30" dirty="0">
-                <a:latin typeface="Times New Roman"/>
-                <a:cs typeface="Times New Roman"/>
-              </a:rPr>
-              <a:t> </a:t>
-            </a:r>
-            <a:r>
-              <a:rPr sz="1200" i="1" dirty="0">
-                <a:latin typeface="Times New Roman"/>
-                <a:cs typeface="Times New Roman"/>
-              </a:rPr>
-              <a:t>make</a:t>
-            </a:r>
-            <a:r>
-              <a:rPr sz="1200" i="1" spc="-35" dirty="0">
-                <a:latin typeface="Times New Roman"/>
-                <a:cs typeface="Times New Roman"/>
-              </a:rPr>
-              <a:t> </a:t>
-            </a:r>
-            <a:r>
-              <a:rPr sz="1200" i="1" dirty="0">
-                <a:latin typeface="Times New Roman"/>
-                <a:cs typeface="Times New Roman"/>
-              </a:rPr>
-              <a:t>it</a:t>
-            </a:r>
-            <a:r>
-              <a:rPr sz="1200" i="1" spc="-25" dirty="0">
-                <a:latin typeface="Times New Roman"/>
-                <a:cs typeface="Times New Roman"/>
-              </a:rPr>
-              <a:t> </a:t>
-            </a:r>
-            <a:r>
-              <a:rPr sz="1200" i="1" dirty="0">
-                <a:latin typeface="Times New Roman"/>
-                <a:cs typeface="Times New Roman"/>
-              </a:rPr>
-              <a:t>clear</a:t>
-            </a:r>
-            <a:r>
-              <a:rPr sz="1200" i="1" spc="-25" dirty="0">
-                <a:latin typeface="Times New Roman"/>
-                <a:cs typeface="Times New Roman"/>
-              </a:rPr>
-              <a:t> </a:t>
-            </a:r>
-            <a:r>
-              <a:rPr sz="1200" i="1" dirty="0">
-                <a:latin typeface="Times New Roman"/>
-                <a:cs typeface="Times New Roman"/>
-              </a:rPr>
-              <a:t>but</a:t>
-            </a:r>
-            <a:r>
-              <a:rPr sz="1200" i="1" spc="-30" dirty="0">
-                <a:latin typeface="Times New Roman"/>
-                <a:cs typeface="Times New Roman"/>
-              </a:rPr>
-              <a:t> </a:t>
-            </a:r>
-            <a:r>
-              <a:rPr sz="1200" i="1" dirty="0">
-                <a:latin typeface="Times New Roman"/>
-                <a:cs typeface="Times New Roman"/>
-              </a:rPr>
-              <a:t>visually</a:t>
-            </a:r>
-            <a:r>
-              <a:rPr sz="1200" i="1" spc="-25" dirty="0">
-                <a:latin typeface="Times New Roman"/>
-                <a:cs typeface="Times New Roman"/>
-              </a:rPr>
-              <a:t> </a:t>
-            </a:r>
-            <a:r>
-              <a:rPr sz="1200" i="1" spc="-10" dirty="0">
-                <a:latin typeface="Times New Roman"/>
-                <a:cs typeface="Times New Roman"/>
-              </a:rPr>
-              <a:t>balanced </a:t>
-            </a:r>
-            <a:r>
-              <a:rPr sz="1200" i="1" dirty="0">
-                <a:latin typeface="Times New Roman"/>
-                <a:cs typeface="Times New Roman"/>
-              </a:rPr>
-              <a:t>within</a:t>
-            </a:r>
-            <a:r>
-              <a:rPr sz="1200" i="1" spc="-25" dirty="0">
-                <a:latin typeface="Times New Roman"/>
-                <a:cs typeface="Times New Roman"/>
-              </a:rPr>
-              <a:t> </a:t>
-            </a:r>
-            <a:r>
-              <a:rPr sz="1200" i="1" dirty="0">
-                <a:latin typeface="Times New Roman"/>
-                <a:cs typeface="Times New Roman"/>
-              </a:rPr>
-              <a:t>the</a:t>
-            </a:r>
-            <a:r>
-              <a:rPr sz="1200" i="1" spc="-30" dirty="0">
-                <a:latin typeface="Times New Roman"/>
-                <a:cs typeface="Times New Roman"/>
-              </a:rPr>
-              <a:t> </a:t>
-            </a:r>
-            <a:r>
-              <a:rPr sz="1200" i="1" spc="-10" dirty="0">
-                <a:latin typeface="Times New Roman"/>
-                <a:cs typeface="Times New Roman"/>
-              </a:rPr>
-              <a:t>form.)</a:t>
-            </a:r>
-            <a:endParaRPr sz="1200" dirty="0">
-              <a:latin typeface="Times New Roman"/>
-              <a:cs typeface="Times New Roman"/>
-            </a:endParaRPr>
+              <a:rPr lang="en-US" sz="1200" b="1" dirty="0">
+                <a:latin typeface="Times New Roman"/>
+                <a:cs typeface="Times New Roman"/>
+              </a:rPr>
+              <a:t>Alignment</a:t>
+            </a:r>
+            <a:r>
+              <a:rPr lang="en-US" sz="1200" dirty="0">
+                <a:latin typeface="Times New Roman"/>
+                <a:cs typeface="Times New Roman"/>
+              </a:rPr>
+              <a:t>: Ensured the "I confirm" checkbox is properly aligned with the label text.</a:t>
+            </a:r>
+          </a:p>
+          <a:p>
+            <a:pPr marL="273685" marR="5080" indent="-171450">
+              <a:lnSpc>
+                <a:spcPts val="1380"/>
+              </a:lnSpc>
+              <a:spcBef>
+                <a:spcPts val="1025"/>
+              </a:spcBef>
+              <a:buFont typeface="Arial" panose="020B0604020202020204" pitchFamily="34" charset="0"/>
+              <a:buChar char="•"/>
+            </a:pPr>
+            <a:r>
+              <a:rPr lang="en-US" sz="1200" b="1" dirty="0">
+                <a:latin typeface="Times New Roman"/>
+                <a:cs typeface="Times New Roman"/>
+              </a:rPr>
+              <a:t>Spacing</a:t>
+            </a:r>
+            <a:r>
+              <a:rPr lang="en-US" sz="1200" dirty="0">
+                <a:latin typeface="Times New Roman"/>
+                <a:cs typeface="Times New Roman"/>
+              </a:rPr>
+              <a:t>: Added a bottom margin to separate the checkbox from the action buttons.</a:t>
+            </a:r>
           </a:p>
         </p:txBody>
       </p:sp>
@@ -7881,7 +7492,7 @@
         </p:nvGrpSpPr>
         <p:grpSpPr>
           <a:xfrm>
-            <a:off x="801369" y="3790314"/>
+            <a:off x="812360" y="3360672"/>
             <a:ext cx="6402705" cy="20320"/>
             <a:chOff x="801369" y="3790314"/>
             <a:chExt cx="6402705" cy="20320"/>
@@ -8226,8 +7837,8 @@
         </p:nvSpPr>
         <p:spPr>
           <a:xfrm>
-            <a:off x="796848" y="4067682"/>
-            <a:ext cx="6082030" cy="725170"/>
+            <a:off x="830136" y="3539606"/>
+            <a:ext cx="6082030" cy="1058623"/>
           </a:xfrm>
           <a:prstGeom prst="rect">
             <a:avLst/>
@@ -8288,237 +7899,55 @@
             </a:endParaRPr>
           </a:p>
           <a:p>
-            <a:pPr marL="102235" marR="5080">
+            <a:pPr marL="273685" marR="5080" indent="-171450">
               <a:lnSpc>
                 <a:spcPts val="1380"/>
               </a:lnSpc>
               <a:spcBef>
                 <a:spcPts val="1230"/>
               </a:spcBef>
+              <a:buFont typeface="Arial" panose="020B0604020202020204" pitchFamily="34" charset="0"/>
+              <a:buChar char="•"/>
             </a:pPr>
             <a:r>
-              <a:rPr sz="1200" i="1" dirty="0">
-                <a:latin typeface="Times New Roman"/>
-                <a:cs typeface="Times New Roman"/>
-              </a:rPr>
-              <a:t>(Style</a:t>
-            </a:r>
-            <a:r>
-              <a:rPr sz="1200" i="1" spc="-30" dirty="0">
-                <a:latin typeface="Times New Roman"/>
-                <a:cs typeface="Times New Roman"/>
-              </a:rPr>
-              <a:t> </a:t>
-            </a:r>
-            <a:r>
-              <a:rPr sz="1200" i="1" dirty="0">
-                <a:latin typeface="Times New Roman"/>
-                <a:cs typeface="Times New Roman"/>
-              </a:rPr>
-              <a:t>the</a:t>
-            </a:r>
-            <a:r>
-              <a:rPr sz="1200" i="1" spc="-35" dirty="0">
-                <a:latin typeface="Times New Roman"/>
-                <a:cs typeface="Times New Roman"/>
-              </a:rPr>
-              <a:t> </a:t>
-            </a:r>
-            <a:r>
-              <a:rPr sz="1200" i="1" dirty="0">
-                <a:latin typeface="Times New Roman"/>
-                <a:cs typeface="Times New Roman"/>
-              </a:rPr>
-              <a:t>footer</a:t>
-            </a:r>
-            <a:r>
-              <a:rPr sz="1200" i="1" spc="-30" dirty="0">
-                <a:latin typeface="Times New Roman"/>
-                <a:cs typeface="Times New Roman"/>
-              </a:rPr>
-              <a:t> </a:t>
-            </a:r>
-            <a:r>
-              <a:rPr sz="1200" i="1" dirty="0">
-                <a:latin typeface="Times New Roman"/>
-                <a:cs typeface="Times New Roman"/>
-              </a:rPr>
-              <a:t>with</a:t>
-            </a:r>
-            <a:r>
-              <a:rPr sz="1200" i="1" spc="-30" dirty="0">
-                <a:latin typeface="Times New Roman"/>
-                <a:cs typeface="Times New Roman"/>
-              </a:rPr>
-              <a:t> </a:t>
-            </a:r>
-            <a:r>
-              <a:rPr sz="1200" i="1" dirty="0">
-                <a:latin typeface="Times New Roman"/>
-                <a:cs typeface="Times New Roman"/>
-              </a:rPr>
-              <a:t>background</a:t>
-            </a:r>
-            <a:r>
-              <a:rPr sz="1200" i="1" spc="-25" dirty="0">
-                <a:latin typeface="Times New Roman"/>
-                <a:cs typeface="Times New Roman"/>
-              </a:rPr>
-              <a:t> </a:t>
-            </a:r>
-            <a:r>
-              <a:rPr sz="1200" i="1" dirty="0">
-                <a:latin typeface="Times New Roman"/>
-                <a:cs typeface="Times New Roman"/>
-              </a:rPr>
-              <a:t>color,</a:t>
-            </a:r>
-            <a:r>
-              <a:rPr sz="1200" i="1" spc="-30" dirty="0">
-                <a:latin typeface="Times New Roman"/>
-                <a:cs typeface="Times New Roman"/>
-              </a:rPr>
-              <a:t> </a:t>
-            </a:r>
-            <a:r>
-              <a:rPr sz="1200" i="1" dirty="0">
-                <a:latin typeface="Times New Roman"/>
-                <a:cs typeface="Times New Roman"/>
-              </a:rPr>
-              <a:t>center</a:t>
-            </a:r>
-            <a:r>
-              <a:rPr sz="1200" i="1" spc="-30" dirty="0">
-                <a:latin typeface="Times New Roman"/>
-                <a:cs typeface="Times New Roman"/>
-              </a:rPr>
-              <a:t> </a:t>
-            </a:r>
-            <a:r>
-              <a:rPr sz="1200" i="1" dirty="0">
-                <a:latin typeface="Times New Roman"/>
-                <a:cs typeface="Times New Roman"/>
-              </a:rPr>
-              <a:t>alignment,</a:t>
-            </a:r>
-            <a:r>
-              <a:rPr sz="1200" i="1" spc="-30" dirty="0">
-                <a:latin typeface="Times New Roman"/>
-                <a:cs typeface="Times New Roman"/>
-              </a:rPr>
-              <a:t> </a:t>
-            </a:r>
-            <a:r>
-              <a:rPr sz="1200" i="1" dirty="0">
-                <a:latin typeface="Times New Roman"/>
-                <a:cs typeface="Times New Roman"/>
-              </a:rPr>
-              <a:t>padding,</a:t>
-            </a:r>
-            <a:r>
-              <a:rPr sz="1200" i="1" spc="-25" dirty="0">
-                <a:latin typeface="Times New Roman"/>
-                <a:cs typeface="Times New Roman"/>
-              </a:rPr>
-              <a:t> </a:t>
-            </a:r>
-            <a:r>
-              <a:rPr sz="1200" i="1" dirty="0">
-                <a:latin typeface="Times New Roman"/>
-                <a:cs typeface="Times New Roman"/>
-              </a:rPr>
-              <a:t>and</a:t>
-            </a:r>
-            <a:r>
-              <a:rPr sz="1200" i="1" spc="-30" dirty="0">
-                <a:latin typeface="Times New Roman"/>
-                <a:cs typeface="Times New Roman"/>
-              </a:rPr>
-              <a:t> </a:t>
-            </a:r>
-            <a:r>
-              <a:rPr sz="1200" i="1" dirty="0">
-                <a:latin typeface="Times New Roman"/>
-                <a:cs typeface="Times New Roman"/>
-              </a:rPr>
-              <a:t>proper</a:t>
-            </a:r>
-            <a:r>
-              <a:rPr sz="1200" i="1" spc="-30" dirty="0">
-                <a:latin typeface="Times New Roman"/>
-                <a:cs typeface="Times New Roman"/>
-              </a:rPr>
-              <a:t> </a:t>
-            </a:r>
-            <a:r>
-              <a:rPr sz="1200" i="1" dirty="0">
-                <a:latin typeface="Times New Roman"/>
-                <a:cs typeface="Times New Roman"/>
-              </a:rPr>
-              <a:t>spacing</a:t>
-            </a:r>
-            <a:r>
-              <a:rPr sz="1200" i="1" spc="-30" dirty="0">
-                <a:latin typeface="Times New Roman"/>
-                <a:cs typeface="Times New Roman"/>
-              </a:rPr>
-              <a:t> </a:t>
-            </a:r>
-            <a:r>
-              <a:rPr sz="1200" i="1" dirty="0">
-                <a:latin typeface="Times New Roman"/>
-                <a:cs typeface="Times New Roman"/>
-              </a:rPr>
-              <a:t>to</a:t>
-            </a:r>
-            <a:r>
-              <a:rPr sz="1200" i="1" spc="-30" dirty="0">
-                <a:latin typeface="Times New Roman"/>
-                <a:cs typeface="Times New Roman"/>
-              </a:rPr>
-              <a:t> </a:t>
-            </a:r>
-            <a:r>
-              <a:rPr sz="1200" i="1" spc="-10" dirty="0">
-                <a:latin typeface="Times New Roman"/>
-                <a:cs typeface="Times New Roman"/>
-              </a:rPr>
-              <a:t>clearly </a:t>
-            </a:r>
-            <a:r>
-              <a:rPr sz="1200" i="1" dirty="0">
-                <a:latin typeface="Times New Roman"/>
-                <a:cs typeface="Times New Roman"/>
-              </a:rPr>
-              <a:t>display</a:t>
-            </a:r>
-            <a:r>
-              <a:rPr sz="1200" i="1" spc="-40" dirty="0">
-                <a:latin typeface="Times New Roman"/>
-                <a:cs typeface="Times New Roman"/>
-              </a:rPr>
-              <a:t> </a:t>
-            </a:r>
-            <a:r>
-              <a:rPr sz="1200" i="1" dirty="0">
-                <a:latin typeface="Times New Roman"/>
-                <a:cs typeface="Times New Roman"/>
-              </a:rPr>
-              <a:t>contact</a:t>
-            </a:r>
-            <a:r>
-              <a:rPr sz="1200" i="1" spc="-40" dirty="0">
-                <a:latin typeface="Times New Roman"/>
-                <a:cs typeface="Times New Roman"/>
-              </a:rPr>
-              <a:t> </a:t>
-            </a:r>
-            <a:r>
-              <a:rPr sz="1200" i="1" spc="-10" dirty="0">
-                <a:latin typeface="Times New Roman"/>
-                <a:cs typeface="Times New Roman"/>
-              </a:rPr>
-              <a:t>information.)</a:t>
+              <a:rPr lang="en-US" sz="1200" b="1" dirty="0">
+                <a:latin typeface="Times New Roman"/>
+                <a:cs typeface="Times New Roman"/>
+              </a:rPr>
+              <a:t>Separation</a:t>
+            </a:r>
+            <a:r>
+              <a:rPr lang="en-US" sz="1200" dirty="0">
+                <a:latin typeface="Times New Roman"/>
+                <a:cs typeface="Times New Roman"/>
+              </a:rPr>
+              <a:t>: Added a large top margin (50px) to clearly separate contact info from the form.</a:t>
+            </a:r>
+          </a:p>
+          <a:p>
+            <a:pPr marL="273685" marR="5080" indent="-171450">
+              <a:lnSpc>
+                <a:spcPts val="1380"/>
+              </a:lnSpc>
+              <a:spcBef>
+                <a:spcPts val="1230"/>
+              </a:spcBef>
+              <a:buFont typeface="Arial" panose="020B0604020202020204" pitchFamily="34" charset="0"/>
+              <a:buChar char="•"/>
+            </a:pPr>
+            <a:r>
+              <a:rPr lang="en-US" sz="1200" b="1" dirty="0">
+                <a:latin typeface="Times New Roman"/>
+                <a:cs typeface="Times New Roman"/>
+              </a:rPr>
+              <a:t>Subtlety</a:t>
+            </a:r>
+            <a:r>
+              <a:rPr lang="en-US" sz="1200" dirty="0">
+                <a:latin typeface="Times New Roman"/>
+                <a:cs typeface="Times New Roman"/>
+              </a:rPr>
+              <a:t>: Reduced the font size to 0.9em and used a different text color (#555) for a professional finish.</a:t>
             </a:r>
             <a:endParaRPr sz="1200" dirty="0">
               <a:latin typeface="Times New Roman"/>
@@ -8535,7 +7964,7 @@
         </p:nvGrpSpPr>
         <p:grpSpPr>
           <a:xfrm>
-            <a:off x="801369" y="5076189"/>
+            <a:off x="829501" y="4704415"/>
             <a:ext cx="6402705" cy="20955"/>
             <a:chOff x="801369" y="5076189"/>
             <a:chExt cx="6402705" cy="20955"/>
@@ -8880,8 +8309,8 @@
         </p:nvSpPr>
         <p:spPr>
           <a:xfrm>
-            <a:off x="792276" y="5409056"/>
-            <a:ext cx="6102350" cy="717550"/>
+            <a:off x="829501" y="4786141"/>
+            <a:ext cx="6561021" cy="2434641"/>
           </a:xfrm>
           <a:prstGeom prst="rect">
             <a:avLst/>
@@ -8951,7 +8380,7 @@
               </a:rPr>
               <a:t>Used:</a:t>
             </a:r>
-            <a:endParaRPr sz="1400">
+            <a:endParaRPr sz="1400" dirty="0">
               <a:latin typeface="Times New Roman"/>
               <a:cs typeface="Times New Roman"/>
             </a:endParaRPr>
@@ -8966,314 +8395,147 @@
               </a:spcBef>
             </a:pPr>
             <a:r>
-              <a:rPr sz="1200" i="1" dirty="0">
-                <a:latin typeface="Times New Roman"/>
-                <a:cs typeface="Times New Roman"/>
-              </a:rPr>
-              <a:t>(Mention</a:t>
-            </a:r>
-            <a:r>
-              <a:rPr sz="1200" i="1" spc="-25" dirty="0">
-                <a:latin typeface="Times New Roman"/>
-                <a:cs typeface="Times New Roman"/>
-              </a:rPr>
-              <a:t> </a:t>
-            </a:r>
-            <a:r>
-              <a:rPr sz="1200" i="1" dirty="0">
-                <a:latin typeface="Times New Roman"/>
-                <a:cs typeface="Times New Roman"/>
-              </a:rPr>
-              <a:t>the</a:t>
-            </a:r>
-            <a:r>
-              <a:rPr sz="1200" i="1" spc="-20" dirty="0">
-                <a:latin typeface="Times New Roman"/>
-                <a:cs typeface="Times New Roman"/>
-              </a:rPr>
-              <a:t> </a:t>
-            </a:r>
-            <a:r>
-              <a:rPr sz="1200" i="1" dirty="0">
-                <a:latin typeface="Times New Roman"/>
-                <a:cs typeface="Times New Roman"/>
-              </a:rPr>
-              <a:t>CSS</a:t>
-            </a:r>
-            <a:r>
-              <a:rPr sz="1200" i="1" spc="-20" dirty="0">
-                <a:latin typeface="Times New Roman"/>
-                <a:cs typeface="Times New Roman"/>
-              </a:rPr>
-              <a:t> </a:t>
-            </a:r>
-            <a:r>
-              <a:rPr sz="1200" i="1" dirty="0">
-                <a:latin typeface="Times New Roman"/>
-                <a:cs typeface="Times New Roman"/>
-              </a:rPr>
-              <a:t>concepts</a:t>
-            </a:r>
-            <a:r>
-              <a:rPr sz="1200" i="1" spc="-25" dirty="0">
-                <a:latin typeface="Times New Roman"/>
-                <a:cs typeface="Times New Roman"/>
-              </a:rPr>
-              <a:t> </a:t>
-            </a:r>
-            <a:r>
-              <a:rPr sz="1200" i="1" dirty="0">
-                <a:latin typeface="Times New Roman"/>
-                <a:cs typeface="Times New Roman"/>
-              </a:rPr>
-              <a:t>applied</a:t>
-            </a:r>
-            <a:r>
-              <a:rPr sz="1200" i="1" spc="-25" dirty="0">
-                <a:latin typeface="Times New Roman"/>
-                <a:cs typeface="Times New Roman"/>
-              </a:rPr>
-              <a:t> </a:t>
-            </a:r>
-            <a:r>
-              <a:rPr sz="1200" i="1" dirty="0">
-                <a:latin typeface="Times New Roman"/>
-                <a:cs typeface="Times New Roman"/>
-              </a:rPr>
-              <a:t>in</a:t>
-            </a:r>
-            <a:r>
-              <a:rPr sz="1200" i="1" spc="-20" dirty="0">
-                <a:latin typeface="Times New Roman"/>
-                <a:cs typeface="Times New Roman"/>
-              </a:rPr>
-              <a:t> </a:t>
-            </a:r>
-            <a:r>
-              <a:rPr sz="1200" i="1" dirty="0">
-                <a:latin typeface="Times New Roman"/>
-                <a:cs typeface="Times New Roman"/>
-              </a:rPr>
-              <a:t>the</a:t>
-            </a:r>
-            <a:r>
-              <a:rPr sz="1200" i="1" spc="-25" dirty="0">
-                <a:latin typeface="Times New Roman"/>
-                <a:cs typeface="Times New Roman"/>
-              </a:rPr>
-              <a:t> </a:t>
-            </a:r>
-            <a:r>
-              <a:rPr sz="1200" i="1" dirty="0">
-                <a:latin typeface="Times New Roman"/>
-                <a:cs typeface="Times New Roman"/>
-              </a:rPr>
-              <a:t>project</a:t>
-            </a:r>
-            <a:r>
-              <a:rPr sz="1200" i="1" spc="-20" dirty="0">
-                <a:latin typeface="Times New Roman"/>
-                <a:cs typeface="Times New Roman"/>
-              </a:rPr>
-              <a:t> </a:t>
-            </a:r>
-            <a:r>
-              <a:rPr sz="1200" i="1" dirty="0">
-                <a:latin typeface="Times New Roman"/>
-                <a:cs typeface="Times New Roman"/>
-              </a:rPr>
-              <a:t>such</a:t>
-            </a:r>
-            <a:r>
-              <a:rPr sz="1200" i="1" spc="-25" dirty="0">
-                <a:latin typeface="Times New Roman"/>
-                <a:cs typeface="Times New Roman"/>
-              </a:rPr>
-              <a:t> </a:t>
-            </a:r>
-            <a:r>
-              <a:rPr sz="1200" i="1" dirty="0">
-                <a:latin typeface="Times New Roman"/>
-                <a:cs typeface="Times New Roman"/>
-              </a:rPr>
-              <a:t>as</a:t>
-            </a:r>
-            <a:r>
-              <a:rPr sz="1200" i="1" spc="-25" dirty="0">
-                <a:latin typeface="Times New Roman"/>
-                <a:cs typeface="Times New Roman"/>
-              </a:rPr>
-              <a:t> </a:t>
-            </a:r>
-            <a:r>
-              <a:rPr sz="1200" i="1" dirty="0">
-                <a:latin typeface="Times New Roman"/>
-                <a:cs typeface="Times New Roman"/>
-              </a:rPr>
-              <a:t>selectors,</a:t>
-            </a:r>
-            <a:r>
-              <a:rPr sz="1200" i="1" spc="-20" dirty="0">
-                <a:latin typeface="Times New Roman"/>
-                <a:cs typeface="Times New Roman"/>
-              </a:rPr>
-              <a:t> </a:t>
-            </a:r>
-            <a:r>
-              <a:rPr sz="1200" i="1" dirty="0">
-                <a:latin typeface="Times New Roman"/>
-                <a:cs typeface="Times New Roman"/>
-              </a:rPr>
-              <a:t>box</a:t>
-            </a:r>
-            <a:r>
-              <a:rPr sz="1200" i="1" spc="-25" dirty="0">
-                <a:latin typeface="Times New Roman"/>
-                <a:cs typeface="Times New Roman"/>
-              </a:rPr>
-              <a:t> </a:t>
-            </a:r>
-            <a:r>
-              <a:rPr sz="1200" i="1" dirty="0">
-                <a:latin typeface="Times New Roman"/>
-                <a:cs typeface="Times New Roman"/>
-              </a:rPr>
-              <a:t>model,</a:t>
-            </a:r>
-            <a:r>
-              <a:rPr sz="1200" i="1" spc="-20" dirty="0">
-                <a:latin typeface="Times New Roman"/>
-                <a:cs typeface="Times New Roman"/>
-              </a:rPr>
-              <a:t> </a:t>
-            </a:r>
-            <a:r>
-              <a:rPr sz="1200" i="1" dirty="0">
-                <a:latin typeface="Times New Roman"/>
-                <a:cs typeface="Times New Roman"/>
-              </a:rPr>
-              <a:t>colors,</a:t>
-            </a:r>
-            <a:r>
-              <a:rPr sz="1200" i="1" spc="-25" dirty="0">
-                <a:latin typeface="Times New Roman"/>
-                <a:cs typeface="Times New Roman"/>
-              </a:rPr>
-              <a:t> </a:t>
-            </a:r>
-            <a:r>
-              <a:rPr sz="1200" i="1" spc="-10" dirty="0">
-                <a:latin typeface="Times New Roman"/>
-                <a:cs typeface="Times New Roman"/>
-              </a:rPr>
-              <a:t>typography, </a:t>
-            </a:r>
-            <a:r>
-              <a:rPr sz="1200" i="1" dirty="0">
-                <a:latin typeface="Times New Roman"/>
-                <a:cs typeface="Times New Roman"/>
-              </a:rPr>
-              <a:t>spacing,</a:t>
-            </a:r>
-            <a:r>
-              <a:rPr sz="1200" i="1" spc="-25" dirty="0">
-                <a:latin typeface="Times New Roman"/>
-                <a:cs typeface="Times New Roman"/>
-              </a:rPr>
-              <a:t> </a:t>
-            </a:r>
-            <a:r>
-              <a:rPr sz="1200" i="1" dirty="0">
-                <a:latin typeface="Times New Roman"/>
-                <a:cs typeface="Times New Roman"/>
-              </a:rPr>
-              <a:t>borders,</a:t>
-            </a:r>
-            <a:r>
-              <a:rPr sz="1200" i="1" spc="-25" dirty="0">
-                <a:latin typeface="Times New Roman"/>
-                <a:cs typeface="Times New Roman"/>
-              </a:rPr>
-              <a:t> </a:t>
-            </a:r>
-            <a:r>
-              <a:rPr sz="1200" i="1" dirty="0">
-                <a:latin typeface="Times New Roman"/>
-                <a:cs typeface="Times New Roman"/>
-              </a:rPr>
-              <a:t>shadows,</a:t>
-            </a:r>
-            <a:r>
-              <a:rPr sz="1200" i="1" spc="-25" dirty="0">
-                <a:latin typeface="Times New Roman"/>
-                <a:cs typeface="Times New Roman"/>
-              </a:rPr>
-              <a:t> </a:t>
-            </a:r>
-            <a:r>
-              <a:rPr sz="1200" i="1" dirty="0">
-                <a:latin typeface="Times New Roman"/>
-                <a:cs typeface="Times New Roman"/>
-              </a:rPr>
-              <a:t>hover</a:t>
-            </a:r>
-            <a:r>
-              <a:rPr sz="1200" i="1" spc="-30" dirty="0">
-                <a:latin typeface="Times New Roman"/>
-                <a:cs typeface="Times New Roman"/>
-              </a:rPr>
-              <a:t> </a:t>
-            </a:r>
-            <a:r>
-              <a:rPr sz="1200" i="1" dirty="0">
-                <a:latin typeface="Times New Roman"/>
-                <a:cs typeface="Times New Roman"/>
-              </a:rPr>
-              <a:t>effects,</a:t>
-            </a:r>
-            <a:r>
-              <a:rPr sz="1200" i="1" spc="-25" dirty="0">
-                <a:latin typeface="Times New Roman"/>
-                <a:cs typeface="Times New Roman"/>
-              </a:rPr>
-              <a:t> </a:t>
-            </a:r>
-            <a:r>
-              <a:rPr sz="1200" i="1" dirty="0">
-                <a:latin typeface="Times New Roman"/>
-                <a:cs typeface="Times New Roman"/>
-              </a:rPr>
-              <a:t>and</a:t>
-            </a:r>
-            <a:r>
-              <a:rPr sz="1200" i="1" spc="-25" dirty="0">
-                <a:latin typeface="Times New Roman"/>
-                <a:cs typeface="Times New Roman"/>
-              </a:rPr>
-              <a:t> </a:t>
-            </a:r>
-            <a:r>
-              <a:rPr sz="1200" i="1" dirty="0">
-                <a:latin typeface="Times New Roman"/>
-                <a:cs typeface="Times New Roman"/>
-              </a:rPr>
-              <a:t>table</a:t>
-            </a:r>
-            <a:r>
-              <a:rPr sz="1200" i="1" spc="-25" dirty="0">
-                <a:latin typeface="Times New Roman"/>
-                <a:cs typeface="Times New Roman"/>
-              </a:rPr>
-              <a:t> </a:t>
-            </a:r>
-            <a:r>
-              <a:rPr sz="1200" i="1" spc="-10" dirty="0">
-                <a:latin typeface="Times New Roman"/>
-                <a:cs typeface="Times New Roman"/>
-              </a:rPr>
-              <a:t>styling.)</a:t>
-            </a:r>
-            <a:endParaRPr sz="1200">
+              <a:rPr lang="en-US" sz="1200" spc="-10" dirty="0">
+                <a:latin typeface="Times New Roman"/>
+                <a:cs typeface="Times New Roman"/>
+              </a:rPr>
+              <a:t>To transform the page, I utilized the following core CSS principles:</a:t>
+            </a:r>
+          </a:p>
+          <a:p>
+            <a:pPr marL="188595" marR="5080" indent="-171450">
+              <a:lnSpc>
+                <a:spcPts val="1390"/>
+              </a:lnSpc>
+              <a:spcBef>
+                <a:spcPts val="1015"/>
+              </a:spcBef>
+              <a:buFont typeface="Arial" panose="020B0604020202020204" pitchFamily="34" charset="0"/>
+              <a:buChar char="•"/>
+            </a:pPr>
+            <a:r>
+              <a:rPr lang="en-US" sz="1200" b="1" spc="-10" dirty="0">
+                <a:latin typeface="Times New Roman"/>
+                <a:cs typeface="Times New Roman"/>
+              </a:rPr>
+              <a:t>Selectors:</a:t>
+            </a:r>
+            <a:r>
+              <a:rPr lang="en-US" sz="1200" spc="-10" dirty="0">
+                <a:latin typeface="Times New Roman"/>
+                <a:cs typeface="Times New Roman"/>
+              </a:rPr>
+              <a:t> Used element (body, form), ID (#regForm, #pTable), and class (.info) selectors to apply specific styles.</a:t>
+            </a:r>
+          </a:p>
+          <a:p>
+            <a:pPr marL="188595" marR="5080" indent="-171450">
+              <a:lnSpc>
+                <a:spcPts val="1390"/>
+              </a:lnSpc>
+              <a:spcBef>
+                <a:spcPts val="1015"/>
+              </a:spcBef>
+              <a:buFont typeface="Arial" panose="020B0604020202020204" pitchFamily="34" charset="0"/>
+              <a:buChar char="•"/>
+            </a:pPr>
+            <a:r>
+              <a:rPr lang="en-US" sz="1200" b="1" spc="-10" dirty="0">
+                <a:latin typeface="Times New Roman"/>
+                <a:cs typeface="Times New Roman"/>
+              </a:rPr>
+              <a:t>Box Model:</a:t>
+            </a:r>
+            <a:r>
+              <a:rPr lang="en-US" sz="1200" spc="-10" dirty="0">
+                <a:latin typeface="Times New Roman"/>
+                <a:cs typeface="Times New Roman"/>
+              </a:rPr>
+              <a:t> Managed margin, border, and padding to control the spacing and size of every element.</a:t>
+            </a:r>
+            <a:endParaRPr lang="en-US" sz="1200" b="1" spc="-10" dirty="0">
+              <a:latin typeface="Times New Roman"/>
+              <a:cs typeface="Times New Roman"/>
+            </a:endParaRPr>
+          </a:p>
+          <a:p>
+            <a:pPr marL="188595" marR="5080" indent="-171450">
+              <a:lnSpc>
+                <a:spcPts val="1390"/>
+              </a:lnSpc>
+              <a:spcBef>
+                <a:spcPts val="1015"/>
+              </a:spcBef>
+              <a:buFont typeface="Arial" panose="020B0604020202020204" pitchFamily="34" charset="0"/>
+              <a:buChar char="•"/>
+            </a:pPr>
+            <a:r>
+              <a:rPr lang="en-US" sz="1200" b="1" spc="-10" dirty="0">
+                <a:latin typeface="Times New Roman"/>
+                <a:cs typeface="Times New Roman"/>
+              </a:rPr>
+              <a:t>Typography: </a:t>
+            </a:r>
+            <a:r>
+              <a:rPr lang="en-US" sz="1200" spc="-10" dirty="0">
+                <a:latin typeface="Times New Roman"/>
+                <a:cs typeface="Times New Roman"/>
+              </a:rPr>
+              <a:t>Applied font-family (Arial) and text-align to ensure a professional and readable look.</a:t>
+            </a:r>
+          </a:p>
+          <a:p>
+            <a:pPr marL="188595" marR="5080" indent="-171450">
+              <a:lnSpc>
+                <a:spcPts val="1390"/>
+              </a:lnSpc>
+              <a:spcBef>
+                <a:spcPts val="1015"/>
+              </a:spcBef>
+              <a:buFont typeface="Arial" panose="020B0604020202020204" pitchFamily="34" charset="0"/>
+              <a:buChar char="•"/>
+            </a:pPr>
+            <a:r>
+              <a:rPr lang="en-US" sz="1200" b="1" spc="-10" dirty="0">
+                <a:latin typeface="Times New Roman"/>
+                <a:cs typeface="Times New Roman"/>
+              </a:rPr>
+              <a:t>Visual Effects:</a:t>
+            </a:r>
+            <a:r>
+              <a:rPr lang="en-US" sz="1200" spc="-10" dirty="0">
+                <a:latin typeface="Times New Roman"/>
+                <a:cs typeface="Times New Roman"/>
+              </a:rPr>
+              <a:t> Implemented border-radius for rounded corners and box-shadow to give the form depth.</a:t>
+            </a:r>
+          </a:p>
+          <a:p>
+            <a:pPr marL="188595" marR="5080" indent="-171450">
+              <a:lnSpc>
+                <a:spcPts val="1390"/>
+              </a:lnSpc>
+              <a:spcBef>
+                <a:spcPts val="1015"/>
+              </a:spcBef>
+              <a:buFont typeface="Arial" panose="020B0604020202020204" pitchFamily="34" charset="0"/>
+              <a:buChar char="•"/>
+            </a:pPr>
+            <a:r>
+              <a:rPr lang="en-US" sz="1200" b="1" spc="-10" dirty="0">
+                <a:latin typeface="Times New Roman"/>
+                <a:cs typeface="Times New Roman"/>
+              </a:rPr>
+              <a:t>Interactive States:</a:t>
+            </a:r>
+            <a:r>
+              <a:rPr lang="en-US" sz="1200" spc="-10" dirty="0">
+                <a:latin typeface="Times New Roman"/>
+                <a:cs typeface="Times New Roman"/>
+              </a:rPr>
+              <a:t> Used pseudo-classes like :hover for buttons and :valid / :invalid for real-time input validation.</a:t>
+            </a:r>
+            <a:endParaRPr sz="1200" dirty="0">
               <a:latin typeface="Times New Roman"/>
               <a:cs typeface="Times New Roman"/>
             </a:endParaRPr>
@@ -9288,7 +8550,7 @@
         </p:nvGrpSpPr>
         <p:grpSpPr>
           <a:xfrm>
-            <a:off x="801369" y="6544309"/>
+            <a:off x="796665" y="7367866"/>
             <a:ext cx="6402705" cy="20955"/>
             <a:chOff x="801369" y="6544309"/>
             <a:chExt cx="6402705" cy="20955"/>
@@ -9633,8 +8895,8 @@
         </p:nvSpPr>
         <p:spPr>
           <a:xfrm>
-            <a:off x="755700" y="6776084"/>
-            <a:ext cx="5134610" cy="543560"/>
+            <a:off x="796666" y="7435477"/>
+            <a:ext cx="6733347" cy="2845010"/>
           </a:xfrm>
           <a:prstGeom prst="rect">
             <a:avLst/>
@@ -9704,203 +8966,167 @@
               </a:rPr>
               <a:t>Steps:</a:t>
             </a:r>
-            <a:endParaRPr sz="1400">
+            <a:endParaRPr sz="1400" dirty="0">
               <a:latin typeface="Times New Roman"/>
               <a:cs typeface="Times New Roman"/>
             </a:endParaRPr>
           </a:p>
           <a:p>
-            <a:pPr marL="12700">
+            <a:pPr marL="184150" indent="-171450">
               <a:lnSpc>
                 <a:spcPct val="100000"/>
               </a:lnSpc>
               <a:spcBef>
                 <a:spcPts val="955"/>
               </a:spcBef>
+              <a:buFont typeface="Arial" panose="020B0604020202020204" pitchFamily="34" charset="0"/>
+              <a:buChar char="•"/>
             </a:pPr>
             <a:r>
-              <a:rPr sz="1200" i="1" dirty="0">
-                <a:latin typeface="Times New Roman"/>
-                <a:cs typeface="Times New Roman"/>
-              </a:rPr>
-              <a:t>(Explain</a:t>
-            </a:r>
-            <a:r>
-              <a:rPr sz="1200" i="1" spc="-20" dirty="0">
-                <a:latin typeface="Times New Roman"/>
-                <a:cs typeface="Times New Roman"/>
-              </a:rPr>
-              <a:t> </a:t>
-            </a:r>
-            <a:r>
-              <a:rPr sz="1200" i="1" dirty="0">
-                <a:latin typeface="Times New Roman"/>
-                <a:cs typeface="Times New Roman"/>
-              </a:rPr>
-              <a:t>the</a:t>
-            </a:r>
-            <a:r>
-              <a:rPr sz="1200" i="1" spc="-20" dirty="0">
-                <a:latin typeface="Times New Roman"/>
-                <a:cs typeface="Times New Roman"/>
-              </a:rPr>
-              <a:t> </a:t>
-            </a:r>
-            <a:r>
-              <a:rPr sz="1200" i="1" spc="-10" dirty="0">
-                <a:latin typeface="Times New Roman"/>
-                <a:cs typeface="Times New Roman"/>
-              </a:rPr>
-              <a:t>step-by-</a:t>
-            </a:r>
-            <a:r>
-              <a:rPr sz="1200" i="1" dirty="0">
-                <a:latin typeface="Times New Roman"/>
-                <a:cs typeface="Times New Roman"/>
-              </a:rPr>
-              <a:t>step</a:t>
-            </a:r>
-            <a:r>
-              <a:rPr sz="1200" i="1" spc="-15" dirty="0">
-                <a:latin typeface="Times New Roman"/>
-                <a:cs typeface="Times New Roman"/>
-              </a:rPr>
-              <a:t> </a:t>
-            </a:r>
-            <a:r>
-              <a:rPr sz="1200" i="1" dirty="0">
-                <a:latin typeface="Times New Roman"/>
-                <a:cs typeface="Times New Roman"/>
-              </a:rPr>
-              <a:t>process</a:t>
-            </a:r>
-            <a:r>
-              <a:rPr sz="1200" i="1" spc="-25" dirty="0">
-                <a:latin typeface="Times New Roman"/>
-                <a:cs typeface="Times New Roman"/>
-              </a:rPr>
-              <a:t> </a:t>
-            </a:r>
-            <a:r>
-              <a:rPr sz="1200" i="1" dirty="0">
-                <a:latin typeface="Times New Roman"/>
-                <a:cs typeface="Times New Roman"/>
-              </a:rPr>
-              <a:t>followed</a:t>
-            </a:r>
-            <a:r>
-              <a:rPr sz="1200" i="1" spc="-15" dirty="0">
-                <a:latin typeface="Times New Roman"/>
-                <a:cs typeface="Times New Roman"/>
-              </a:rPr>
-              <a:t> </a:t>
-            </a:r>
-            <a:r>
-              <a:rPr sz="1200" i="1" dirty="0">
-                <a:latin typeface="Times New Roman"/>
-                <a:cs typeface="Times New Roman"/>
-              </a:rPr>
-              <a:t>to</a:t>
-            </a:r>
-            <a:r>
-              <a:rPr sz="1200" i="1" spc="-20" dirty="0">
-                <a:latin typeface="Times New Roman"/>
-                <a:cs typeface="Times New Roman"/>
-              </a:rPr>
-              <a:t> </a:t>
-            </a:r>
-            <a:r>
-              <a:rPr sz="1200" i="1" dirty="0">
-                <a:latin typeface="Times New Roman"/>
-                <a:cs typeface="Times New Roman"/>
-              </a:rPr>
-              <a:t>apply</a:t>
-            </a:r>
-            <a:r>
-              <a:rPr sz="1200" i="1" spc="-20" dirty="0">
-                <a:latin typeface="Times New Roman"/>
-                <a:cs typeface="Times New Roman"/>
-              </a:rPr>
-              <a:t> </a:t>
-            </a:r>
-            <a:r>
-              <a:rPr sz="1200" i="1" dirty="0">
-                <a:latin typeface="Times New Roman"/>
-                <a:cs typeface="Times New Roman"/>
-              </a:rPr>
-              <a:t>CSS</a:t>
-            </a:r>
-            <a:r>
-              <a:rPr sz="1200" i="1" spc="-20" dirty="0">
-                <a:latin typeface="Times New Roman"/>
-                <a:cs typeface="Times New Roman"/>
-              </a:rPr>
-              <a:t> </a:t>
-            </a:r>
-            <a:r>
-              <a:rPr sz="1200" i="1" dirty="0">
-                <a:latin typeface="Times New Roman"/>
-                <a:cs typeface="Times New Roman"/>
-              </a:rPr>
-              <a:t>styling</a:t>
-            </a:r>
-            <a:r>
-              <a:rPr sz="1200" i="1" spc="-15" dirty="0">
-                <a:latin typeface="Times New Roman"/>
-                <a:cs typeface="Times New Roman"/>
-              </a:rPr>
-              <a:t> </a:t>
-            </a:r>
-            <a:r>
-              <a:rPr sz="1200" i="1" dirty="0">
-                <a:latin typeface="Times New Roman"/>
-                <a:cs typeface="Times New Roman"/>
-              </a:rPr>
-              <a:t>to</a:t>
-            </a:r>
-            <a:r>
-              <a:rPr sz="1200" i="1" spc="-20" dirty="0">
-                <a:latin typeface="Times New Roman"/>
-                <a:cs typeface="Times New Roman"/>
-              </a:rPr>
-              <a:t> </a:t>
-            </a:r>
-            <a:r>
-              <a:rPr sz="1200" i="1" dirty="0">
-                <a:latin typeface="Times New Roman"/>
-                <a:cs typeface="Times New Roman"/>
-              </a:rPr>
-              <a:t>the</a:t>
-            </a:r>
-            <a:r>
-              <a:rPr sz="1200" i="1" spc="-20" dirty="0">
-                <a:latin typeface="Times New Roman"/>
-                <a:cs typeface="Times New Roman"/>
-              </a:rPr>
-              <a:t> </a:t>
-            </a:r>
-            <a:r>
-              <a:rPr sz="1200" i="1" dirty="0">
-                <a:latin typeface="Times New Roman"/>
-                <a:cs typeface="Times New Roman"/>
-              </a:rPr>
-              <a:t>HTML</a:t>
-            </a:r>
-            <a:r>
-              <a:rPr sz="1200" i="1" spc="-25" dirty="0">
-                <a:latin typeface="Times New Roman"/>
-                <a:cs typeface="Times New Roman"/>
-              </a:rPr>
-              <a:t> </a:t>
-            </a:r>
-            <a:r>
-              <a:rPr sz="1200" i="1" spc="-10" dirty="0">
-                <a:latin typeface="Times New Roman"/>
-                <a:cs typeface="Times New Roman"/>
-              </a:rPr>
-              <a:t>page.)</a:t>
-            </a:r>
-            <a:endParaRPr sz="1200">
+              <a:rPr lang="en-US" sz="1200" b="1" dirty="0">
+                <a:latin typeface="Times New Roman"/>
+                <a:cs typeface="Times New Roman"/>
+              </a:rPr>
+              <a:t>File Creation</a:t>
+            </a:r>
+            <a:r>
+              <a:rPr lang="en-US" sz="1200" dirty="0">
+                <a:latin typeface="Times New Roman"/>
+                <a:cs typeface="Times New Roman"/>
+              </a:rPr>
+              <a:t>: Created an external style.css and linked it to index.html using the &lt;link&gt; tag in the head section.</a:t>
+            </a:r>
+          </a:p>
+          <a:p>
+            <a:pPr marL="184150" indent="-171450">
+              <a:lnSpc>
+                <a:spcPct val="100000"/>
+              </a:lnSpc>
+              <a:spcBef>
+                <a:spcPts val="955"/>
+              </a:spcBef>
+              <a:buFont typeface="Arial" panose="020B0604020202020204" pitchFamily="34" charset="0"/>
+              <a:buChar char="•"/>
+            </a:pPr>
+            <a:r>
+              <a:rPr lang="en-US" sz="1200" b="1" dirty="0">
+                <a:latin typeface="Times New Roman"/>
+                <a:cs typeface="Times New Roman"/>
+              </a:rPr>
+              <a:t>Global Reset: </a:t>
+            </a:r>
+            <a:r>
+              <a:rPr lang="en-US" sz="1200" dirty="0">
+                <a:latin typeface="Times New Roman"/>
+                <a:cs typeface="Times New Roman"/>
+              </a:rPr>
+              <a:t>Defined the body background color as #f0f8ff and set a consistent font style.</a:t>
+            </a:r>
+          </a:p>
+          <a:p>
+            <a:pPr marL="184150" indent="-171450">
+              <a:lnSpc>
+                <a:spcPct val="100000"/>
+              </a:lnSpc>
+              <a:spcBef>
+                <a:spcPts val="955"/>
+              </a:spcBef>
+              <a:buFont typeface="Arial" panose="020B0604020202020204" pitchFamily="34" charset="0"/>
+              <a:buChar char="•"/>
+            </a:pPr>
+            <a:r>
+              <a:rPr lang="en-US" sz="1200" b="1" dirty="0">
+                <a:latin typeface="Times New Roman"/>
+                <a:cs typeface="Times New Roman"/>
+              </a:rPr>
+              <a:t>Form Structuring: </a:t>
+            </a:r>
+            <a:r>
+              <a:rPr lang="en-US" sz="1200" dirty="0">
+                <a:latin typeface="Times New Roman"/>
+                <a:cs typeface="Times New Roman"/>
+              </a:rPr>
+              <a:t>Wrapped the registration fields in a card-style layout with a white background and centered it on the page.</a:t>
+            </a:r>
+          </a:p>
+          <a:p>
+            <a:pPr marL="184150" indent="-171450">
+              <a:lnSpc>
+                <a:spcPct val="100000"/>
+              </a:lnSpc>
+              <a:spcBef>
+                <a:spcPts val="955"/>
+              </a:spcBef>
+              <a:buFont typeface="Arial" panose="020B0604020202020204" pitchFamily="34" charset="0"/>
+              <a:buChar char="•"/>
+            </a:pPr>
+            <a:r>
+              <a:rPr lang="en-US" sz="1200" b="1" dirty="0">
+                <a:latin typeface="Times New Roman"/>
+                <a:cs typeface="Times New Roman"/>
+              </a:rPr>
+              <a:t>Field &amp; Label Tuning:</a:t>
+            </a:r>
+            <a:r>
+              <a:rPr lang="en-US" sz="1200" dirty="0">
+                <a:latin typeface="Times New Roman"/>
+                <a:cs typeface="Times New Roman"/>
+              </a:rPr>
+              <a:t> Adjusted input widths and added padding to make text entry comfortable for the user.</a:t>
+            </a:r>
+          </a:p>
+          <a:p>
+            <a:pPr marL="184150" indent="-171450">
+              <a:lnSpc>
+                <a:spcPct val="100000"/>
+              </a:lnSpc>
+              <a:spcBef>
+                <a:spcPts val="955"/>
+              </a:spcBef>
+              <a:buFont typeface="Arial" panose="020B0604020202020204" pitchFamily="34" charset="0"/>
+              <a:buChar char="•"/>
+            </a:pPr>
+            <a:r>
+              <a:rPr lang="en-US" sz="1200" b="1" dirty="0">
+                <a:latin typeface="Times New Roman"/>
+                <a:cs typeface="Times New Roman"/>
+              </a:rPr>
+              <a:t>Validation Logic:</a:t>
+            </a:r>
+            <a:r>
+              <a:rPr lang="en-US" sz="1200" dirty="0">
+                <a:latin typeface="Times New Roman"/>
+                <a:cs typeface="Times New Roman"/>
+              </a:rPr>
+              <a:t> Added CSS rules to change input borders to Green for correct data and Red for errors.</a:t>
+            </a:r>
+          </a:p>
+          <a:p>
+            <a:pPr marL="184150" indent="-171450">
+              <a:lnSpc>
+                <a:spcPct val="100000"/>
+              </a:lnSpc>
+              <a:spcBef>
+                <a:spcPts val="955"/>
+              </a:spcBef>
+              <a:buFont typeface="Arial" panose="020B0604020202020204" pitchFamily="34" charset="0"/>
+              <a:buChar char="•"/>
+            </a:pPr>
+            <a:r>
+              <a:rPr lang="en-US" sz="1200" b="1" dirty="0">
+                <a:latin typeface="Times New Roman"/>
+                <a:cs typeface="Times New Roman"/>
+              </a:rPr>
+              <a:t>Table &amp; Footer Polish:</a:t>
+            </a:r>
+            <a:r>
+              <a:rPr lang="en-US" sz="1200" dirty="0">
+                <a:latin typeface="Times New Roman"/>
+                <a:cs typeface="Times New Roman"/>
+              </a:rPr>
+              <a:t> Styled the participants table with a yellow header and defined a separate background for the contact footer.</a:t>
+            </a:r>
+            <a:endParaRPr sz="1200" dirty="0">
               <a:latin typeface="Times New Roman"/>
               <a:cs typeface="Times New Roman"/>
             </a:endParaRPr>
@@ -9915,7 +9141,7 @@
         </p:nvGrpSpPr>
         <p:grpSpPr>
           <a:xfrm>
-            <a:off x="801369" y="7750809"/>
+            <a:off x="812359" y="10239356"/>
             <a:ext cx="6402705" cy="20955"/>
             <a:chOff x="801369" y="7750809"/>
             <a:chExt cx="6402705" cy="20955"/>
@@ -10231,642 +9457,6 @@
                   </a:lnTo>
                   <a:lnTo>
                     <a:pt x="6402006" y="3048"/>
-                  </a:lnTo>
-                  <a:lnTo>
-                    <a:pt x="6402006" y="0"/>
-                  </a:lnTo>
-                  <a:close/>
-                </a:path>
-              </a:pathLst>
-            </a:custGeom>
-            <a:solidFill>
-              <a:srgbClr val="E2E2E2"/>
-            </a:solidFill>
-          </p:spPr>
-          <p:txBody>
-            <a:bodyPr wrap="square" lIns="0" tIns="0" rIns="0" bIns="0" rtlCol="0"/>
-            <a:lstStyle/>
-            <a:p>
-              <a:endParaRPr/>
-            </a:p>
-          </p:txBody>
-        </p:sp>
-      </p:grpSp>
-      <p:sp>
-        <p:nvSpPr>
-          <p:cNvPr id="43" name="object 43"/>
-          <p:cNvSpPr txBox="1"/>
-          <p:nvPr/>
-        </p:nvSpPr>
-        <p:spPr>
-          <a:xfrm>
-            <a:off x="763320" y="8087105"/>
-            <a:ext cx="6421120" cy="717550"/>
-          </a:xfrm>
-          <a:prstGeom prst="rect">
-            <a:avLst/>
-          </a:prstGeom>
-        </p:spPr>
-        <p:txBody>
-          <a:bodyPr vert="horz" wrap="square" lIns="0" tIns="12700" rIns="0" bIns="0" rtlCol="0">
-            <a:spAutoFit/>
-          </a:bodyPr>
-          <a:lstStyle/>
-          <a:p>
-            <a:pPr marL="12700">
-              <a:lnSpc>
-                <a:spcPct val="100000"/>
-              </a:lnSpc>
-              <a:spcBef>
-                <a:spcPts val="100"/>
-              </a:spcBef>
-            </a:pPr>
-            <a:r>
-              <a:rPr sz="1400" b="1" spc="-10" dirty="0">
-                <a:solidFill>
-                  <a:srgbClr val="3B78D7"/>
-                </a:solidFill>
-                <a:latin typeface="Cambria"/>
-                <a:cs typeface="Cambria"/>
-              </a:rPr>
-              <a:t>6.Output:</a:t>
-            </a:r>
-            <a:endParaRPr sz="1400">
-              <a:latin typeface="Cambria"/>
-              <a:cs typeface="Cambria"/>
-            </a:endParaRPr>
-          </a:p>
-          <a:p>
-            <a:pPr marL="45720" marR="5080">
-              <a:lnSpc>
-                <a:spcPts val="1380"/>
-              </a:lnSpc>
-              <a:spcBef>
-                <a:spcPts val="1045"/>
-              </a:spcBef>
-            </a:pPr>
-            <a:r>
-              <a:rPr sz="1200" i="1" dirty="0">
-                <a:latin typeface="Times New Roman"/>
-                <a:cs typeface="Times New Roman"/>
-              </a:rPr>
-              <a:t>(Attach</a:t>
-            </a:r>
-            <a:r>
-              <a:rPr sz="1200" i="1" spc="-25" dirty="0">
-                <a:latin typeface="Times New Roman"/>
-                <a:cs typeface="Times New Roman"/>
-              </a:rPr>
-              <a:t> </a:t>
-            </a:r>
-            <a:r>
-              <a:rPr sz="1200" i="1" dirty="0">
-                <a:latin typeface="Times New Roman"/>
-                <a:cs typeface="Times New Roman"/>
-              </a:rPr>
-              <a:t>screenshots</a:t>
-            </a:r>
-            <a:r>
-              <a:rPr sz="1200" i="1" spc="-30" dirty="0">
-                <a:latin typeface="Times New Roman"/>
-                <a:cs typeface="Times New Roman"/>
-              </a:rPr>
-              <a:t> </a:t>
-            </a:r>
-            <a:r>
-              <a:rPr sz="1200" i="1" dirty="0">
-                <a:latin typeface="Times New Roman"/>
-                <a:cs typeface="Times New Roman"/>
-              </a:rPr>
-              <a:t>of</a:t>
-            </a:r>
-            <a:r>
-              <a:rPr sz="1200" i="1" spc="-20" dirty="0">
-                <a:latin typeface="Times New Roman"/>
-                <a:cs typeface="Times New Roman"/>
-              </a:rPr>
-              <a:t> </a:t>
-            </a:r>
-            <a:r>
-              <a:rPr sz="1200" i="1" dirty="0">
-                <a:latin typeface="Times New Roman"/>
-                <a:cs typeface="Times New Roman"/>
-              </a:rPr>
-              <a:t>the</a:t>
-            </a:r>
-            <a:r>
-              <a:rPr sz="1200" i="1" spc="-30" dirty="0">
-                <a:latin typeface="Times New Roman"/>
-                <a:cs typeface="Times New Roman"/>
-              </a:rPr>
-              <a:t> </a:t>
-            </a:r>
-            <a:r>
-              <a:rPr sz="1200" i="1" dirty="0">
-                <a:latin typeface="Times New Roman"/>
-                <a:cs typeface="Times New Roman"/>
-              </a:rPr>
-              <a:t>fully</a:t>
-            </a:r>
-            <a:r>
-              <a:rPr sz="1200" i="1" spc="-20" dirty="0">
-                <a:latin typeface="Times New Roman"/>
-                <a:cs typeface="Times New Roman"/>
-              </a:rPr>
-              <a:t> </a:t>
-            </a:r>
-            <a:r>
-              <a:rPr sz="1200" i="1" dirty="0">
-                <a:latin typeface="Times New Roman"/>
-                <a:cs typeface="Times New Roman"/>
-              </a:rPr>
-              <a:t>styled</a:t>
-            </a:r>
-            <a:r>
-              <a:rPr sz="1200" i="1" spc="-25" dirty="0">
-                <a:latin typeface="Times New Roman"/>
-                <a:cs typeface="Times New Roman"/>
-              </a:rPr>
-              <a:t> </a:t>
-            </a:r>
-            <a:r>
-              <a:rPr sz="1200" i="1" dirty="0">
-                <a:latin typeface="Times New Roman"/>
-                <a:cs typeface="Times New Roman"/>
-              </a:rPr>
-              <a:t>webpage,</a:t>
-            </a:r>
-            <a:r>
-              <a:rPr sz="1200" i="1" spc="-25" dirty="0">
-                <a:latin typeface="Times New Roman"/>
-                <a:cs typeface="Times New Roman"/>
-              </a:rPr>
-              <a:t> </a:t>
-            </a:r>
-            <a:r>
-              <a:rPr sz="1200" i="1" dirty="0">
-                <a:latin typeface="Times New Roman"/>
-                <a:cs typeface="Times New Roman"/>
-              </a:rPr>
-              <a:t>including</a:t>
-            </a:r>
-            <a:r>
-              <a:rPr sz="1200" i="1" spc="-20" dirty="0">
-                <a:latin typeface="Times New Roman"/>
-                <a:cs typeface="Times New Roman"/>
-              </a:rPr>
-              <a:t> </a:t>
-            </a:r>
-            <a:r>
-              <a:rPr sz="1200" i="1" dirty="0">
-                <a:latin typeface="Times New Roman"/>
-                <a:cs typeface="Times New Roman"/>
-              </a:rPr>
-              <a:t>the</a:t>
-            </a:r>
-            <a:r>
-              <a:rPr sz="1200" i="1" spc="-25" dirty="0">
-                <a:latin typeface="Times New Roman"/>
-                <a:cs typeface="Times New Roman"/>
-              </a:rPr>
-              <a:t> </a:t>
-            </a:r>
-            <a:r>
-              <a:rPr sz="1200" i="1" dirty="0">
-                <a:latin typeface="Times New Roman"/>
-                <a:cs typeface="Times New Roman"/>
-              </a:rPr>
-              <a:t>form,</a:t>
-            </a:r>
-            <a:r>
-              <a:rPr sz="1200" i="1" spc="-20" dirty="0">
-                <a:latin typeface="Times New Roman"/>
-                <a:cs typeface="Times New Roman"/>
-              </a:rPr>
-              <a:t> </a:t>
-            </a:r>
-            <a:r>
-              <a:rPr sz="1200" i="1" dirty="0">
-                <a:latin typeface="Times New Roman"/>
-                <a:cs typeface="Times New Roman"/>
-              </a:rPr>
-              <a:t>table,</a:t>
-            </a:r>
-            <a:r>
-              <a:rPr sz="1200" i="1" spc="-25" dirty="0">
-                <a:latin typeface="Times New Roman"/>
-                <a:cs typeface="Times New Roman"/>
-              </a:rPr>
-              <a:t> </a:t>
-            </a:r>
-            <a:r>
-              <a:rPr sz="1200" i="1" dirty="0">
-                <a:latin typeface="Times New Roman"/>
-                <a:cs typeface="Times New Roman"/>
-              </a:rPr>
-              <a:t>and</a:t>
-            </a:r>
-            <a:r>
-              <a:rPr sz="1200" i="1" spc="-20" dirty="0">
-                <a:latin typeface="Times New Roman"/>
-                <a:cs typeface="Times New Roman"/>
-              </a:rPr>
-              <a:t> </a:t>
-            </a:r>
-            <a:r>
-              <a:rPr sz="1200" i="1" dirty="0">
-                <a:latin typeface="Times New Roman"/>
-                <a:cs typeface="Times New Roman"/>
-              </a:rPr>
-              <a:t>footer,</a:t>
-            </a:r>
-            <a:r>
-              <a:rPr sz="1200" i="1" spc="-25" dirty="0">
-                <a:latin typeface="Times New Roman"/>
-                <a:cs typeface="Times New Roman"/>
-              </a:rPr>
-              <a:t> </a:t>
-            </a:r>
-            <a:r>
-              <a:rPr sz="1200" i="1" dirty="0">
-                <a:latin typeface="Times New Roman"/>
-                <a:cs typeface="Times New Roman"/>
-              </a:rPr>
-              <a:t>to</a:t>
-            </a:r>
-            <a:r>
-              <a:rPr sz="1200" i="1" spc="-25" dirty="0">
-                <a:latin typeface="Times New Roman"/>
-                <a:cs typeface="Times New Roman"/>
-              </a:rPr>
-              <a:t> </a:t>
-            </a:r>
-            <a:r>
-              <a:rPr sz="1200" i="1" dirty="0">
-                <a:latin typeface="Times New Roman"/>
-                <a:cs typeface="Times New Roman"/>
-              </a:rPr>
-              <a:t>demonstrate</a:t>
-            </a:r>
-            <a:r>
-              <a:rPr sz="1200" i="1" spc="-25" dirty="0">
-                <a:latin typeface="Times New Roman"/>
-                <a:cs typeface="Times New Roman"/>
-              </a:rPr>
-              <a:t> the </a:t>
-            </a:r>
-            <a:r>
-              <a:rPr sz="1200" i="1" dirty="0">
-                <a:latin typeface="Times New Roman"/>
-                <a:cs typeface="Times New Roman"/>
-              </a:rPr>
-              <a:t>final</a:t>
-            </a:r>
-            <a:r>
-              <a:rPr sz="1200" i="1" spc="-30" dirty="0">
-                <a:latin typeface="Times New Roman"/>
-                <a:cs typeface="Times New Roman"/>
-              </a:rPr>
-              <a:t> </a:t>
-            </a:r>
-            <a:r>
-              <a:rPr sz="1200" i="1" spc="-10" dirty="0">
-                <a:latin typeface="Times New Roman"/>
-                <a:cs typeface="Times New Roman"/>
-              </a:rPr>
-              <a:t>output.)</a:t>
-            </a:r>
-            <a:endParaRPr sz="1200">
-              <a:latin typeface="Times New Roman"/>
-              <a:cs typeface="Times New Roman"/>
-            </a:endParaRPr>
-          </a:p>
-        </p:txBody>
-      </p:sp>
-      <p:grpSp>
-        <p:nvGrpSpPr>
-          <p:cNvPr id="44" name="object 44"/>
-          <p:cNvGrpSpPr/>
-          <p:nvPr/>
-        </p:nvGrpSpPr>
-        <p:grpSpPr>
-          <a:xfrm>
-            <a:off x="801369" y="9223375"/>
-            <a:ext cx="6402705" cy="20955"/>
-            <a:chOff x="801369" y="9223375"/>
-            <a:chExt cx="6402705" cy="20955"/>
-          </a:xfrm>
-        </p:grpSpPr>
-        <p:sp>
-          <p:nvSpPr>
-            <p:cNvPr id="45" name="object 45"/>
-            <p:cNvSpPr/>
-            <p:nvPr/>
-          </p:nvSpPr>
-          <p:spPr>
-            <a:xfrm>
-              <a:off x="801370" y="9223387"/>
-              <a:ext cx="6400800" cy="19685"/>
-            </a:xfrm>
-            <a:custGeom>
-              <a:avLst/>
-              <a:gdLst/>
-              <a:ahLst/>
-              <a:cxnLst/>
-              <a:rect l="l" t="t" r="r" b="b"/>
-              <a:pathLst>
-                <a:path w="6400800" h="19684">
-                  <a:moveTo>
-                    <a:pt x="6400800" y="0"/>
-                  </a:moveTo>
-                  <a:lnTo>
-                    <a:pt x="0" y="0"/>
-                  </a:lnTo>
-                  <a:lnTo>
-                    <a:pt x="0" y="19672"/>
-                  </a:lnTo>
-                  <a:lnTo>
-                    <a:pt x="6400800" y="19672"/>
-                  </a:lnTo>
-                  <a:lnTo>
-                    <a:pt x="6400800" y="0"/>
-                  </a:lnTo>
-                  <a:close/>
-                </a:path>
-              </a:pathLst>
-            </a:custGeom>
-            <a:solidFill>
-              <a:srgbClr val="9F9F9F"/>
-            </a:solidFill>
-          </p:spPr>
-          <p:txBody>
-            <a:bodyPr wrap="square" lIns="0" tIns="0" rIns="0" bIns="0" rtlCol="0"/>
-            <a:lstStyle/>
-            <a:p>
-              <a:endParaRPr/>
-            </a:p>
-          </p:txBody>
-        </p:sp>
-        <p:sp>
-          <p:nvSpPr>
-            <p:cNvPr id="46" name="object 46"/>
-            <p:cNvSpPr/>
-            <p:nvPr/>
-          </p:nvSpPr>
-          <p:spPr>
-            <a:xfrm>
-              <a:off x="7200899" y="9224518"/>
-              <a:ext cx="3175" cy="3175"/>
-            </a:xfrm>
-            <a:custGeom>
-              <a:avLst/>
-              <a:gdLst/>
-              <a:ahLst/>
-              <a:cxnLst/>
-              <a:rect l="l" t="t" r="r" b="b"/>
-              <a:pathLst>
-                <a:path w="3175" h="3175">
-                  <a:moveTo>
-                    <a:pt x="3047" y="0"/>
-                  </a:moveTo>
-                  <a:lnTo>
-                    <a:pt x="0" y="0"/>
-                  </a:lnTo>
-                  <a:lnTo>
-                    <a:pt x="0" y="3047"/>
-                  </a:lnTo>
-                  <a:lnTo>
-                    <a:pt x="3047" y="3047"/>
-                  </a:lnTo>
-                  <a:lnTo>
-                    <a:pt x="3047" y="0"/>
-                  </a:lnTo>
-                  <a:close/>
-                </a:path>
-              </a:pathLst>
-            </a:custGeom>
-            <a:solidFill>
-              <a:srgbClr val="E2E2E2"/>
-            </a:solidFill>
-          </p:spPr>
-          <p:txBody>
-            <a:bodyPr wrap="square" lIns="0" tIns="0" rIns="0" bIns="0" rtlCol="0"/>
-            <a:lstStyle/>
-            <a:p>
-              <a:endParaRPr/>
-            </a:p>
-          </p:txBody>
-        </p:sp>
-        <p:sp>
-          <p:nvSpPr>
-            <p:cNvPr id="47" name="object 47"/>
-            <p:cNvSpPr/>
-            <p:nvPr/>
-          </p:nvSpPr>
-          <p:spPr>
-            <a:xfrm>
-              <a:off x="801928" y="9224530"/>
-              <a:ext cx="6402070" cy="17145"/>
-            </a:xfrm>
-            <a:custGeom>
-              <a:avLst/>
-              <a:gdLst/>
-              <a:ahLst/>
-              <a:cxnLst/>
-              <a:rect l="l" t="t" r="r" b="b"/>
-              <a:pathLst>
-                <a:path w="6402070" h="17145">
-                  <a:moveTo>
-                    <a:pt x="3048" y="3035"/>
-                  </a:moveTo>
-                  <a:lnTo>
-                    <a:pt x="0" y="3035"/>
-                  </a:lnTo>
-                  <a:lnTo>
-                    <a:pt x="0" y="16751"/>
-                  </a:lnTo>
-                  <a:lnTo>
-                    <a:pt x="3048" y="16751"/>
-                  </a:lnTo>
-                  <a:lnTo>
-                    <a:pt x="3048" y="3035"/>
-                  </a:lnTo>
-                  <a:close/>
-                </a:path>
-                <a:path w="6402070" h="17145">
-                  <a:moveTo>
-                    <a:pt x="6402006" y="0"/>
-                  </a:moveTo>
-                  <a:lnTo>
-                    <a:pt x="6398971" y="0"/>
-                  </a:lnTo>
-                  <a:lnTo>
-                    <a:pt x="6398971" y="3035"/>
-                  </a:lnTo>
-                  <a:lnTo>
-                    <a:pt x="6402006" y="3035"/>
-                  </a:lnTo>
-                  <a:lnTo>
-                    <a:pt x="6402006" y="0"/>
-                  </a:lnTo>
-                  <a:close/>
-                </a:path>
-              </a:pathLst>
-            </a:custGeom>
-            <a:solidFill>
-              <a:srgbClr val="9F9F9F"/>
-            </a:solidFill>
-          </p:spPr>
-          <p:txBody>
-            <a:bodyPr wrap="square" lIns="0" tIns="0" rIns="0" bIns="0" rtlCol="0"/>
-            <a:lstStyle/>
-            <a:p>
-              <a:endParaRPr/>
-            </a:p>
-          </p:txBody>
-        </p:sp>
-        <p:sp>
-          <p:nvSpPr>
-            <p:cNvPr id="48" name="object 48"/>
-            <p:cNvSpPr/>
-            <p:nvPr/>
-          </p:nvSpPr>
-          <p:spPr>
-            <a:xfrm>
-              <a:off x="7200899" y="9227566"/>
-              <a:ext cx="3175" cy="13970"/>
-            </a:xfrm>
-            <a:custGeom>
-              <a:avLst/>
-              <a:gdLst/>
-              <a:ahLst/>
-              <a:cxnLst/>
-              <a:rect l="l" t="t" r="r" b="b"/>
-              <a:pathLst>
-                <a:path w="3175" h="13970">
-                  <a:moveTo>
-                    <a:pt x="3047" y="0"/>
-                  </a:moveTo>
-                  <a:lnTo>
-                    <a:pt x="0" y="0"/>
-                  </a:lnTo>
-                  <a:lnTo>
-                    <a:pt x="0" y="13716"/>
-                  </a:lnTo>
-                  <a:lnTo>
-                    <a:pt x="3047" y="13716"/>
-                  </a:lnTo>
-                  <a:lnTo>
-                    <a:pt x="3047" y="0"/>
-                  </a:lnTo>
-                  <a:close/>
-                </a:path>
-              </a:pathLst>
-            </a:custGeom>
-            <a:solidFill>
-              <a:srgbClr val="E2E2E2"/>
-            </a:solidFill>
-          </p:spPr>
-          <p:txBody>
-            <a:bodyPr wrap="square" lIns="0" tIns="0" rIns="0" bIns="0" rtlCol="0"/>
-            <a:lstStyle/>
-            <a:p>
-              <a:endParaRPr/>
-            </a:p>
-          </p:txBody>
-        </p:sp>
-        <p:sp>
-          <p:nvSpPr>
-            <p:cNvPr id="49" name="object 49"/>
-            <p:cNvSpPr/>
-            <p:nvPr/>
-          </p:nvSpPr>
-          <p:spPr>
-            <a:xfrm>
-              <a:off x="801928" y="9241282"/>
-              <a:ext cx="3175" cy="3175"/>
-            </a:xfrm>
-            <a:custGeom>
-              <a:avLst/>
-              <a:gdLst/>
-              <a:ahLst/>
-              <a:cxnLst/>
-              <a:rect l="l" t="t" r="r" b="b"/>
-              <a:pathLst>
-                <a:path w="3175" h="3175">
-                  <a:moveTo>
-                    <a:pt x="3048" y="0"/>
-                  </a:moveTo>
-                  <a:lnTo>
-                    <a:pt x="0" y="0"/>
-                  </a:lnTo>
-                  <a:lnTo>
-                    <a:pt x="0" y="3047"/>
-                  </a:lnTo>
-                  <a:lnTo>
-                    <a:pt x="3048" y="3047"/>
-                  </a:lnTo>
-                  <a:lnTo>
-                    <a:pt x="3048" y="0"/>
-                  </a:lnTo>
-                  <a:close/>
-                </a:path>
-              </a:pathLst>
-            </a:custGeom>
-            <a:solidFill>
-              <a:srgbClr val="9F9F9F"/>
-            </a:solidFill>
-          </p:spPr>
-          <p:txBody>
-            <a:bodyPr wrap="square" lIns="0" tIns="0" rIns="0" bIns="0" rtlCol="0"/>
-            <a:lstStyle/>
-            <a:p>
-              <a:endParaRPr/>
-            </a:p>
-          </p:txBody>
-        </p:sp>
-        <p:sp>
-          <p:nvSpPr>
-            <p:cNvPr id="50" name="object 50"/>
-            <p:cNvSpPr/>
-            <p:nvPr/>
-          </p:nvSpPr>
-          <p:spPr>
-            <a:xfrm>
-              <a:off x="801928" y="9241294"/>
-              <a:ext cx="6402070" cy="3175"/>
-            </a:xfrm>
-            <a:custGeom>
-              <a:avLst/>
-              <a:gdLst/>
-              <a:ahLst/>
-              <a:cxnLst/>
-              <a:rect l="l" t="t" r="r" b="b"/>
-              <a:pathLst>
-                <a:path w="6402070" h="3175">
-                  <a:moveTo>
-                    <a:pt x="6402006" y="0"/>
-                  </a:moveTo>
-                  <a:lnTo>
-                    <a:pt x="6399022" y="0"/>
-                  </a:lnTo>
-                  <a:lnTo>
-                    <a:pt x="3048" y="0"/>
-                  </a:lnTo>
-                  <a:lnTo>
-                    <a:pt x="0" y="0"/>
-                  </a:lnTo>
-                  <a:lnTo>
-                    <a:pt x="0" y="3035"/>
-                  </a:lnTo>
-                  <a:lnTo>
-                    <a:pt x="3048" y="3035"/>
-                  </a:lnTo>
-                  <a:lnTo>
-                    <a:pt x="6398971" y="3035"/>
-                  </a:lnTo>
-                  <a:lnTo>
-                    <a:pt x="6402006" y="3035"/>
                   </a:lnTo>
                   <a:lnTo>
                     <a:pt x="6402006" y="0"/>
@@ -10993,7 +9583,7 @@
         </p:blipFill>
         <p:spPr>
           <a:xfrm>
-            <a:off x="5959475" y="361949"/>
+            <a:off x="5953797" y="359009"/>
             <a:ext cx="1074407" cy="401954"/>
           </a:xfrm>
           <a:prstGeom prst="rect">
@@ -11015,7 +9605,7 @@
         </p:blipFill>
         <p:spPr>
           <a:xfrm>
-            <a:off x="3997325" y="342937"/>
+            <a:off x="4188074" y="342899"/>
             <a:ext cx="996314" cy="434174"/>
           </a:xfrm>
           <a:prstGeom prst="rect">
@@ -11031,8 +9621,8 @@
         </p:nvSpPr>
         <p:spPr>
           <a:xfrm>
-            <a:off x="790752" y="868425"/>
-            <a:ext cx="6021705" cy="717550"/>
+            <a:off x="616586" y="6395219"/>
+            <a:ext cx="6021705" cy="2177519"/>
           </a:xfrm>
           <a:prstGeom prst="rect">
             <a:avLst/>
@@ -11082,7 +9672,7 @@
               </a:rPr>
               <a:t>Outcome:</a:t>
             </a:r>
-            <a:endParaRPr sz="1400">
+            <a:endParaRPr sz="1400" dirty="0">
               <a:latin typeface="Times New Roman"/>
               <a:cs typeface="Times New Roman"/>
             </a:endParaRPr>
@@ -11097,181 +9687,92 @@
               </a:spcBef>
             </a:pPr>
             <a:r>
-              <a:rPr sz="1200" i="1" dirty="0">
-                <a:latin typeface="Times New Roman"/>
-                <a:cs typeface="Times New Roman"/>
-              </a:rPr>
-              <a:t>(Explain</a:t>
-            </a:r>
-            <a:r>
-              <a:rPr sz="1200" i="1" spc="-30" dirty="0">
-                <a:latin typeface="Times New Roman"/>
-                <a:cs typeface="Times New Roman"/>
-              </a:rPr>
-              <a:t> </a:t>
-            </a:r>
-            <a:r>
-              <a:rPr sz="1200" i="1" dirty="0">
-                <a:latin typeface="Times New Roman"/>
-                <a:cs typeface="Times New Roman"/>
-              </a:rPr>
-              <a:t>the</a:t>
-            </a:r>
-            <a:r>
-              <a:rPr sz="1200" i="1" spc="-25" dirty="0">
-                <a:latin typeface="Times New Roman"/>
-                <a:cs typeface="Times New Roman"/>
-              </a:rPr>
-              <a:t> </a:t>
-            </a:r>
-            <a:r>
-              <a:rPr sz="1200" i="1" dirty="0">
-                <a:latin typeface="Times New Roman"/>
-                <a:cs typeface="Times New Roman"/>
-              </a:rPr>
-              <a:t>skills</a:t>
-            </a:r>
-            <a:r>
-              <a:rPr sz="1200" i="1" spc="-30" dirty="0">
-                <a:latin typeface="Times New Roman"/>
-                <a:cs typeface="Times New Roman"/>
-              </a:rPr>
-              <a:t> </a:t>
-            </a:r>
-            <a:r>
-              <a:rPr sz="1200" i="1" dirty="0">
-                <a:latin typeface="Times New Roman"/>
-                <a:cs typeface="Times New Roman"/>
-              </a:rPr>
-              <a:t>and</a:t>
-            </a:r>
-            <a:r>
-              <a:rPr sz="1200" i="1" spc="-25" dirty="0">
-                <a:latin typeface="Times New Roman"/>
-                <a:cs typeface="Times New Roman"/>
-              </a:rPr>
-              <a:t> </a:t>
-            </a:r>
-            <a:r>
-              <a:rPr sz="1200" i="1" dirty="0">
-                <a:latin typeface="Times New Roman"/>
-                <a:cs typeface="Times New Roman"/>
-              </a:rPr>
-              <a:t>understanding</a:t>
-            </a:r>
-            <a:r>
-              <a:rPr sz="1200" i="1" spc="-25" dirty="0">
-                <a:latin typeface="Times New Roman"/>
-                <a:cs typeface="Times New Roman"/>
-              </a:rPr>
-              <a:t> </a:t>
-            </a:r>
-            <a:r>
-              <a:rPr sz="1200" i="1" dirty="0">
-                <a:latin typeface="Times New Roman"/>
-                <a:cs typeface="Times New Roman"/>
-              </a:rPr>
-              <a:t>gained</a:t>
-            </a:r>
-            <a:r>
-              <a:rPr sz="1200" i="1" spc="-25" dirty="0">
-                <a:latin typeface="Times New Roman"/>
-                <a:cs typeface="Times New Roman"/>
-              </a:rPr>
-              <a:t> </a:t>
-            </a:r>
-            <a:r>
-              <a:rPr sz="1200" i="1" dirty="0">
-                <a:latin typeface="Times New Roman"/>
-                <a:cs typeface="Times New Roman"/>
-              </a:rPr>
-              <a:t>about</a:t>
-            </a:r>
-            <a:r>
-              <a:rPr sz="1200" i="1" spc="-30" dirty="0">
-                <a:latin typeface="Times New Roman"/>
-                <a:cs typeface="Times New Roman"/>
-              </a:rPr>
-              <a:t> </a:t>
-            </a:r>
-            <a:r>
-              <a:rPr sz="1200" i="1" dirty="0">
-                <a:latin typeface="Times New Roman"/>
-                <a:cs typeface="Times New Roman"/>
-              </a:rPr>
-              <a:t>CSS</a:t>
-            </a:r>
-            <a:r>
-              <a:rPr sz="1200" i="1" spc="-25" dirty="0">
-                <a:latin typeface="Times New Roman"/>
-                <a:cs typeface="Times New Roman"/>
-              </a:rPr>
-              <a:t> </a:t>
-            </a:r>
-            <a:r>
-              <a:rPr sz="1200" i="1" dirty="0">
-                <a:latin typeface="Times New Roman"/>
-                <a:cs typeface="Times New Roman"/>
-              </a:rPr>
-              <a:t>styling,</a:t>
-            </a:r>
-            <a:r>
-              <a:rPr sz="1200" i="1" spc="-25" dirty="0">
-                <a:latin typeface="Times New Roman"/>
-                <a:cs typeface="Times New Roman"/>
-              </a:rPr>
-              <a:t> </a:t>
-            </a:r>
-            <a:r>
-              <a:rPr sz="1200" i="1" dirty="0">
-                <a:latin typeface="Times New Roman"/>
-                <a:cs typeface="Times New Roman"/>
-              </a:rPr>
-              <a:t>layout</a:t>
-            </a:r>
-            <a:r>
-              <a:rPr sz="1200" i="1" spc="-25" dirty="0">
-                <a:latin typeface="Times New Roman"/>
-                <a:cs typeface="Times New Roman"/>
-              </a:rPr>
-              <a:t> </a:t>
-            </a:r>
-            <a:r>
-              <a:rPr sz="1200" i="1" dirty="0">
-                <a:latin typeface="Times New Roman"/>
-                <a:cs typeface="Times New Roman"/>
-              </a:rPr>
-              <a:t>control,</a:t>
-            </a:r>
-            <a:r>
-              <a:rPr sz="1200" i="1" spc="-25" dirty="0">
-                <a:latin typeface="Times New Roman"/>
-                <a:cs typeface="Times New Roman"/>
-              </a:rPr>
-              <a:t> </a:t>
-            </a:r>
-            <a:r>
-              <a:rPr sz="1200" i="1" dirty="0">
-                <a:latin typeface="Times New Roman"/>
-                <a:cs typeface="Times New Roman"/>
-              </a:rPr>
-              <a:t>and</a:t>
-            </a:r>
-            <a:r>
-              <a:rPr sz="1200" i="1" spc="-25" dirty="0">
-                <a:latin typeface="Times New Roman"/>
-                <a:cs typeface="Times New Roman"/>
-              </a:rPr>
-              <a:t> </a:t>
-            </a:r>
-            <a:r>
-              <a:rPr sz="1200" i="1" spc="-10" dirty="0">
-                <a:latin typeface="Times New Roman"/>
-                <a:cs typeface="Times New Roman"/>
-              </a:rPr>
-              <a:t>presentation design.)</a:t>
-            </a:r>
-            <a:endParaRPr sz="1200">
+              <a:rPr lang="en-US" sz="1300" b="1" dirty="0">
+                <a:latin typeface="Times New Roman"/>
+                <a:cs typeface="Times New Roman"/>
+              </a:rPr>
+              <a:t>Layout Mastery</a:t>
+            </a:r>
+            <a:r>
+              <a:rPr lang="en-US" sz="1300" dirty="0">
+                <a:latin typeface="Times New Roman"/>
+                <a:cs typeface="Times New Roman"/>
+              </a:rPr>
+              <a:t>: I learned how to use the CSS Box Model to turn a vertical list of HTML tags into a balanced, centered interface.</a:t>
+            </a:r>
+          </a:p>
+          <a:p>
+            <a:pPr marL="108585" marR="5080">
+              <a:lnSpc>
+                <a:spcPts val="1390"/>
+              </a:lnSpc>
+              <a:spcBef>
+                <a:spcPts val="1019"/>
+              </a:spcBef>
+            </a:pPr>
+            <a:r>
+              <a:rPr lang="en-US" sz="1300" b="1" dirty="0">
+                <a:latin typeface="Times New Roman"/>
+                <a:cs typeface="Times New Roman"/>
+              </a:rPr>
+              <a:t>Visual Design</a:t>
+            </a:r>
+            <a:r>
+              <a:rPr lang="en-US" sz="1300" dirty="0">
+                <a:latin typeface="Times New Roman"/>
+                <a:cs typeface="Times New Roman"/>
+              </a:rPr>
+              <a:t>: I understood how small details like border-radius and box-shadow can make a website look modern rather than basic.</a:t>
+            </a:r>
+          </a:p>
+          <a:p>
+            <a:pPr marL="108585" marR="5080">
+              <a:lnSpc>
+                <a:spcPts val="1390"/>
+              </a:lnSpc>
+              <a:spcBef>
+                <a:spcPts val="1019"/>
+              </a:spcBef>
+            </a:pPr>
+            <a:r>
+              <a:rPr lang="en-US" sz="1300" b="1" dirty="0">
+                <a:latin typeface="Times New Roman"/>
+                <a:cs typeface="Times New Roman"/>
+              </a:rPr>
+              <a:t>User Feedback: </a:t>
+            </a:r>
+            <a:r>
+              <a:rPr lang="en-US" sz="1300" dirty="0">
+                <a:latin typeface="Times New Roman"/>
+                <a:cs typeface="Times New Roman"/>
+              </a:rPr>
+              <a:t>I discovered how to use CSS validation to provide instant visual feedback to users without needing complex scripts.</a:t>
+            </a:r>
+          </a:p>
+          <a:p>
+            <a:pPr marL="108585" marR="5080">
+              <a:lnSpc>
+                <a:spcPts val="1390"/>
+              </a:lnSpc>
+              <a:spcBef>
+                <a:spcPts val="1019"/>
+              </a:spcBef>
+            </a:pPr>
+            <a:r>
+              <a:rPr lang="en-US" sz="1300" b="1" dirty="0">
+                <a:latin typeface="Times New Roman"/>
+                <a:cs typeface="Times New Roman"/>
+              </a:rPr>
+              <a:t>Organization:</a:t>
+            </a:r>
+            <a:r>
+              <a:rPr lang="en-US" sz="1300" dirty="0">
+                <a:latin typeface="Times New Roman"/>
+                <a:cs typeface="Times New Roman"/>
+              </a:rPr>
+              <a:t> I learned the importance of using an external stylesheet (style.css) to keep my project code clean and manageable.</a:t>
+            </a:r>
+            <a:endParaRPr sz="1300" dirty="0">
               <a:latin typeface="Times New Roman"/>
               <a:cs typeface="Times New Roman"/>
             </a:endParaRPr>
@@ -11286,10 +9787,10 @@
         </p:nvGrpSpPr>
         <p:grpSpPr>
           <a:xfrm>
-            <a:off x="801369" y="2019299"/>
-            <a:ext cx="6402705" cy="20320"/>
-            <a:chOff x="801369" y="2019299"/>
-            <a:chExt cx="6402705" cy="20320"/>
+            <a:off x="493079" y="8702675"/>
+            <a:ext cx="6402704" cy="20193"/>
+            <a:chOff x="801370" y="2019299"/>
+            <a:chExt cx="6402704" cy="20193"/>
           </a:xfrm>
         </p:grpSpPr>
         <p:sp>
@@ -11631,8 +10132,8 @@
         </p:nvSpPr>
         <p:spPr>
           <a:xfrm>
-            <a:off x="821232" y="2224785"/>
-            <a:ext cx="6155690" cy="741680"/>
+            <a:off x="616586" y="8852805"/>
+            <a:ext cx="6155690" cy="1100301"/>
           </a:xfrm>
           <a:prstGeom prst="rect">
             <a:avLst/>
@@ -11682,224 +10183,30 @@
               </a:rPr>
               <a:t>Conclusion:</a:t>
             </a:r>
-            <a:endParaRPr sz="1400">
+            <a:endParaRPr sz="1400" dirty="0">
               <a:latin typeface="Times New Roman"/>
               <a:cs typeface="Times New Roman"/>
             </a:endParaRPr>
           </a:p>
           <a:p>
-            <a:pPr marL="78105" marR="5080">
+            <a:pPr marL="249555" marR="5080" indent="-171450">
               <a:lnSpc>
                 <a:spcPts val="1380"/>
               </a:lnSpc>
               <a:spcBef>
                 <a:spcPts val="1235"/>
               </a:spcBef>
+              <a:buFont typeface="Arial" panose="020B0604020202020204" pitchFamily="34" charset="0"/>
+              <a:buChar char="•"/>
             </a:pPr>
             <a:r>
-              <a:rPr sz="1200" i="1" dirty="0">
-                <a:latin typeface="Times New Roman"/>
-                <a:cs typeface="Times New Roman"/>
-              </a:rPr>
-              <a:t>(Summarize</a:t>
-            </a:r>
-            <a:r>
-              <a:rPr sz="1200" i="1" spc="-25" dirty="0">
-                <a:latin typeface="Times New Roman"/>
-                <a:cs typeface="Times New Roman"/>
-              </a:rPr>
-              <a:t> </a:t>
-            </a:r>
-            <a:r>
-              <a:rPr sz="1200" i="1" dirty="0">
-                <a:latin typeface="Times New Roman"/>
-                <a:cs typeface="Times New Roman"/>
-              </a:rPr>
-              <a:t>how</a:t>
-            </a:r>
-            <a:r>
-              <a:rPr sz="1200" i="1" spc="-20" dirty="0">
-                <a:latin typeface="Times New Roman"/>
-                <a:cs typeface="Times New Roman"/>
-              </a:rPr>
-              <a:t> </a:t>
-            </a:r>
-            <a:r>
-              <a:rPr sz="1200" i="1" dirty="0">
-                <a:latin typeface="Times New Roman"/>
-                <a:cs typeface="Times New Roman"/>
-              </a:rPr>
-              <a:t>the</a:t>
-            </a:r>
-            <a:r>
-              <a:rPr sz="1200" i="1" spc="-25" dirty="0">
-                <a:latin typeface="Times New Roman"/>
-                <a:cs typeface="Times New Roman"/>
-              </a:rPr>
-              <a:t> </a:t>
-            </a:r>
-            <a:r>
-              <a:rPr sz="1200" i="1" dirty="0">
-                <a:latin typeface="Times New Roman"/>
-                <a:cs typeface="Times New Roman"/>
-              </a:rPr>
-              <a:t>HTML</a:t>
-            </a:r>
-            <a:r>
-              <a:rPr sz="1200" i="1" spc="-20" dirty="0">
-                <a:latin typeface="Times New Roman"/>
-                <a:cs typeface="Times New Roman"/>
-              </a:rPr>
-              <a:t> </a:t>
-            </a:r>
-            <a:r>
-              <a:rPr sz="1200" i="1" dirty="0">
-                <a:latin typeface="Times New Roman"/>
-                <a:cs typeface="Times New Roman"/>
-              </a:rPr>
-              <a:t>page</a:t>
-            </a:r>
-            <a:r>
-              <a:rPr sz="1200" i="1" spc="-30" dirty="0">
-                <a:latin typeface="Times New Roman"/>
-                <a:cs typeface="Times New Roman"/>
-              </a:rPr>
-              <a:t> </a:t>
-            </a:r>
-            <a:r>
-              <a:rPr sz="1200" i="1" dirty="0">
-                <a:latin typeface="Times New Roman"/>
-                <a:cs typeface="Times New Roman"/>
-              </a:rPr>
-              <a:t>was</a:t>
-            </a:r>
-            <a:r>
-              <a:rPr sz="1200" i="1" spc="-25" dirty="0">
-                <a:latin typeface="Times New Roman"/>
-                <a:cs typeface="Times New Roman"/>
-              </a:rPr>
-              <a:t> </a:t>
-            </a:r>
-            <a:r>
-              <a:rPr sz="1200" i="1" dirty="0">
-                <a:latin typeface="Times New Roman"/>
-                <a:cs typeface="Times New Roman"/>
-              </a:rPr>
-              <a:t>successfully</a:t>
-            </a:r>
-            <a:r>
-              <a:rPr sz="1200" i="1" spc="-25" dirty="0">
-                <a:latin typeface="Times New Roman"/>
-                <a:cs typeface="Times New Roman"/>
-              </a:rPr>
-              <a:t> </a:t>
-            </a:r>
-            <a:r>
-              <a:rPr sz="1200" i="1" dirty="0">
-                <a:latin typeface="Times New Roman"/>
-                <a:cs typeface="Times New Roman"/>
-              </a:rPr>
-              <a:t>enhanced</a:t>
-            </a:r>
-            <a:r>
-              <a:rPr sz="1200" i="1" spc="-20" dirty="0">
-                <a:latin typeface="Times New Roman"/>
-                <a:cs typeface="Times New Roman"/>
-              </a:rPr>
-              <a:t> </a:t>
-            </a:r>
-            <a:r>
-              <a:rPr sz="1200" i="1" dirty="0">
-                <a:latin typeface="Times New Roman"/>
-                <a:cs typeface="Times New Roman"/>
-              </a:rPr>
-              <a:t>using</a:t>
-            </a:r>
-            <a:r>
-              <a:rPr sz="1200" i="1" spc="-25" dirty="0">
-                <a:latin typeface="Times New Roman"/>
-                <a:cs typeface="Times New Roman"/>
-              </a:rPr>
-              <a:t> </a:t>
-            </a:r>
-            <a:r>
-              <a:rPr sz="1200" i="1" dirty="0">
-                <a:latin typeface="Times New Roman"/>
-                <a:cs typeface="Times New Roman"/>
-              </a:rPr>
-              <a:t>CSS</a:t>
-            </a:r>
-            <a:r>
-              <a:rPr sz="1200" i="1" spc="-20" dirty="0">
-                <a:latin typeface="Times New Roman"/>
-                <a:cs typeface="Times New Roman"/>
-              </a:rPr>
-              <a:t> </a:t>
-            </a:r>
-            <a:r>
-              <a:rPr sz="1200" i="1" dirty="0">
-                <a:latin typeface="Times New Roman"/>
-                <a:cs typeface="Times New Roman"/>
-              </a:rPr>
-              <a:t>to</a:t>
-            </a:r>
-            <a:r>
-              <a:rPr sz="1200" i="1" spc="-20" dirty="0">
-                <a:latin typeface="Times New Roman"/>
-                <a:cs typeface="Times New Roman"/>
-              </a:rPr>
-              <a:t> </a:t>
-            </a:r>
-            <a:r>
-              <a:rPr sz="1200" i="1" dirty="0">
-                <a:latin typeface="Times New Roman"/>
-                <a:cs typeface="Times New Roman"/>
-              </a:rPr>
-              <a:t>improve</a:t>
-            </a:r>
-            <a:r>
-              <a:rPr sz="1200" i="1" spc="-25" dirty="0">
-                <a:latin typeface="Times New Roman"/>
-                <a:cs typeface="Times New Roman"/>
-              </a:rPr>
-              <a:t> </a:t>
-            </a:r>
-            <a:r>
-              <a:rPr sz="1200" i="1" dirty="0">
-                <a:latin typeface="Times New Roman"/>
-                <a:cs typeface="Times New Roman"/>
-              </a:rPr>
-              <a:t>appearance</a:t>
-            </a:r>
-            <a:r>
-              <a:rPr sz="1200" i="1" spc="-25" dirty="0">
-                <a:latin typeface="Times New Roman"/>
-                <a:cs typeface="Times New Roman"/>
-              </a:rPr>
-              <a:t> and </a:t>
-            </a:r>
-            <a:r>
-              <a:rPr sz="1200" i="1" dirty="0">
-                <a:latin typeface="Times New Roman"/>
-                <a:cs typeface="Times New Roman"/>
-              </a:rPr>
-              <a:t>user</a:t>
-            </a:r>
-            <a:r>
-              <a:rPr sz="1200" i="1" spc="-30" dirty="0">
-                <a:latin typeface="Times New Roman"/>
-                <a:cs typeface="Times New Roman"/>
-              </a:rPr>
-              <a:t> </a:t>
-            </a:r>
-            <a:r>
-              <a:rPr sz="1200" i="1" spc="-10" dirty="0">
-                <a:latin typeface="Times New Roman"/>
-                <a:cs typeface="Times New Roman"/>
-              </a:rPr>
-              <a:t>experience.)</a:t>
-            </a:r>
-            <a:endParaRPr sz="1200">
+              <a:rPr lang="en-US" sz="1300" dirty="0">
+                <a:latin typeface="Times New Roman"/>
+                <a:cs typeface="Times New Roman"/>
+              </a:rPr>
+              <a:t>The project successfully meets all requirements for Assignment-2. By applying CSS, I have transformed a plain HTML structure into a clean, professional-looking event registration portal. The final result is visually appealing, easy to navigate, and demonstrates a solid understanding of presentation-layer design.</a:t>
+            </a:r>
+            <a:endParaRPr sz="1300" dirty="0">
               <a:latin typeface="Times New Roman"/>
               <a:cs typeface="Times New Roman"/>
             </a:endParaRPr>
@@ -11920,7 +10227,7 @@
         </p:blipFill>
         <p:spPr>
           <a:xfrm>
-            <a:off x="539750" y="442594"/>
+            <a:off x="749997" y="441007"/>
             <a:ext cx="1495933" cy="370204"/>
           </a:xfrm>
           <a:prstGeom prst="rect">
@@ -11942,7 +10249,7 @@
         </p:blipFill>
         <p:spPr>
           <a:xfrm>
-            <a:off x="2463800" y="342899"/>
+            <a:off x="2567078" y="342899"/>
             <a:ext cx="1004798" cy="566420"/>
           </a:xfrm>
           <a:prstGeom prst="rect">
@@ -11950,6 +10257,413 @@
           </a:prstGeom>
         </p:spPr>
       </p:pic>
+      <p:sp>
+        <p:nvSpPr>
+          <p:cNvPr id="16" name="object 43">
+            <a:extLst>
+              <a:ext uri="{FF2B5EF4-FFF2-40B4-BE49-F238E27FC236}">
+                <a16:creationId xmlns:a16="http://schemas.microsoft.com/office/drawing/2014/main" id="{2D6B3F04-0ECB-0810-3C39-9B2DEAD0C874}"/>
+              </a:ext>
+            </a:extLst>
+          </p:cNvPr>
+          <p:cNvSpPr txBox="1"/>
+          <p:nvPr/>
+        </p:nvSpPr>
+        <p:spPr>
+          <a:xfrm>
+            <a:off x="747620" y="892191"/>
+            <a:ext cx="6421120" cy="456535"/>
+          </a:xfrm>
+          <a:prstGeom prst="rect">
+            <a:avLst/>
+          </a:prstGeom>
+        </p:spPr>
+        <p:txBody>
+          <a:bodyPr vert="horz" wrap="square" lIns="0" tIns="12700" rIns="0" bIns="0" rtlCol="0">
+            <a:spAutoFit/>
+          </a:bodyPr>
+          <a:lstStyle/>
+          <a:p>
+            <a:pPr marL="12700">
+              <a:lnSpc>
+                <a:spcPct val="100000"/>
+              </a:lnSpc>
+              <a:spcBef>
+                <a:spcPts val="100"/>
+              </a:spcBef>
+            </a:pPr>
+            <a:r>
+              <a:rPr lang="en-US" sz="1400" b="1" spc="-10" dirty="0">
+                <a:solidFill>
+                  <a:srgbClr val="3B78D7"/>
+                </a:solidFill>
+                <a:latin typeface="Cambria"/>
+                <a:cs typeface="Cambria"/>
+              </a:rPr>
+              <a:t>6.Output:</a:t>
+            </a:r>
+          </a:p>
+          <a:p>
+            <a:pPr marL="12700">
+              <a:lnSpc>
+                <a:spcPct val="100000"/>
+              </a:lnSpc>
+              <a:spcBef>
+                <a:spcPts val="100"/>
+              </a:spcBef>
+            </a:pPr>
+            <a:endParaRPr lang="en-US" sz="1400" dirty="0">
+              <a:latin typeface="Cambria"/>
+              <a:cs typeface="Cambria"/>
+            </a:endParaRPr>
+          </a:p>
+        </p:txBody>
+      </p:sp>
+      <p:grpSp>
+        <p:nvGrpSpPr>
+          <p:cNvPr id="44" name="object 44"/>
+          <p:cNvGrpSpPr/>
+          <p:nvPr/>
+        </p:nvGrpSpPr>
+        <p:grpSpPr>
+          <a:xfrm>
+            <a:off x="583247" y="6261456"/>
+            <a:ext cx="6402705" cy="20955"/>
+            <a:chOff x="801369" y="9223375"/>
+            <a:chExt cx="6402705" cy="20955"/>
+          </a:xfrm>
+        </p:grpSpPr>
+        <p:sp>
+          <p:nvSpPr>
+            <p:cNvPr id="45" name="object 45"/>
+            <p:cNvSpPr/>
+            <p:nvPr/>
+          </p:nvSpPr>
+          <p:spPr>
+            <a:xfrm>
+              <a:off x="801370" y="9223387"/>
+              <a:ext cx="6400800" cy="19685"/>
+            </a:xfrm>
+            <a:custGeom>
+              <a:avLst/>
+              <a:gdLst/>
+              <a:ahLst/>
+              <a:cxnLst/>
+              <a:rect l="l" t="t" r="r" b="b"/>
+              <a:pathLst>
+                <a:path w="6400800" h="19684">
+                  <a:moveTo>
+                    <a:pt x="6400800" y="0"/>
+                  </a:moveTo>
+                  <a:lnTo>
+                    <a:pt x="0" y="0"/>
+                  </a:lnTo>
+                  <a:lnTo>
+                    <a:pt x="0" y="19672"/>
+                  </a:lnTo>
+                  <a:lnTo>
+                    <a:pt x="6400800" y="19672"/>
+                  </a:lnTo>
+                  <a:lnTo>
+                    <a:pt x="6400800" y="0"/>
+                  </a:lnTo>
+                  <a:close/>
+                </a:path>
+              </a:pathLst>
+            </a:custGeom>
+            <a:solidFill>
+              <a:srgbClr val="9F9F9F"/>
+            </a:solidFill>
+          </p:spPr>
+          <p:txBody>
+            <a:bodyPr wrap="square" lIns="0" tIns="0" rIns="0" bIns="0" rtlCol="0"/>
+            <a:lstStyle/>
+            <a:p>
+              <a:endParaRPr/>
+            </a:p>
+          </p:txBody>
+        </p:sp>
+        <p:sp>
+          <p:nvSpPr>
+            <p:cNvPr id="46" name="object 46"/>
+            <p:cNvSpPr/>
+            <p:nvPr/>
+          </p:nvSpPr>
+          <p:spPr>
+            <a:xfrm>
+              <a:off x="7200899" y="9224518"/>
+              <a:ext cx="3175" cy="3175"/>
+            </a:xfrm>
+            <a:custGeom>
+              <a:avLst/>
+              <a:gdLst/>
+              <a:ahLst/>
+              <a:cxnLst/>
+              <a:rect l="l" t="t" r="r" b="b"/>
+              <a:pathLst>
+                <a:path w="3175" h="3175">
+                  <a:moveTo>
+                    <a:pt x="3047" y="0"/>
+                  </a:moveTo>
+                  <a:lnTo>
+                    <a:pt x="0" y="0"/>
+                  </a:lnTo>
+                  <a:lnTo>
+                    <a:pt x="0" y="3047"/>
+                  </a:lnTo>
+                  <a:lnTo>
+                    <a:pt x="3047" y="3047"/>
+                  </a:lnTo>
+                  <a:lnTo>
+                    <a:pt x="3047" y="0"/>
+                  </a:lnTo>
+                  <a:close/>
+                </a:path>
+              </a:pathLst>
+            </a:custGeom>
+            <a:solidFill>
+              <a:srgbClr val="E2E2E2"/>
+            </a:solidFill>
+          </p:spPr>
+          <p:txBody>
+            <a:bodyPr wrap="square" lIns="0" tIns="0" rIns="0" bIns="0" rtlCol="0"/>
+            <a:lstStyle/>
+            <a:p>
+              <a:endParaRPr/>
+            </a:p>
+          </p:txBody>
+        </p:sp>
+        <p:sp>
+          <p:nvSpPr>
+            <p:cNvPr id="47" name="object 47"/>
+            <p:cNvSpPr/>
+            <p:nvPr/>
+          </p:nvSpPr>
+          <p:spPr>
+            <a:xfrm>
+              <a:off x="801928" y="9224530"/>
+              <a:ext cx="6402070" cy="17145"/>
+            </a:xfrm>
+            <a:custGeom>
+              <a:avLst/>
+              <a:gdLst/>
+              <a:ahLst/>
+              <a:cxnLst/>
+              <a:rect l="l" t="t" r="r" b="b"/>
+              <a:pathLst>
+                <a:path w="6402070" h="17145">
+                  <a:moveTo>
+                    <a:pt x="3048" y="3035"/>
+                  </a:moveTo>
+                  <a:lnTo>
+                    <a:pt x="0" y="3035"/>
+                  </a:lnTo>
+                  <a:lnTo>
+                    <a:pt x="0" y="16751"/>
+                  </a:lnTo>
+                  <a:lnTo>
+                    <a:pt x="3048" y="16751"/>
+                  </a:lnTo>
+                  <a:lnTo>
+                    <a:pt x="3048" y="3035"/>
+                  </a:lnTo>
+                  <a:close/>
+                </a:path>
+                <a:path w="6402070" h="17145">
+                  <a:moveTo>
+                    <a:pt x="6402006" y="0"/>
+                  </a:moveTo>
+                  <a:lnTo>
+                    <a:pt x="6398971" y="0"/>
+                  </a:lnTo>
+                  <a:lnTo>
+                    <a:pt x="6398971" y="3035"/>
+                  </a:lnTo>
+                  <a:lnTo>
+                    <a:pt x="6402006" y="3035"/>
+                  </a:lnTo>
+                  <a:lnTo>
+                    <a:pt x="6402006" y="0"/>
+                  </a:lnTo>
+                  <a:close/>
+                </a:path>
+              </a:pathLst>
+            </a:custGeom>
+            <a:solidFill>
+              <a:srgbClr val="9F9F9F"/>
+            </a:solidFill>
+          </p:spPr>
+          <p:txBody>
+            <a:bodyPr wrap="square" lIns="0" tIns="0" rIns="0" bIns="0" rtlCol="0"/>
+            <a:lstStyle/>
+            <a:p>
+              <a:endParaRPr/>
+            </a:p>
+          </p:txBody>
+        </p:sp>
+        <p:sp>
+          <p:nvSpPr>
+            <p:cNvPr id="48" name="object 48"/>
+            <p:cNvSpPr/>
+            <p:nvPr/>
+          </p:nvSpPr>
+          <p:spPr>
+            <a:xfrm>
+              <a:off x="7200899" y="9227566"/>
+              <a:ext cx="3175" cy="13970"/>
+            </a:xfrm>
+            <a:custGeom>
+              <a:avLst/>
+              <a:gdLst/>
+              <a:ahLst/>
+              <a:cxnLst/>
+              <a:rect l="l" t="t" r="r" b="b"/>
+              <a:pathLst>
+                <a:path w="3175" h="13970">
+                  <a:moveTo>
+                    <a:pt x="3047" y="0"/>
+                  </a:moveTo>
+                  <a:lnTo>
+                    <a:pt x="0" y="0"/>
+                  </a:lnTo>
+                  <a:lnTo>
+                    <a:pt x="0" y="13716"/>
+                  </a:lnTo>
+                  <a:lnTo>
+                    <a:pt x="3047" y="13716"/>
+                  </a:lnTo>
+                  <a:lnTo>
+                    <a:pt x="3047" y="0"/>
+                  </a:lnTo>
+                  <a:close/>
+                </a:path>
+              </a:pathLst>
+            </a:custGeom>
+            <a:solidFill>
+              <a:srgbClr val="E2E2E2"/>
+            </a:solidFill>
+          </p:spPr>
+          <p:txBody>
+            <a:bodyPr wrap="square" lIns="0" tIns="0" rIns="0" bIns="0" rtlCol="0"/>
+            <a:lstStyle/>
+            <a:p>
+              <a:endParaRPr/>
+            </a:p>
+          </p:txBody>
+        </p:sp>
+        <p:sp>
+          <p:nvSpPr>
+            <p:cNvPr id="49" name="object 49"/>
+            <p:cNvSpPr/>
+            <p:nvPr/>
+          </p:nvSpPr>
+          <p:spPr>
+            <a:xfrm>
+              <a:off x="801928" y="9241282"/>
+              <a:ext cx="3175" cy="3175"/>
+            </a:xfrm>
+            <a:custGeom>
+              <a:avLst/>
+              <a:gdLst/>
+              <a:ahLst/>
+              <a:cxnLst/>
+              <a:rect l="l" t="t" r="r" b="b"/>
+              <a:pathLst>
+                <a:path w="3175" h="3175">
+                  <a:moveTo>
+                    <a:pt x="3048" y="0"/>
+                  </a:moveTo>
+                  <a:lnTo>
+                    <a:pt x="0" y="0"/>
+                  </a:lnTo>
+                  <a:lnTo>
+                    <a:pt x="0" y="3047"/>
+                  </a:lnTo>
+                  <a:lnTo>
+                    <a:pt x="3048" y="3047"/>
+                  </a:lnTo>
+                  <a:lnTo>
+                    <a:pt x="3048" y="0"/>
+                  </a:lnTo>
+                  <a:close/>
+                </a:path>
+              </a:pathLst>
+            </a:custGeom>
+            <a:solidFill>
+              <a:srgbClr val="9F9F9F"/>
+            </a:solidFill>
+          </p:spPr>
+          <p:txBody>
+            <a:bodyPr wrap="square" lIns="0" tIns="0" rIns="0" bIns="0" rtlCol="0"/>
+            <a:lstStyle/>
+            <a:p>
+              <a:endParaRPr/>
+            </a:p>
+          </p:txBody>
+        </p:sp>
+        <p:sp>
+          <p:nvSpPr>
+            <p:cNvPr id="50" name="object 50"/>
+            <p:cNvSpPr/>
+            <p:nvPr/>
+          </p:nvSpPr>
+          <p:spPr>
+            <a:xfrm>
+              <a:off x="801928" y="9241294"/>
+              <a:ext cx="6402070" cy="3175"/>
+            </a:xfrm>
+            <a:custGeom>
+              <a:avLst/>
+              <a:gdLst/>
+              <a:ahLst/>
+              <a:cxnLst/>
+              <a:rect l="l" t="t" r="r" b="b"/>
+              <a:pathLst>
+                <a:path w="6402070" h="3175">
+                  <a:moveTo>
+                    <a:pt x="6402006" y="0"/>
+                  </a:moveTo>
+                  <a:lnTo>
+                    <a:pt x="6399022" y="0"/>
+                  </a:lnTo>
+                  <a:lnTo>
+                    <a:pt x="3048" y="0"/>
+                  </a:lnTo>
+                  <a:lnTo>
+                    <a:pt x="0" y="0"/>
+                  </a:lnTo>
+                  <a:lnTo>
+                    <a:pt x="0" y="3035"/>
+                  </a:lnTo>
+                  <a:lnTo>
+                    <a:pt x="3048" y="3035"/>
+                  </a:lnTo>
+                  <a:lnTo>
+                    <a:pt x="6398971" y="3035"/>
+                  </a:lnTo>
+                  <a:lnTo>
+                    <a:pt x="6402006" y="3035"/>
+                  </a:lnTo>
+                  <a:lnTo>
+                    <a:pt x="6402006" y="0"/>
+                  </a:lnTo>
+                  <a:close/>
+                </a:path>
+              </a:pathLst>
+            </a:custGeom>
+            <a:solidFill>
+              <a:srgbClr val="E2E2E2"/>
+            </a:solidFill>
+          </p:spPr>
+          <p:txBody>
+            <a:bodyPr wrap="square" lIns="0" tIns="0" rIns="0" bIns="0" rtlCol="0"/>
+            <a:lstStyle/>
+            <a:p>
+              <a:endParaRPr/>
+            </a:p>
+          </p:txBody>
+        </p:sp>
+      </p:grpSp>
     </p:spTree>
   </p:cSld>
   <p:clrMapOvr>

</xml_diff>